<commit_message>
Add labeled dataset-features slide to the deck
Co-Authored-By: Claude Opus 4.8 <noreply@anthropic.com>
</commit_message>
<xml_diff>
--- a/docs/REE_Results_Slides_Final.pptx
+++ b/docs/REE_Results_Slides_Final.pptx
@@ -26,6 +26,7 @@
     <p:sldId id="274" r:id="rId25"/>
     <p:sldId id="275" r:id="rId26"/>
     <p:sldId id="276" r:id="rId27"/>
+    <p:sldId id="277" r:id="rId28"/>
   </p:sldIdLst>
   <p:sldSz cx="12191695" cy="6858000" type="screen4x3"/>
   <p:notesSz cx="6858000" cy="9144000"/>
@@ -3270,14 +3271,14 @@
                 </a:solidFill>
                 <a:latin typeface="Arial"/>
               </a:rPr>
-              <a:t>Confidence by metal</a:t>
+              <a:t>Accuracy by metal</a:t>
             </a:r>
           </a:p>
         </p:txBody>
       </p:sp>
       <p:pic>
         <p:nvPicPr>
-          <p:cNvPr id="3" name="Picture 2" descr="confidence_per_metal.png"/>
+          <p:cNvPr id="3" name="Picture 2" descr="by_metal_accuracy.png"/>
           <p:cNvPicPr>
             <a:picLocks noChangeAspect="1"/>
           </p:cNvPicPr>
@@ -3291,8 +3292,8 @@
         </p:blipFill>
         <p:spPr>
           <a:xfrm>
-            <a:off x="2308061" y="1508760"/>
-            <a:ext cx="7575571" cy="4297680"/>
+            <a:off x="1270309" y="1508760"/>
+            <a:ext cx="9651076" cy="4114800"/>
           </a:xfrm>
           <a:prstGeom prst="rect">
             <a:avLst/>
@@ -3307,7 +3308,7 @@
         </p:nvSpPr>
         <p:spPr>
           <a:xfrm>
-            <a:off x="640080" y="5952744"/>
+            <a:off x="640080" y="5769864"/>
             <a:ext cx="10881360" cy="1005840"/>
           </a:xfrm>
           <a:prstGeom prst="rect">
@@ -3333,7 +3334,7 @@
                 </a:solidFill>
                 <a:latin typeface="Arial"/>
               </a:rPr>
-              <a:t>Each bar is the model's median estimated error for a metal, which is its confidence signal, so a shorter bar means it is more sure. The model is most confident on Americium and Curium and least confident on Neptunium(V), Uranium(VI), and Erbium.</a:t>
+              <a:t>Accuracy is not uniform. It is highest on Americium and Curium and lowest on Neptunium(V), Erbium, and Uranium(VI), so a single overall number hides large differences between metals.</a:t>
             </a:r>
           </a:p>
         </p:txBody>
@@ -3398,14 +3399,14 @@
                 </a:solidFill>
                 <a:latin typeface="Arial"/>
               </a:rPr>
-              <a:t>Confidence versus error, by metal</a:t>
+              <a:t>Confidence by metal</a:t>
             </a:r>
           </a:p>
         </p:txBody>
       </p:sp>
       <p:pic>
         <p:nvPicPr>
-          <p:cNvPr id="3" name="Picture 2" descr="by_metal_confidence_vs_error.png"/>
+          <p:cNvPr id="3" name="Picture 2" descr="confidence_per_metal.png"/>
           <p:cNvPicPr>
             <a:picLocks noChangeAspect="1"/>
           </p:cNvPicPr>
@@ -3419,8 +3420,8 @@
         </p:blipFill>
         <p:spPr>
           <a:xfrm>
-            <a:off x="3267777" y="1508760"/>
-            <a:ext cx="5656139" cy="3931920"/>
+            <a:off x="2308061" y="1508760"/>
+            <a:ext cx="7575571" cy="4297680"/>
           </a:xfrm>
           <a:prstGeom prst="rect">
             <a:avLst/>
@@ -3435,7 +3436,7 @@
         </p:nvSpPr>
         <p:spPr>
           <a:xfrm>
-            <a:off x="640080" y="5586983"/>
+            <a:off x="640080" y="5952744"/>
             <a:ext cx="10881360" cy="1005840"/>
           </a:xfrm>
           <a:prstGeom prst="rect">
@@ -3461,7 +3462,7 @@
                 </a:solidFill>
                 <a:latin typeface="Arial"/>
               </a:rPr>
-              <a:t>The horizontal axis is the model's estimated error and the vertical axis is the actual error. They line up, so Americium and Curium sit low on both while Neptunium(V), Uranium(VI), and Erbium sit high on both, which is what lets the model flag the metals it cannot predict well.</a:t>
+              <a:t>Each bar is the model's median estimated error for a metal, which is its confidence signal, so a shorter bar means it is more sure. The model is most confident on Americium and Curium and least confident on Neptunium(V), Uranium(VI), and Erbium.</a:t>
             </a:r>
           </a:p>
         </p:txBody>
@@ -3526,14 +3527,14 @@
                 </a:solidFill>
                 <a:latin typeface="Arial"/>
               </a:rPr>
-              <a:t>Separation between metal pairs</a:t>
+              <a:t>Confidence versus error, by metal</a:t>
             </a:r>
           </a:p>
         </p:txBody>
       </p:sp>
       <p:pic>
         <p:nvPicPr>
-          <p:cNvPr id="3" name="Picture 2" descr="by_metal_pair_separation.png"/>
+          <p:cNvPr id="3" name="Picture 2" descr="by_metal_confidence_vs_error.png"/>
           <p:cNvPicPr>
             <a:picLocks noChangeAspect="1"/>
           </p:cNvPicPr>
@@ -3547,8 +3548,8 @@
         </p:blipFill>
         <p:spPr>
           <a:xfrm>
-            <a:off x="900040" y="1508760"/>
-            <a:ext cx="10391613" cy="4114800"/>
+            <a:off x="3267777" y="1508760"/>
+            <a:ext cx="5656139" cy="3931920"/>
           </a:xfrm>
           <a:prstGeom prst="rect">
             <a:avLst/>
@@ -3563,7 +3564,7 @@
         </p:nvSpPr>
         <p:spPr>
           <a:xfrm>
-            <a:off x="640080" y="5769864"/>
+            <a:off x="640080" y="5586983"/>
             <a:ext cx="10881360" cy="1005840"/>
           </a:xfrm>
           <a:prstGeom prst="rect">
@@ -3589,7 +3590,7 @@
                 </a:solidFill>
                 <a:latin typeface="Arial"/>
               </a:rPr>
-              <a:t>A separation is the logD difference between two metals at the same conditions. Pairs far apart in logD such as Dysprosium and Ytterbium are predicted well, while tight adjacent pairs such as Erbium and Terbium are hardest, which is the case that matters most for industry.</a:t>
+              <a:t>The horizontal axis is the model's estimated error and the vertical axis is the actual error. They line up, so Americium and Curium sit low on both while Neptunium(V), Uranium(VI), and Erbium sit high on both, which is what lets the model flag the metals it cannot predict well.</a:t>
             </a:r>
           </a:p>
         </p:txBody>
@@ -3654,14 +3655,14 @@
                 </a:solidFill>
                 <a:latin typeface="Arial"/>
               </a:rPr>
-              <a:t>Confidence by metal pair</a:t>
+              <a:t>Separation between metal pairs</a:t>
             </a:r>
           </a:p>
         </p:txBody>
       </p:sp>
       <p:pic>
         <p:nvPicPr>
-          <p:cNvPr id="3" name="Picture 2" descr="by_pair_confidence_vs_error.png"/>
+          <p:cNvPr id="3" name="Picture 2" descr="by_metal_pair_separation.png"/>
           <p:cNvPicPr>
             <a:picLocks noChangeAspect="1"/>
           </p:cNvPicPr>
@@ -3675,8 +3676,8 @@
         </p:blipFill>
         <p:spPr>
           <a:xfrm>
-            <a:off x="2728891" y="1508760"/>
-            <a:ext cx="6733912" cy="3931920"/>
+            <a:off x="900040" y="1508760"/>
+            <a:ext cx="10391613" cy="4114800"/>
           </a:xfrm>
           <a:prstGeom prst="rect">
             <a:avLst/>
@@ -3691,7 +3692,7 @@
         </p:nvSpPr>
         <p:spPr>
           <a:xfrm>
-            <a:off x="640080" y="5586983"/>
+            <a:off x="640080" y="5769864"/>
             <a:ext cx="10881360" cy="1005840"/>
           </a:xfrm>
           <a:prstGeom prst="rect">
@@ -3717,7 +3718,7 @@
                 </a:solidFill>
                 <a:latin typeface="Arial"/>
               </a:rPr>
-              <a:t>Confidence behaves the same way on pairs: the model's estimated error for a pair lines up with the actual separation error, so it is most confident on the easy far-apart pairs and least confident on hard adjacent pairs such as Erbium and Terbium.</a:t>
+              <a:t>A separation is the logD difference between two metals at the same conditions. Pairs far apart in logD such as Dysprosium and Ytterbium are predicted well, while tight adjacent pairs such as Erbium and Terbium are hardest, which is the case that matters most for industry.</a:t>
             </a:r>
           </a:p>
         </p:txBody>
@@ -3782,14 +3783,14 @@
                 </a:solidFill>
                 <a:latin typeface="Arial"/>
               </a:rPr>
-              <a:t>Ensemble weights</a:t>
+              <a:t>Confidence by metal pair</a:t>
             </a:r>
           </a:p>
         </p:txBody>
       </p:sp>
       <p:pic>
         <p:nvPicPr>
-          <p:cNvPr id="3" name="Picture 2" descr="ensemble_weights.png"/>
+          <p:cNvPr id="3" name="Picture 2" descr="by_pair_confidence_vs_error.png"/>
           <p:cNvPicPr>
             <a:picLocks noChangeAspect="1"/>
           </p:cNvPicPr>
@@ -3803,8 +3804,8 @@
         </p:blipFill>
         <p:spPr>
           <a:xfrm>
-            <a:off x="792327" y="1508760"/>
-            <a:ext cx="10607040" cy="3795179"/>
+            <a:off x="2728891" y="1508760"/>
+            <a:ext cx="6733912" cy="3931920"/>
           </a:xfrm>
           <a:prstGeom prst="rect">
             <a:avLst/>
@@ -3819,7 +3820,7 @@
         </p:nvSpPr>
         <p:spPr>
           <a:xfrm>
-            <a:off x="640080" y="5450243"/>
+            <a:off x="640080" y="5586983"/>
             <a:ext cx="10881360" cy="1005840"/>
           </a:xfrm>
           <a:prstGeom prst="rect">
@@ -3845,7 +3846,7 @@
                 </a:solidFill>
                 <a:latin typeface="Arial"/>
               </a:rPr>
-              <a:t>Non-negative least squares keeps only the members that help, leaving ExtraTrees, LightGBM, and XGBoost on Track B and dropping the rest to a weight of zero.</a:t>
+              <a:t>Confidence behaves the same way on pairs: the model's estimated error for a pair lines up with the actual separation error, so it is most confident on the easy far-apart pairs and least confident on hard adjacent pairs such as Erbium and Terbium.</a:t>
             </a:r>
           </a:p>
         </p:txBody>
@@ -3910,14 +3911,14 @@
                 </a:solidFill>
                 <a:latin typeface="Arial"/>
               </a:rPr>
-              <a:t>Uncertainty intervals</a:t>
+              <a:t>Ensemble weights</a:t>
             </a:r>
           </a:p>
         </p:txBody>
       </p:sp>
       <p:pic>
         <p:nvPicPr>
-          <p:cNvPr id="3" name="Picture 2" descr="conformal_calibration.png"/>
+          <p:cNvPr id="3" name="Picture 2" descr="ensemble_weights.png"/>
           <p:cNvPicPr>
             <a:picLocks noChangeAspect="1"/>
           </p:cNvPicPr>
@@ -3973,7 +3974,7 @@
                 </a:solidFill>
                 <a:latin typeface="Arial"/>
               </a:rPr>
-              <a:t>Each prediction comes with a range. A 90 percent interval is built to contain the true logD about 90 percent of the time, an 80 percent interval about 80 percent. The left bars show the measured coverage (0.89 to 0.90 and 0.79 to 0.80), so the ranges are honest; the right bars show the typical width, narrower on Track B.</a:t>
+              <a:t>Non-negative least squares keeps only the members that help, leaving ExtraTrees, LightGBM, and XGBoost on Track B and dropping the rest to a weight of zero.</a:t>
             </a:r>
           </a:p>
         </p:txBody>
@@ -4038,21 +4039,45 @@
                 </a:solidFill>
                 <a:latin typeface="Arial"/>
               </a:rPr>
-              <a:t>Comparison with Dr. Zhang's model</a:t>
-            </a:r>
-          </a:p>
-        </p:txBody>
-      </p:sp>
-      <p:sp>
-        <p:nvSpPr>
-          <p:cNvPr id="3" name="TextBox 2"/>
+              <a:t>Uncertainty intervals</a:t>
+            </a:r>
+          </a:p>
+        </p:txBody>
+      </p:sp>
+      <p:pic>
+        <p:nvPicPr>
+          <p:cNvPr id="3" name="Picture 2" descr="conformal_calibration.png"/>
+          <p:cNvPicPr>
+            <a:picLocks noChangeAspect="1"/>
+          </p:cNvPicPr>
+          <p:nvPr/>
+        </p:nvPicPr>
+        <p:blipFill>
+          <a:blip r:embed="rId2"/>
+          <a:stretch>
+            <a:fillRect/>
+          </a:stretch>
+        </p:blipFill>
+        <p:spPr>
+          <a:xfrm>
+            <a:off x="792327" y="1508760"/>
+            <a:ext cx="10607040" cy="3795179"/>
+          </a:xfrm>
+          <a:prstGeom prst="rect">
+            <a:avLst/>
+          </a:prstGeom>
+        </p:spPr>
+      </p:pic>
+      <p:sp>
+        <p:nvSpPr>
+          <p:cNvPr id="4" name="TextBox 3"/>
           <p:cNvSpPr txBox="1"/>
           <p:nvPr/>
         </p:nvSpPr>
         <p:spPr>
           <a:xfrm>
-            <a:off x="640080" y="1645920"/>
-            <a:ext cx="10972800" cy="3657600"/>
+            <a:off x="640080" y="5450243"/>
+            <a:ext cx="10881360" cy="1005840"/>
           </a:xfrm>
           <a:prstGeom prst="rect">
             <a:avLst/>
@@ -4067,49 +4092,17 @@
           <a:p>
             <a:pPr algn="l">
               <a:spcAft>
-                <a:spcPts val="1400"/>
-              </a:spcAft>
-            </a:pPr>
-            <a:r>
-              <a:rPr sz="1800" b="0" i="0">
-                <a:solidFill>
-                  <a:srgbClr val="000000"/>
-                </a:solidFill>
-                <a:latin typeface="Arial"/>
-              </a:rPr>
-              <a:t>Both projects use the same 8,075-row f-element dataset (295 molecules, 28 metals), so the comparison is fair on the data.</a:t>
-            </a:r>
-          </a:p>
-          <a:p>
-            <a:pPr algn="l">
-              <a:spcAft>
-                <a:spcPts val="1400"/>
-              </a:spcAft>
-            </a:pPr>
-            <a:r>
-              <a:rPr sz="1800" b="0" i="0">
-                <a:solidFill>
-                  <a:srgbClr val="000000"/>
-                </a:solidFill>
-                <a:latin typeface="Arial"/>
-              </a:rPr>
-              <a:t>His supervised model is a 3-class XGBoost classifier that reports 72 percent accuracy on one 494-row held-out test, with no way to rank which predictions to trust.</a:t>
-            </a:r>
-          </a:p>
-          <a:p>
-            <a:pPr algn="l">
-              <a:spcAft>
                 <a:spcPts val="600"/>
               </a:spcAft>
             </a:pPr>
             <a:r>
-              <a:rPr sz="1800" b="0" i="0">
-                <a:solidFill>
-                  <a:srgbClr val="000000"/>
-                </a:solidFill>
-                <a:latin typeface="Arial"/>
-              </a:rPr>
-              <a:t>Ours predicts the continuous logD value with a confidence score and an uncertainty interval, and it can also be scored as a classifier on his exact task, which the next slides do.</a:t>
+              <a:rPr sz="1300" b="0" i="1">
+                <a:solidFill>
+                  <a:srgbClr val="404040"/>
+                </a:solidFill>
+                <a:latin typeface="Arial"/>
+              </a:rPr>
+              <a:t>Each prediction comes with a range. A 90 percent interval is built to contain the true logD about 90 percent of the time, an 80 percent interval about 80 percent. The left bars show the measured coverage (0.89 to 0.90 and 0.79 to 0.80), so the ranges are honest; the right bars show the typical width, narrower on Track B.</a:t>
             </a:r>
           </a:p>
         </p:txBody>
@@ -4174,45 +4167,21 @@
                 </a:solidFill>
                 <a:latin typeface="Arial"/>
               </a:rPr>
-              <a:t>Accuracy by confidence level, versus Zhang</a:t>
-            </a:r>
-          </a:p>
-        </p:txBody>
-      </p:sp>
-      <p:pic>
-        <p:nvPicPr>
-          <p:cNvPr id="3" name="Picture 2" descr="zhang_comparison_selective.png"/>
-          <p:cNvPicPr>
-            <a:picLocks noChangeAspect="1"/>
-          </p:cNvPicPr>
-          <p:nvPr/>
-        </p:nvPicPr>
-        <p:blipFill>
-          <a:blip r:embed="rId2"/>
-          <a:stretch>
-            <a:fillRect/>
-          </a:stretch>
-        </p:blipFill>
-        <p:spPr>
-          <a:xfrm>
-            <a:off x="2932411" y="1508760"/>
-            <a:ext cx="6326872" cy="3931920"/>
-          </a:xfrm>
-          <a:prstGeom prst="rect">
-            <a:avLst/>
-          </a:prstGeom>
-        </p:spPr>
-      </p:pic>
-      <p:sp>
-        <p:nvSpPr>
-          <p:cNvPr id="4" name="TextBox 3"/>
+              <a:t>Comparison with Dr. Zhang's model</a:t>
+            </a:r>
+          </a:p>
+        </p:txBody>
+      </p:sp>
+      <p:sp>
+        <p:nvSpPr>
+          <p:cNvPr id="3" name="TextBox 2"/>
           <p:cNvSpPr txBox="1"/>
           <p:nvPr/>
         </p:nvSpPr>
         <p:spPr>
           <a:xfrm>
-            <a:off x="640080" y="5586983"/>
-            <a:ext cx="10881360" cy="1005840"/>
+            <a:off x="640080" y="1645920"/>
+            <a:ext cx="10972800" cy="3657600"/>
           </a:xfrm>
           <a:prstGeom prst="rect">
             <a:avLst/>
@@ -4227,17 +4196,49 @@
           <a:p>
             <a:pPr algn="l">
               <a:spcAft>
+                <a:spcPts val="1400"/>
+              </a:spcAft>
+            </a:pPr>
+            <a:r>
+              <a:rPr sz="1800" b="0" i="0">
+                <a:solidFill>
+                  <a:srgbClr val="000000"/>
+                </a:solidFill>
+                <a:latin typeface="Arial"/>
+              </a:rPr>
+              <a:t>Both projects use the same 8,075-row f-element dataset (295 molecules, 28 metals), so the comparison is fair on the data.</a:t>
+            </a:r>
+          </a:p>
+          <a:p>
+            <a:pPr algn="l">
+              <a:spcAft>
+                <a:spcPts val="1400"/>
+              </a:spcAft>
+            </a:pPr>
+            <a:r>
+              <a:rPr sz="1800" b="0" i="0">
+                <a:solidFill>
+                  <a:srgbClr val="000000"/>
+                </a:solidFill>
+                <a:latin typeface="Arial"/>
+              </a:rPr>
+              <a:t>His supervised model is a 3-class XGBoost classifier that reports 72 percent accuracy on one 494-row held-out test, with no way to rank which predictions to trust.</a:t>
+            </a:r>
+          </a:p>
+          <a:p>
+            <a:pPr algn="l">
+              <a:spcAft>
                 <a:spcPts val="600"/>
               </a:spcAft>
             </a:pPr>
             <a:r>
-              <a:rPr sz="1300" b="0" i="1">
-                <a:solidFill>
-                  <a:srgbClr val="404040"/>
-                </a:solidFill>
-                <a:latin typeface="Arial"/>
-              </a:rPr>
-              <a:t>His 0.72 is a single value over all molecules. Ours can be ranked by confidence, so on the predictions it is most sure about it is far more accurate, which a single value cannot offer.</a:t>
+              <a:rPr sz="1800" b="0" i="0">
+                <a:solidFill>
+                  <a:srgbClr val="000000"/>
+                </a:solidFill>
+                <a:latin typeface="Arial"/>
+              </a:rPr>
+              <a:t>Ours predicts the continuous logD value with a confidence score and an uncertainty interval, and it can also be scored as a classifier on his exact task, which the next slides do.</a:t>
             </a:r>
           </a:p>
         </p:txBody>
@@ -4302,6 +4303,134 @@
                 </a:solidFill>
                 <a:latin typeface="Arial"/>
               </a:rPr>
+              <a:t>Accuracy by confidence level, versus Zhang</a:t>
+            </a:r>
+          </a:p>
+        </p:txBody>
+      </p:sp>
+      <p:pic>
+        <p:nvPicPr>
+          <p:cNvPr id="3" name="Picture 2" descr="zhang_comparison_selective.png"/>
+          <p:cNvPicPr>
+            <a:picLocks noChangeAspect="1"/>
+          </p:cNvPicPr>
+          <p:nvPr/>
+        </p:nvPicPr>
+        <p:blipFill>
+          <a:blip r:embed="rId2"/>
+          <a:stretch>
+            <a:fillRect/>
+          </a:stretch>
+        </p:blipFill>
+        <p:spPr>
+          <a:xfrm>
+            <a:off x="2932411" y="1508760"/>
+            <a:ext cx="6326872" cy="3931920"/>
+          </a:xfrm>
+          <a:prstGeom prst="rect">
+            <a:avLst/>
+          </a:prstGeom>
+        </p:spPr>
+      </p:pic>
+      <p:sp>
+        <p:nvSpPr>
+          <p:cNvPr id="4" name="TextBox 3"/>
+          <p:cNvSpPr txBox="1"/>
+          <p:nvPr/>
+        </p:nvSpPr>
+        <p:spPr>
+          <a:xfrm>
+            <a:off x="640080" y="5586983"/>
+            <a:ext cx="10881360" cy="1005840"/>
+          </a:xfrm>
+          <a:prstGeom prst="rect">
+            <a:avLst/>
+          </a:prstGeom>
+          <a:noFill/>
+        </p:spPr>
+        <p:txBody>
+          <a:bodyPr wrap="square" lIns="0" rIns="0" tIns="0" bIns="0">
+            <a:spAutoFit/>
+          </a:bodyPr>
+          <a:lstStyle/>
+          <a:p>
+            <a:pPr algn="l">
+              <a:spcAft>
+                <a:spcPts val="600"/>
+              </a:spcAft>
+            </a:pPr>
+            <a:r>
+              <a:rPr sz="1300" b="0" i="1">
+                <a:solidFill>
+                  <a:srgbClr val="404040"/>
+                </a:solidFill>
+                <a:latin typeface="Arial"/>
+              </a:rPr>
+              <a:t>His 0.72 is a single value over all molecules. Ours can be ranked by confidence, so on the predictions it is most sure about it is far more accurate, which a single value cannot offer.</a:t>
+            </a:r>
+          </a:p>
+        </p:txBody>
+      </p:sp>
+    </p:spTree>
+  </p:cSld>
+  <p:clrMapOvr>
+    <a:masterClrMapping/>
+  </p:clrMapOvr>
+</p:sld>
+</file>
+
+<file path=ppt/slides/slide19.xml><?xml version="1.0" encoding="utf-8"?>
+<p:sld xmlns:a="http://schemas.openxmlformats.org/drawingml/2006/main" xmlns:p="http://schemas.openxmlformats.org/presentationml/2006/main" xmlns:r="http://schemas.openxmlformats.org/officeDocument/2006/relationships">
+  <p:cSld>
+    <p:bg>
+      <p:bgPr>
+        <a:solidFill>
+          <a:srgbClr val="FFFFFF"/>
+        </a:solidFill>
+        <a:effectLst/>
+      </p:bgPr>
+    </p:bg>
+    <p:spTree>
+      <p:nvGrpSpPr>
+        <p:cNvPr id="1" name=""/>
+        <p:cNvGrpSpPr/>
+        <p:nvPr/>
+      </p:nvGrpSpPr>
+      <p:grpSpPr/>
+      <p:sp>
+        <p:nvSpPr>
+          <p:cNvPr id="2" name="TextBox 1"/>
+          <p:cNvSpPr txBox="1"/>
+          <p:nvPr/>
+        </p:nvSpPr>
+        <p:spPr>
+          <a:xfrm>
+            <a:off x="640080" y="457200"/>
+            <a:ext cx="10972800" cy="914400"/>
+          </a:xfrm>
+          <a:prstGeom prst="rect">
+            <a:avLst/>
+          </a:prstGeom>
+          <a:noFill/>
+        </p:spPr>
+        <p:txBody>
+          <a:bodyPr wrap="square" lIns="0" rIns="0" tIns="0" bIns="0">
+            <a:spAutoFit/>
+          </a:bodyPr>
+          <a:lstStyle/>
+          <a:p>
+            <a:pPr algn="l">
+              <a:spcAft>
+                <a:spcPts val="600"/>
+              </a:spcAft>
+            </a:pPr>
+            <a:r>
+              <a:rPr sz="2900" b="1" i="0">
+                <a:solidFill>
+                  <a:srgbClr val="000000"/>
+                </a:solidFill>
+                <a:latin typeface="Arial"/>
+              </a:rPr>
               <a:t>Our model on Dr. Zhang's test set</a:t>
             </a:r>
           </a:p>
@@ -4378,7 +4507,331 @@
 </p:sld>
 </file>
 
-<file path=ppt/slides/slide19.xml><?xml version="1.0" encoding="utf-8"?>
+<file path=ppt/slides/slide2.xml><?xml version="1.0" encoding="utf-8"?>
+<p:sld xmlns:a="http://schemas.openxmlformats.org/drawingml/2006/main" xmlns:p="http://schemas.openxmlformats.org/presentationml/2006/main" xmlns:r="http://schemas.openxmlformats.org/officeDocument/2006/relationships">
+  <p:cSld>
+    <p:bg>
+      <p:bgPr>
+        <a:solidFill>
+          <a:srgbClr val="FFFFFF"/>
+        </a:solidFill>
+        <a:effectLst/>
+      </p:bgPr>
+    </p:bg>
+    <p:spTree>
+      <p:nvGrpSpPr>
+        <p:cNvPr id="1" name=""/>
+        <p:cNvGrpSpPr/>
+        <p:nvPr/>
+      </p:nvGrpSpPr>
+      <p:grpSpPr/>
+      <p:sp>
+        <p:nvSpPr>
+          <p:cNvPr id="2" name="TextBox 1"/>
+          <p:cNvSpPr txBox="1"/>
+          <p:nvPr/>
+        </p:nvSpPr>
+        <p:spPr>
+          <a:xfrm>
+            <a:off x="640080" y="457200"/>
+            <a:ext cx="10972800" cy="914400"/>
+          </a:xfrm>
+          <a:prstGeom prst="rect">
+            <a:avLst/>
+          </a:prstGeom>
+          <a:noFill/>
+        </p:spPr>
+        <p:txBody>
+          <a:bodyPr wrap="square" lIns="0" rIns="0" tIns="0" bIns="0">
+            <a:spAutoFit/>
+          </a:bodyPr>
+          <a:lstStyle/>
+          <a:p>
+            <a:pPr algn="l">
+              <a:spcAft>
+                <a:spcPts val="600"/>
+              </a:spcAft>
+            </a:pPr>
+            <a:r>
+              <a:rPr sz="2900" b="1" i="0">
+                <a:solidFill>
+                  <a:srgbClr val="000000"/>
+                </a:solidFill>
+                <a:latin typeface="Arial"/>
+              </a:rPr>
+              <a:t>Dataset</a:t>
+            </a:r>
+          </a:p>
+        </p:txBody>
+      </p:sp>
+      <p:sp>
+        <p:nvSpPr>
+          <p:cNvPr id="3" name="TextBox 2"/>
+          <p:cNvSpPr txBox="1"/>
+          <p:nvPr/>
+        </p:nvSpPr>
+        <p:spPr>
+          <a:xfrm>
+            <a:off x="640080" y="1371600"/>
+            <a:ext cx="10972800" cy="1554480"/>
+          </a:xfrm>
+          <a:prstGeom prst="rect">
+            <a:avLst/>
+          </a:prstGeom>
+          <a:noFill/>
+        </p:spPr>
+        <p:txBody>
+          <a:bodyPr wrap="square" lIns="0" rIns="0" tIns="0" bIns="0">
+            <a:spAutoFit/>
+          </a:bodyPr>
+          <a:lstStyle/>
+          <a:p>
+            <a:pPr algn="l">
+              <a:spcAft>
+                <a:spcPts val="600"/>
+              </a:spcAft>
+            </a:pPr>
+            <a:r>
+              <a:rPr sz="1600" b="0" i="0">
+                <a:solidFill>
+                  <a:srgbClr val="000000"/>
+                </a:solidFill>
+                <a:latin typeface="Arial"/>
+              </a:rPr>
+              <a:t>The goal is to predict how well an extractant separates two f-elements, with logD (the log of the distribution coefficient, D) as the target. The inputs are molecular descriptors, the SMILES string, molecular fingerprints, and environmental factors such as pH and temperature.</a:t>
+            </a:r>
+          </a:p>
+        </p:txBody>
+      </p:sp>
+      <p:sp>
+        <p:nvSpPr>
+          <p:cNvPr id="4" name="TextBox 3"/>
+          <p:cNvSpPr txBox="1"/>
+          <p:nvPr/>
+        </p:nvSpPr>
+        <p:spPr>
+          <a:xfrm>
+            <a:off x="640080" y="3108960"/>
+            <a:ext cx="2743200" cy="1463040"/>
+          </a:xfrm>
+          <a:prstGeom prst="rect">
+            <a:avLst/>
+          </a:prstGeom>
+          <a:noFill/>
+        </p:spPr>
+        <p:txBody>
+          <a:bodyPr wrap="square" lIns="0" rIns="0" tIns="0" bIns="0">
+            <a:spAutoFit/>
+          </a:bodyPr>
+          <a:lstStyle/>
+          <a:p>
+            <a:pPr algn="l">
+              <a:spcAft>
+                <a:spcPts val="600"/>
+              </a:spcAft>
+            </a:pPr>
+            <a:r>
+              <a:rPr sz="4400" b="1" i="0">
+                <a:solidFill>
+                  <a:srgbClr val="000000"/>
+                </a:solidFill>
+                <a:latin typeface="Arial"/>
+              </a:rPr>
+              <a:t>8,075</a:t>
+            </a:r>
+          </a:p>
+          <a:p>
+            <a:pPr algn="l">
+              <a:spcAft>
+                <a:spcPts val="600"/>
+              </a:spcAft>
+            </a:pPr>
+            <a:r>
+              <a:rPr sz="1400" b="0" i="0">
+                <a:solidFill>
+                  <a:srgbClr val="404040"/>
+                </a:solidFill>
+                <a:latin typeface="Arial"/>
+              </a:rPr>
+              <a:t>measurements</a:t>
+            </a:r>
+          </a:p>
+        </p:txBody>
+      </p:sp>
+      <p:sp>
+        <p:nvSpPr>
+          <p:cNvPr id="5" name="TextBox 4"/>
+          <p:cNvSpPr txBox="1"/>
+          <p:nvPr/>
+        </p:nvSpPr>
+        <p:spPr>
+          <a:xfrm>
+            <a:off x="3429000" y="3108960"/>
+            <a:ext cx="2743200" cy="1463040"/>
+          </a:xfrm>
+          <a:prstGeom prst="rect">
+            <a:avLst/>
+          </a:prstGeom>
+          <a:noFill/>
+        </p:spPr>
+        <p:txBody>
+          <a:bodyPr wrap="square" lIns="0" rIns="0" tIns="0" bIns="0">
+            <a:spAutoFit/>
+          </a:bodyPr>
+          <a:lstStyle/>
+          <a:p>
+            <a:pPr algn="l">
+              <a:spcAft>
+                <a:spcPts val="600"/>
+              </a:spcAft>
+            </a:pPr>
+            <a:r>
+              <a:rPr sz="4400" b="1" i="0">
+                <a:solidFill>
+                  <a:srgbClr val="000000"/>
+                </a:solidFill>
+                <a:latin typeface="Arial"/>
+              </a:rPr>
+              <a:t>295</a:t>
+            </a:r>
+          </a:p>
+          <a:p>
+            <a:pPr algn="l">
+              <a:spcAft>
+                <a:spcPts val="600"/>
+              </a:spcAft>
+            </a:pPr>
+            <a:r>
+              <a:rPr sz="1400" b="0" i="0">
+                <a:solidFill>
+                  <a:srgbClr val="404040"/>
+                </a:solidFill>
+                <a:latin typeface="Arial"/>
+              </a:rPr>
+              <a:t>distinct extractants</a:t>
+            </a:r>
+          </a:p>
+        </p:txBody>
+      </p:sp>
+      <p:sp>
+        <p:nvSpPr>
+          <p:cNvPr id="6" name="TextBox 5"/>
+          <p:cNvSpPr txBox="1"/>
+          <p:nvPr/>
+        </p:nvSpPr>
+        <p:spPr>
+          <a:xfrm>
+            <a:off x="6217920" y="3108960"/>
+            <a:ext cx="2743200" cy="1463040"/>
+          </a:xfrm>
+          <a:prstGeom prst="rect">
+            <a:avLst/>
+          </a:prstGeom>
+          <a:noFill/>
+        </p:spPr>
+        <p:txBody>
+          <a:bodyPr wrap="square" lIns="0" rIns="0" tIns="0" bIns="0">
+            <a:spAutoFit/>
+          </a:bodyPr>
+          <a:lstStyle/>
+          <a:p>
+            <a:pPr algn="l">
+              <a:spcAft>
+                <a:spcPts val="600"/>
+              </a:spcAft>
+            </a:pPr>
+            <a:r>
+              <a:rPr sz="4400" b="1" i="0">
+                <a:solidFill>
+                  <a:srgbClr val="000000"/>
+                </a:solidFill>
+                <a:latin typeface="Arial"/>
+              </a:rPr>
+              <a:t>28</a:t>
+            </a:r>
+          </a:p>
+          <a:p>
+            <a:pPr algn="l">
+              <a:spcAft>
+                <a:spcPts val="600"/>
+              </a:spcAft>
+            </a:pPr>
+            <a:r>
+              <a:rPr sz="1400" b="0" i="0">
+                <a:solidFill>
+                  <a:srgbClr val="404040"/>
+                </a:solidFill>
+                <a:latin typeface="Arial"/>
+              </a:rPr>
+              <a:t>f-element metals</a:t>
+            </a:r>
+          </a:p>
+        </p:txBody>
+      </p:sp>
+      <p:sp>
+        <p:nvSpPr>
+          <p:cNvPr id="7" name="TextBox 6"/>
+          <p:cNvSpPr txBox="1"/>
+          <p:nvPr/>
+        </p:nvSpPr>
+        <p:spPr>
+          <a:xfrm>
+            <a:off x="9006840" y="3108960"/>
+            <a:ext cx="2743200" cy="1463040"/>
+          </a:xfrm>
+          <a:prstGeom prst="rect">
+            <a:avLst/>
+          </a:prstGeom>
+          <a:noFill/>
+        </p:spPr>
+        <p:txBody>
+          <a:bodyPr wrap="square" lIns="0" rIns="0" tIns="0" bIns="0">
+            <a:spAutoFit/>
+          </a:bodyPr>
+          <a:lstStyle/>
+          <a:p>
+            <a:pPr algn="l">
+              <a:spcAft>
+                <a:spcPts val="600"/>
+              </a:spcAft>
+            </a:pPr>
+            <a:r>
+              <a:rPr sz="4400" b="1" i="0">
+                <a:solidFill>
+                  <a:srgbClr val="000000"/>
+                </a:solidFill>
+                <a:latin typeface="Arial"/>
+              </a:rPr>
+              <a:t>~17.5</a:t>
+            </a:r>
+          </a:p>
+          <a:p>
+            <a:pPr algn="l">
+              <a:spcAft>
+                <a:spcPts val="600"/>
+              </a:spcAft>
+            </a:pPr>
+            <a:r>
+              <a:rPr sz="1400" b="0" i="0">
+                <a:solidFill>
+                  <a:srgbClr val="404040"/>
+                </a:solidFill>
+                <a:latin typeface="Arial"/>
+              </a:rPr>
+              <a:t>log-unit range of logD</a:t>
+            </a:r>
+          </a:p>
+        </p:txBody>
+      </p:sp>
+    </p:spTree>
+  </p:cSld>
+  <p:clrMapOvr>
+    <a:masterClrMapping/>
+  </p:clrMapOvr>
+</p:sld>
+</file>
+
+<file path=ppt/slides/slide20.xml><?xml version="1.0" encoding="utf-8"?>
 <p:sld xmlns:a="http://schemas.openxmlformats.org/drawingml/2006/main" xmlns:p="http://schemas.openxmlformats.org/presentationml/2006/main" xmlns:r="http://schemas.openxmlformats.org/officeDocument/2006/relationships">
   <p:cSld>
     <p:bg>
@@ -4713,7 +5166,7 @@
 </p:sld>
 </file>
 
-<file path=ppt/slides/slide2.xml><?xml version="1.0" encoding="utf-8"?>
+<file path=ppt/slides/slide21.xml><?xml version="1.0" encoding="utf-8"?>
 <p:sld xmlns:a="http://schemas.openxmlformats.org/drawingml/2006/main" xmlns:p="http://schemas.openxmlformats.org/presentationml/2006/main" xmlns:r="http://schemas.openxmlformats.org/officeDocument/2006/relationships">
   <p:cSld>
     <p:bg>
@@ -4765,330 +5218,6 @@
                 </a:solidFill>
                 <a:latin typeface="Arial"/>
               </a:rPr>
-              <a:t>Dataset</a:t>
-            </a:r>
-          </a:p>
-        </p:txBody>
-      </p:sp>
-      <p:sp>
-        <p:nvSpPr>
-          <p:cNvPr id="3" name="TextBox 2"/>
-          <p:cNvSpPr txBox="1"/>
-          <p:nvPr/>
-        </p:nvSpPr>
-        <p:spPr>
-          <a:xfrm>
-            <a:off x="640080" y="1371600"/>
-            <a:ext cx="10972800" cy="1554480"/>
-          </a:xfrm>
-          <a:prstGeom prst="rect">
-            <a:avLst/>
-          </a:prstGeom>
-          <a:noFill/>
-        </p:spPr>
-        <p:txBody>
-          <a:bodyPr wrap="square" lIns="0" rIns="0" tIns="0" bIns="0">
-            <a:spAutoFit/>
-          </a:bodyPr>
-          <a:lstStyle/>
-          <a:p>
-            <a:pPr algn="l">
-              <a:spcAft>
-                <a:spcPts val="600"/>
-              </a:spcAft>
-            </a:pPr>
-            <a:r>
-              <a:rPr sz="1600" b="0" i="0">
-                <a:solidFill>
-                  <a:srgbClr val="000000"/>
-                </a:solidFill>
-                <a:latin typeface="Arial"/>
-              </a:rPr>
-              <a:t>The goal is to predict how well an extractant separates two f-elements, with logD (the log of the distribution coefficient, D) as the target. The inputs are molecular descriptors, the SMILES string, molecular fingerprints, and environmental factors such as pH and temperature.</a:t>
-            </a:r>
-          </a:p>
-        </p:txBody>
-      </p:sp>
-      <p:sp>
-        <p:nvSpPr>
-          <p:cNvPr id="4" name="TextBox 3"/>
-          <p:cNvSpPr txBox="1"/>
-          <p:nvPr/>
-        </p:nvSpPr>
-        <p:spPr>
-          <a:xfrm>
-            <a:off x="640080" y="3108960"/>
-            <a:ext cx="2743200" cy="1463040"/>
-          </a:xfrm>
-          <a:prstGeom prst="rect">
-            <a:avLst/>
-          </a:prstGeom>
-          <a:noFill/>
-        </p:spPr>
-        <p:txBody>
-          <a:bodyPr wrap="square" lIns="0" rIns="0" tIns="0" bIns="0">
-            <a:spAutoFit/>
-          </a:bodyPr>
-          <a:lstStyle/>
-          <a:p>
-            <a:pPr algn="l">
-              <a:spcAft>
-                <a:spcPts val="600"/>
-              </a:spcAft>
-            </a:pPr>
-            <a:r>
-              <a:rPr sz="4400" b="1" i="0">
-                <a:solidFill>
-                  <a:srgbClr val="000000"/>
-                </a:solidFill>
-                <a:latin typeface="Arial"/>
-              </a:rPr>
-              <a:t>8,075</a:t>
-            </a:r>
-          </a:p>
-          <a:p>
-            <a:pPr algn="l">
-              <a:spcAft>
-                <a:spcPts val="600"/>
-              </a:spcAft>
-            </a:pPr>
-            <a:r>
-              <a:rPr sz="1400" b="0" i="0">
-                <a:solidFill>
-                  <a:srgbClr val="404040"/>
-                </a:solidFill>
-                <a:latin typeface="Arial"/>
-              </a:rPr>
-              <a:t>measurements</a:t>
-            </a:r>
-          </a:p>
-        </p:txBody>
-      </p:sp>
-      <p:sp>
-        <p:nvSpPr>
-          <p:cNvPr id="5" name="TextBox 4"/>
-          <p:cNvSpPr txBox="1"/>
-          <p:nvPr/>
-        </p:nvSpPr>
-        <p:spPr>
-          <a:xfrm>
-            <a:off x="3429000" y="3108960"/>
-            <a:ext cx="2743200" cy="1463040"/>
-          </a:xfrm>
-          <a:prstGeom prst="rect">
-            <a:avLst/>
-          </a:prstGeom>
-          <a:noFill/>
-        </p:spPr>
-        <p:txBody>
-          <a:bodyPr wrap="square" lIns="0" rIns="0" tIns="0" bIns="0">
-            <a:spAutoFit/>
-          </a:bodyPr>
-          <a:lstStyle/>
-          <a:p>
-            <a:pPr algn="l">
-              <a:spcAft>
-                <a:spcPts val="600"/>
-              </a:spcAft>
-            </a:pPr>
-            <a:r>
-              <a:rPr sz="4400" b="1" i="0">
-                <a:solidFill>
-                  <a:srgbClr val="000000"/>
-                </a:solidFill>
-                <a:latin typeface="Arial"/>
-              </a:rPr>
-              <a:t>295</a:t>
-            </a:r>
-          </a:p>
-          <a:p>
-            <a:pPr algn="l">
-              <a:spcAft>
-                <a:spcPts val="600"/>
-              </a:spcAft>
-            </a:pPr>
-            <a:r>
-              <a:rPr sz="1400" b="0" i="0">
-                <a:solidFill>
-                  <a:srgbClr val="404040"/>
-                </a:solidFill>
-                <a:latin typeface="Arial"/>
-              </a:rPr>
-              <a:t>distinct extractants</a:t>
-            </a:r>
-          </a:p>
-        </p:txBody>
-      </p:sp>
-      <p:sp>
-        <p:nvSpPr>
-          <p:cNvPr id="6" name="TextBox 5"/>
-          <p:cNvSpPr txBox="1"/>
-          <p:nvPr/>
-        </p:nvSpPr>
-        <p:spPr>
-          <a:xfrm>
-            <a:off x="6217920" y="3108960"/>
-            <a:ext cx="2743200" cy="1463040"/>
-          </a:xfrm>
-          <a:prstGeom prst="rect">
-            <a:avLst/>
-          </a:prstGeom>
-          <a:noFill/>
-        </p:spPr>
-        <p:txBody>
-          <a:bodyPr wrap="square" lIns="0" rIns="0" tIns="0" bIns="0">
-            <a:spAutoFit/>
-          </a:bodyPr>
-          <a:lstStyle/>
-          <a:p>
-            <a:pPr algn="l">
-              <a:spcAft>
-                <a:spcPts val="600"/>
-              </a:spcAft>
-            </a:pPr>
-            <a:r>
-              <a:rPr sz="4400" b="1" i="0">
-                <a:solidFill>
-                  <a:srgbClr val="000000"/>
-                </a:solidFill>
-                <a:latin typeface="Arial"/>
-              </a:rPr>
-              <a:t>28</a:t>
-            </a:r>
-          </a:p>
-          <a:p>
-            <a:pPr algn="l">
-              <a:spcAft>
-                <a:spcPts val="600"/>
-              </a:spcAft>
-            </a:pPr>
-            <a:r>
-              <a:rPr sz="1400" b="0" i="0">
-                <a:solidFill>
-                  <a:srgbClr val="404040"/>
-                </a:solidFill>
-                <a:latin typeface="Arial"/>
-              </a:rPr>
-              <a:t>f-element metals</a:t>
-            </a:r>
-          </a:p>
-        </p:txBody>
-      </p:sp>
-      <p:sp>
-        <p:nvSpPr>
-          <p:cNvPr id="7" name="TextBox 6"/>
-          <p:cNvSpPr txBox="1"/>
-          <p:nvPr/>
-        </p:nvSpPr>
-        <p:spPr>
-          <a:xfrm>
-            <a:off x="9006840" y="3108960"/>
-            <a:ext cx="2743200" cy="1463040"/>
-          </a:xfrm>
-          <a:prstGeom prst="rect">
-            <a:avLst/>
-          </a:prstGeom>
-          <a:noFill/>
-        </p:spPr>
-        <p:txBody>
-          <a:bodyPr wrap="square" lIns="0" rIns="0" tIns="0" bIns="0">
-            <a:spAutoFit/>
-          </a:bodyPr>
-          <a:lstStyle/>
-          <a:p>
-            <a:pPr algn="l">
-              <a:spcAft>
-                <a:spcPts val="600"/>
-              </a:spcAft>
-            </a:pPr>
-            <a:r>
-              <a:rPr sz="4400" b="1" i="0">
-                <a:solidFill>
-                  <a:srgbClr val="000000"/>
-                </a:solidFill>
-                <a:latin typeface="Arial"/>
-              </a:rPr>
-              <a:t>~17.5</a:t>
-            </a:r>
-          </a:p>
-          <a:p>
-            <a:pPr algn="l">
-              <a:spcAft>
-                <a:spcPts val="600"/>
-              </a:spcAft>
-            </a:pPr>
-            <a:r>
-              <a:rPr sz="1400" b="0" i="0">
-                <a:solidFill>
-                  <a:srgbClr val="404040"/>
-                </a:solidFill>
-                <a:latin typeface="Arial"/>
-              </a:rPr>
-              <a:t>log-unit range of logD</a:t>
-            </a:r>
-          </a:p>
-        </p:txBody>
-      </p:sp>
-    </p:spTree>
-  </p:cSld>
-  <p:clrMapOvr>
-    <a:masterClrMapping/>
-  </p:clrMapOvr>
-</p:sld>
-</file>
-
-<file path=ppt/slides/slide20.xml><?xml version="1.0" encoding="utf-8"?>
-<p:sld xmlns:a="http://schemas.openxmlformats.org/drawingml/2006/main" xmlns:p="http://schemas.openxmlformats.org/presentationml/2006/main" xmlns:r="http://schemas.openxmlformats.org/officeDocument/2006/relationships">
-  <p:cSld>
-    <p:bg>
-      <p:bgPr>
-        <a:solidFill>
-          <a:srgbClr val="FFFFFF"/>
-        </a:solidFill>
-        <a:effectLst/>
-      </p:bgPr>
-    </p:bg>
-    <p:spTree>
-      <p:nvGrpSpPr>
-        <p:cNvPr id="1" name=""/>
-        <p:cNvGrpSpPr/>
-        <p:nvPr/>
-      </p:nvGrpSpPr>
-      <p:grpSpPr/>
-      <p:sp>
-        <p:nvSpPr>
-          <p:cNvPr id="2" name="TextBox 1"/>
-          <p:cNvSpPr txBox="1"/>
-          <p:nvPr/>
-        </p:nvSpPr>
-        <p:spPr>
-          <a:xfrm>
-            <a:off x="640080" y="457200"/>
-            <a:ext cx="10972800" cy="914400"/>
-          </a:xfrm>
-          <a:prstGeom prst="rect">
-            <a:avLst/>
-          </a:prstGeom>
-          <a:noFill/>
-        </p:spPr>
-        <p:txBody>
-          <a:bodyPr wrap="square" lIns="0" rIns="0" tIns="0" bIns="0">
-            <a:spAutoFit/>
-          </a:bodyPr>
-          <a:lstStyle/>
-          <a:p>
-            <a:pPr algn="l">
-              <a:spcAft>
-                <a:spcPts val="600"/>
-              </a:spcAft>
-            </a:pPr>
-            <a:r>
-              <a:rPr sz="2900" b="1" i="0">
-                <a:solidFill>
-                  <a:srgbClr val="000000"/>
-                </a:solidFill>
-                <a:latin typeface="Arial"/>
-              </a:rPr>
               <a:t>Training on Dr. Zhang's data</a:t>
             </a:r>
           </a:p>
@@ -5165,7 +5294,7 @@
 </p:sld>
 </file>
 
-<file path=ppt/slides/slide21.xml><?xml version="1.0" encoding="utf-8"?>
+<file path=ppt/slides/slide22.xml><?xml version="1.0" encoding="utf-8"?>
 <p:sld xmlns:a="http://schemas.openxmlformats.org/drawingml/2006/main" xmlns:p="http://schemas.openxmlformats.org/presentationml/2006/main" xmlns:r="http://schemas.openxmlformats.org/officeDocument/2006/relationships">
   <p:cSld>
     <p:bg>
@@ -5401,7 +5530,7 @@
                 </a:solidFill>
                 <a:latin typeface="Arial"/>
               </a:rPr>
-              <a:t>Two prediction tasks</a:t>
+              <a:t>Dataset features and why</a:t>
             </a:r>
           </a:p>
         </p:txBody>
@@ -5415,7 +5544,7 @@
         <p:spPr>
           <a:xfrm>
             <a:off x="640080" y="1371600"/>
-            <a:ext cx="10972800" cy="731520"/>
+            <a:ext cx="10972800" cy="5120640"/>
           </a:xfrm>
           <a:prstGeom prst="rect">
             <a:avLst/>
@@ -5430,191 +5559,101 @@
           <a:p>
             <a:pPr algn="l">
               <a:spcAft>
-                <a:spcPts val="600"/>
-              </a:spcAft>
-            </a:pPr>
-            <a:r>
-              <a:rPr sz="1600" b="0" i="0">
+                <a:spcPts val="1400"/>
+              </a:spcAft>
+            </a:pPr>
+            <a:r>
+              <a:rPr sz="1500" b="1">
                 <a:solidFill>
                   <a:srgbClr val="000000"/>
                 </a:solidFill>
                 <a:latin typeface="Arial"/>
               </a:rPr>
-              <a:t>The tasks are kept apart so a molecule cannot leak across training and testing, which would inflate the score.</a:t>
-            </a:r>
-          </a:p>
-        </p:txBody>
-      </p:sp>
-      <p:sp>
-        <p:nvSpPr>
-          <p:cNvPr id="4" name="TextBox 3"/>
-          <p:cNvSpPr txBox="1"/>
-          <p:nvPr/>
-        </p:nvSpPr>
-        <p:spPr>
-          <a:xfrm>
-            <a:off x="640080" y="2377440"/>
-            <a:ext cx="5303520" cy="3108960"/>
-          </a:xfrm>
-          <a:prstGeom prst="rect">
-            <a:avLst/>
-          </a:prstGeom>
-          <a:noFill/>
-        </p:spPr>
-        <p:txBody>
-          <a:bodyPr wrap="square" lIns="0" rIns="0" tIns="0" bIns="0">
-            <a:spAutoFit/>
-          </a:bodyPr>
-          <a:lstStyle/>
-          <a:p>
-            <a:pPr algn="l">
-              <a:spcAft>
-                <a:spcPts val="600"/>
-              </a:spcAft>
-            </a:pPr>
-            <a:r>
-              <a:rPr sz="1900" b="1" i="0">
+              <a:t>Extractant structure:  </a:t>
+            </a:r>
+            <a:r>
+              <a:rPr sz="1500" b="0">
                 <a:solidFill>
                   <a:srgbClr val="000000"/>
                 </a:solidFill>
                 <a:latin typeface="Arial"/>
               </a:rPr>
-              <a:t>Track A: screen a new molecule</a:t>
-            </a:r>
-          </a:p>
-          <a:p>
-            <a:pPr algn="l">
-              <a:spcAft>
-                <a:spcPts val="1200"/>
-              </a:spcAft>
-            </a:pPr>
-            <a:r>
-              <a:rPr sz="1300" b="0" i="1">
-                <a:solidFill>
-                  <a:srgbClr val="404040"/>
-                </a:solidFill>
-                <a:latin typeface="Arial"/>
-              </a:rPr>
-              <a:t>molecule-grouped cross-validation</a:t>
-            </a:r>
-          </a:p>
-          <a:p>
-            <a:pPr algn="l">
-              <a:spcAft>
-                <a:spcPts val="800"/>
-              </a:spcAft>
-            </a:pPr>
-            <a:r>
-              <a:rPr sz="1800" b="1" i="0">
+              <a:t>SMILES, a Morgan fingerprint, RDKit descriptors, and donor-atom counts (O, N, S, P) with logP. These set how, and how strongly, the extractant binds a metal.</a:t>
+            </a:r>
+          </a:p>
+          <a:p>
+            <a:pPr algn="l">
+              <a:spcAft>
+                <a:spcPts val="1400"/>
+              </a:spcAft>
+            </a:pPr>
+            <a:r>
+              <a:rPr sz="1500" b="1">
                 <a:solidFill>
                   <a:srgbClr val="000000"/>
                 </a:solidFill>
                 <a:latin typeface="Arial"/>
               </a:rPr>
-              <a:t>R-squared 0.466     RMSE 1.148</a:t>
-            </a:r>
-          </a:p>
-          <a:p>
-            <a:pPr algn="l">
-              <a:spcAft>
-                <a:spcPts val="600"/>
-              </a:spcAft>
-            </a:pPr>
-            <a:r>
-              <a:rPr sz="1500" b="0" i="0">
+              <a:t>Metal descriptors:  </a:t>
+            </a:r>
+            <a:r>
+              <a:rPr sz="1500" b="0">
                 <a:solidFill>
                   <a:srgbClr val="000000"/>
                 </a:solidFill>
                 <a:latin typeface="Arial"/>
               </a:rPr>
-              <a:t>Most confident 10 percent: R-squared 0.912, RMSE 0.493</a:t>
-            </a:r>
-          </a:p>
-        </p:txBody>
-      </p:sp>
-      <p:sp>
-        <p:nvSpPr>
-          <p:cNvPr id="5" name="TextBox 4"/>
-          <p:cNvSpPr txBox="1"/>
-          <p:nvPr/>
-        </p:nvSpPr>
-        <p:spPr>
-          <a:xfrm>
-            <a:off x="6400800" y="2377440"/>
-            <a:ext cx="5303520" cy="3108960"/>
-          </a:xfrm>
-          <a:prstGeom prst="rect">
-            <a:avLst/>
-          </a:prstGeom>
-          <a:noFill/>
-        </p:spPr>
-        <p:txBody>
-          <a:bodyPr wrap="square" lIns="0" rIns="0" tIns="0" bIns="0">
-            <a:spAutoFit/>
-          </a:bodyPr>
-          <a:lstStyle/>
-          <a:p>
-            <a:pPr algn="l">
-              <a:spcAft>
-                <a:spcPts val="600"/>
-              </a:spcAft>
-            </a:pPr>
-            <a:r>
-              <a:rPr sz="1900" b="1" i="0">
+              <a:t>ionic radius, charge and oxidation state, ionization energies, electronegativity, and atomic number. These carry the lanthanide-contraction trend that makes neighboring rare earths hard to separate, and let the model relate one metal to another.</a:t>
+            </a:r>
+          </a:p>
+          <a:p>
+            <a:pPr algn="l">
+              <a:spcAft>
+                <a:spcPts val="1400"/>
+              </a:spcAft>
+            </a:pPr>
+            <a:r>
+              <a:rPr sz="1500" b="1">
                 <a:solidFill>
                   <a:srgbClr val="000000"/>
                 </a:solidFill>
                 <a:latin typeface="Arial"/>
               </a:rPr>
-              <a:t>Track B: optimize conditions</a:t>
-            </a:r>
-          </a:p>
-          <a:p>
-            <a:pPr algn="l">
-              <a:spcAft>
-                <a:spcPts val="1200"/>
-              </a:spcAft>
-            </a:pPr>
-            <a:r>
-              <a:rPr sz="1300" b="0" i="1">
-                <a:solidFill>
-                  <a:srgbClr val="404040"/>
-                </a:solidFill>
-                <a:latin typeface="Arial"/>
-              </a:rPr>
-              <a:t>random-row cross-validation</a:t>
-            </a:r>
-          </a:p>
-          <a:p>
-            <a:pPr algn="l">
-              <a:spcAft>
-                <a:spcPts val="800"/>
-              </a:spcAft>
-            </a:pPr>
-            <a:r>
-              <a:rPr sz="1800" b="1" i="0">
+              <a:t>Acid and conditions:  </a:t>
+            </a:r>
+            <a:r>
+              <a:rPr sz="1500" b="0">
                 <a:solidFill>
                   <a:srgbClr val="000000"/>
                 </a:solidFill>
                 <a:latin typeface="Arial"/>
               </a:rPr>
-              <a:t>R-squared 0.725     RMSE 0.823</a:t>
-            </a:r>
-          </a:p>
-          <a:p>
-            <a:pPr algn="l">
-              <a:spcAft>
-                <a:spcPts val="600"/>
-              </a:spcAft>
-            </a:pPr>
-            <a:r>
-              <a:rPr sz="1500" b="0" i="0">
+              <a:t>acid type and concentration, temperature, and extractant concentration. logD is an equilibrium, so it shifts with these as much as with the molecule.</a:t>
+            </a:r>
+          </a:p>
+          <a:p>
+            <a:pPr algn="l">
+              <a:spcAft>
+                <a:spcPts val="1400"/>
+              </a:spcAft>
+            </a:pPr>
+            <a:r>
+              <a:rPr sz="1500" b="1">
                 <a:solidFill>
                   <a:srgbClr val="000000"/>
                 </a:solidFill>
                 <a:latin typeface="Arial"/>
               </a:rPr>
-              <a:t>Most confident 10 percent: R-squared 0.940, RMSE 0.341</a:t>
+              <a:t>Diluent (solvent):  </a:t>
+            </a:r>
+            <a:r>
+              <a:rPr sz="1500" b="0">
+                <a:solidFill>
+                  <a:srgbClr val="000000"/>
+                </a:solidFill>
+                <a:latin typeface="Arial"/>
+              </a:rPr>
+              <a:t>molar mass, logP, boiling and melting points, density, solubility, and dipole moment. The diluent sets the organic-phase environment around the extractant.</a:t>
             </a:r>
           </a:p>
         </p:txBody>
@@ -5679,7 +5718,7 @@
                 </a:solidFill>
                 <a:latin typeface="Arial"/>
               </a:rPr>
-              <a:t>Definitions</a:t>
+              <a:t>Two prediction tasks</a:t>
             </a:r>
           </a:p>
         </p:txBody>
@@ -5692,8 +5731,8 @@
         </p:nvSpPr>
         <p:spPr>
           <a:xfrm>
-            <a:off x="640080" y="1463040"/>
-            <a:ext cx="10972800" cy="4937760"/>
+            <a:off x="640080" y="1371600"/>
+            <a:ext cx="10972800" cy="731520"/>
           </a:xfrm>
           <a:prstGeom prst="rect">
             <a:avLst/>
@@ -5708,126 +5747,191 @@
           <a:p>
             <a:pPr algn="l">
               <a:spcAft>
-                <a:spcPts val="1300"/>
-              </a:spcAft>
-            </a:pPr>
-            <a:r>
-              <a:rPr sz="1600" b="1">
+                <a:spcPts val="600"/>
+              </a:spcAft>
+            </a:pPr>
+            <a:r>
+              <a:rPr sz="1600" b="0" i="0">
                 <a:solidFill>
                   <a:srgbClr val="000000"/>
                 </a:solidFill>
                 <a:latin typeface="Arial"/>
               </a:rPr>
-              <a:t>Confidence score:  </a:t>
-            </a:r>
-            <a:r>
-              <a:rPr sz="1600" b="0">
+              <a:t>The tasks are kept apart so a molecule cannot leak across training and testing, which would inflate the score.</a:t>
+            </a:r>
+          </a:p>
+        </p:txBody>
+      </p:sp>
+      <p:sp>
+        <p:nvSpPr>
+          <p:cNvPr id="4" name="TextBox 3"/>
+          <p:cNvSpPr txBox="1"/>
+          <p:nvPr/>
+        </p:nvSpPr>
+        <p:spPr>
+          <a:xfrm>
+            <a:off x="640080" y="2377440"/>
+            <a:ext cx="5303520" cy="3108960"/>
+          </a:xfrm>
+          <a:prstGeom prst="rect">
+            <a:avLst/>
+          </a:prstGeom>
+          <a:noFill/>
+        </p:spPr>
+        <p:txBody>
+          <a:bodyPr wrap="square" lIns="0" rIns="0" tIns="0" bIns="0">
+            <a:spAutoFit/>
+          </a:bodyPr>
+          <a:lstStyle/>
+          <a:p>
+            <a:pPr algn="l">
+              <a:spcAft>
+                <a:spcPts val="600"/>
+              </a:spcAft>
+            </a:pPr>
+            <a:r>
+              <a:rPr sz="1900" b="1" i="0">
                 <a:solidFill>
                   <a:srgbClr val="000000"/>
                 </a:solidFill>
                 <a:latin typeface="Arial"/>
               </a:rPr>
-              <a:t>a second model estimates how far off each prediction is likely to be, so a small estimated error means high confidence.</a:t>
-            </a:r>
-          </a:p>
-          <a:p>
-            <a:pPr algn="l">
-              <a:spcAft>
-                <a:spcPts val="1300"/>
-              </a:spcAft>
-            </a:pPr>
-            <a:r>
-              <a:rPr sz="1600" b="1">
+              <a:t>Track A: screen a new molecule</a:t>
+            </a:r>
+          </a:p>
+          <a:p>
+            <a:pPr algn="l">
+              <a:spcAft>
+                <a:spcPts val="1200"/>
+              </a:spcAft>
+            </a:pPr>
+            <a:r>
+              <a:rPr sz="1300" b="0" i="1">
+                <a:solidFill>
+                  <a:srgbClr val="404040"/>
+                </a:solidFill>
+                <a:latin typeface="Arial"/>
+              </a:rPr>
+              <a:t>molecule-grouped cross-validation</a:t>
+            </a:r>
+          </a:p>
+          <a:p>
+            <a:pPr algn="l">
+              <a:spcAft>
+                <a:spcPts val="800"/>
+              </a:spcAft>
+            </a:pPr>
+            <a:r>
+              <a:rPr sz="1800" b="1" i="0">
                 <a:solidFill>
                   <a:srgbClr val="000000"/>
                 </a:solidFill>
                 <a:latin typeface="Arial"/>
               </a:rPr>
-              <a:t>Most confident 10 percent (or 25, or 50):  </a:t>
-            </a:r>
-            <a:r>
-              <a:rPr sz="1600" b="0">
+              <a:t>R-squared 0.466     RMSE 1.148</a:t>
+            </a:r>
+          </a:p>
+          <a:p>
+            <a:pPr algn="l">
+              <a:spcAft>
+                <a:spcPts val="600"/>
+              </a:spcAft>
+            </a:pPr>
+            <a:r>
+              <a:rPr sz="1500" b="0" i="0">
                 <a:solidFill>
                   <a:srgbClr val="000000"/>
                 </a:solidFill>
                 <a:latin typeface="Arial"/>
               </a:rPr>
-              <a:t>the fraction of predictions with the smallest estimated error. Keeping only those gives much higher accuracy.</a:t>
-            </a:r>
-          </a:p>
-          <a:p>
-            <a:pPr algn="l">
-              <a:spcAft>
-                <a:spcPts val="1300"/>
-              </a:spcAft>
-            </a:pPr>
-            <a:r>
-              <a:rPr sz="1600" b="1">
+              <a:t>Most confident 10 percent: R-squared 0.912, RMSE 0.493</a:t>
+            </a:r>
+          </a:p>
+        </p:txBody>
+      </p:sp>
+      <p:sp>
+        <p:nvSpPr>
+          <p:cNvPr id="5" name="TextBox 4"/>
+          <p:cNvSpPr txBox="1"/>
+          <p:nvPr/>
+        </p:nvSpPr>
+        <p:spPr>
+          <a:xfrm>
+            <a:off x="6400800" y="2377440"/>
+            <a:ext cx="5303520" cy="3108960"/>
+          </a:xfrm>
+          <a:prstGeom prst="rect">
+            <a:avLst/>
+          </a:prstGeom>
+          <a:noFill/>
+        </p:spPr>
+        <p:txBody>
+          <a:bodyPr wrap="square" lIns="0" rIns="0" tIns="0" bIns="0">
+            <a:spAutoFit/>
+          </a:bodyPr>
+          <a:lstStyle/>
+          <a:p>
+            <a:pPr algn="l">
+              <a:spcAft>
+                <a:spcPts val="600"/>
+              </a:spcAft>
+            </a:pPr>
+            <a:r>
+              <a:rPr sz="1900" b="1" i="0">
                 <a:solidFill>
                   <a:srgbClr val="000000"/>
                 </a:solidFill>
                 <a:latin typeface="Arial"/>
               </a:rPr>
-              <a:t>Uncertainty interval:  </a:t>
-            </a:r>
-            <a:r>
-              <a:rPr sz="1600" b="0">
+              <a:t>Track B: optimize conditions</a:t>
+            </a:r>
+          </a:p>
+          <a:p>
+            <a:pPr algn="l">
+              <a:spcAft>
+                <a:spcPts val="1200"/>
+              </a:spcAft>
+            </a:pPr>
+            <a:r>
+              <a:rPr sz="1300" b="0" i="1">
+                <a:solidFill>
+                  <a:srgbClr val="404040"/>
+                </a:solidFill>
+                <a:latin typeface="Arial"/>
+              </a:rPr>
+              <a:t>random-row cross-validation</a:t>
+            </a:r>
+          </a:p>
+          <a:p>
+            <a:pPr algn="l">
+              <a:spcAft>
+                <a:spcPts val="800"/>
+              </a:spcAft>
+            </a:pPr>
+            <a:r>
+              <a:rPr sz="1800" b="1" i="0">
                 <a:solidFill>
                   <a:srgbClr val="000000"/>
                 </a:solidFill>
                 <a:latin typeface="Arial"/>
               </a:rPr>
-              <a:t>instead of a single number, the model returns a range of logD values for each prediction.</a:t>
-            </a:r>
-          </a:p>
-          <a:p>
-            <a:pPr algn="l">
-              <a:spcAft>
-                <a:spcPts val="1300"/>
-              </a:spcAft>
-            </a:pPr>
-            <a:r>
-              <a:rPr sz="1600" b="1">
+              <a:t>R-squared 0.725     RMSE 0.823</a:t>
+            </a:r>
+          </a:p>
+          <a:p>
+            <a:pPr algn="l">
+              <a:spcAft>
+                <a:spcPts val="600"/>
+              </a:spcAft>
+            </a:pPr>
+            <a:r>
+              <a:rPr sz="1500" b="0" i="0">
                 <a:solidFill>
                   <a:srgbClr val="000000"/>
                 </a:solidFill>
                 <a:latin typeface="Arial"/>
               </a:rPr>
-              <a:t>90 percent interval:  </a:t>
-            </a:r>
-            <a:r>
-              <a:rPr sz="1600" b="0">
-                <a:solidFill>
-                  <a:srgbClr val="000000"/>
-                </a:solidFill>
-                <a:latin typeface="Arial"/>
-              </a:rPr>
-              <a:t>a range built to contain the true logD about 90 percent of the time. An 80 percent interval is narrower and contains it about 80 percent of the time.</a:t>
-            </a:r>
-          </a:p>
-          <a:p>
-            <a:pPr algn="l">
-              <a:spcAft>
-                <a:spcPts val="1300"/>
-              </a:spcAft>
-            </a:pPr>
-            <a:r>
-              <a:rPr sz="1600" b="1">
-                <a:solidFill>
-                  <a:srgbClr val="000000"/>
-                </a:solidFill>
-                <a:latin typeface="Arial"/>
-              </a:rPr>
-              <a:t>Coverage:  </a:t>
-            </a:r>
-            <a:r>
-              <a:rPr sz="1600" b="0">
-                <a:solidFill>
-                  <a:srgbClr val="000000"/>
-                </a:solidFill>
-                <a:latin typeface="Arial"/>
-              </a:rPr>
-              <a:t>the fraction of points whose true value actually lands inside the interval. We measured 0.89 to 0.90 against the 90 percent target, so the ranges are honest.</a:t>
+              <a:t>Most confident 10 percent: R-squared 0.940, RMSE 0.341</a:t>
             </a:r>
           </a:p>
         </p:txBody>
@@ -5892,7 +5996,7 @@
                 </a:solidFill>
                 <a:latin typeface="Arial"/>
               </a:rPr>
-              <a:t>What a 90 percent interval means</a:t>
+              <a:t>Definitions</a:t>
             </a:r>
           </a:p>
         </p:txBody>
@@ -5905,8 +6009,8 @@
         </p:nvSpPr>
         <p:spPr>
           <a:xfrm>
-            <a:off x="640080" y="1280160"/>
-            <a:ext cx="10972800" cy="1783080"/>
+            <a:off x="640080" y="1463040"/>
+            <a:ext cx="10972800" cy="4937760"/>
           </a:xfrm>
           <a:prstGeom prst="rect">
             <a:avLst/>
@@ -5921,61 +6025,130 @@
           <a:p>
             <a:pPr algn="l">
               <a:spcAft>
-                <a:spcPts val="800"/>
-              </a:spcAft>
-            </a:pPr>
-            <a:r>
-              <a:rPr sz="1500" b="0" i="0">
+                <a:spcPts val="1300"/>
+              </a:spcAft>
+            </a:pPr>
+            <a:r>
+              <a:rPr sz="1600" b="1">
                 <a:solidFill>
                   <a:srgbClr val="000000"/>
                 </a:solidFill>
                 <a:latin typeface="Arial"/>
               </a:rPr>
-              <a:t>The model gives a range, not just a single number. For example, it might predict a logD of 1.5 and report that it is 90 percent sure the true value is between 0.6 and 2.4. Across many predictions, each with its own 90 percent range, the true value should land inside about 90 times out of 100, while an 80 percent range is narrower and contains it about 80 times out of 100.</a:t>
-            </a:r>
-          </a:p>
-          <a:p>
-            <a:pPr algn="l">
-              <a:spcAft>
-                <a:spcPts val="600"/>
-              </a:spcAft>
-            </a:pPr>
-            <a:r>
-              <a:rPr sz="1500" b="0" i="0">
+              <a:t>Confidence score:  </a:t>
+            </a:r>
+            <a:r>
+              <a:rPr sz="1600" b="0">
                 <a:solidFill>
                   <a:srgbClr val="000000"/>
                 </a:solidFill>
                 <a:latin typeface="Arial"/>
               </a:rPr>
-              <a:t>Coverage is how often this actually happens. Checking every range against the real value, the true logD landed inside the 90 percent range 89 to 90 percent of the time, right on target, which is what it means to say the ranges are honest.</a:t>
-            </a:r>
-          </a:p>
-        </p:txBody>
-      </p:sp>
-      <p:pic>
-        <p:nvPicPr>
-          <p:cNvPr id="4" name="Picture 3" descr="coverage_illustration.png"/>
-          <p:cNvPicPr>
-            <a:picLocks noChangeAspect="1"/>
-          </p:cNvPicPr>
-          <p:nvPr/>
-        </p:nvPicPr>
-        <p:blipFill>
-          <a:blip r:embed="rId2"/>
-          <a:stretch>
-            <a:fillRect/>
-          </a:stretch>
-        </p:blipFill>
-        <p:spPr>
-          <a:xfrm>
-            <a:off x="3219269" y="3154680"/>
-            <a:ext cx="5753155" cy="3429000"/>
-          </a:xfrm>
-          <a:prstGeom prst="rect">
-            <a:avLst/>
-          </a:prstGeom>
-        </p:spPr>
-      </p:pic>
+              <a:t>a second model estimates how far off each prediction is likely to be, so a small estimated error means high confidence.</a:t>
+            </a:r>
+          </a:p>
+          <a:p>
+            <a:pPr algn="l">
+              <a:spcAft>
+                <a:spcPts val="1300"/>
+              </a:spcAft>
+            </a:pPr>
+            <a:r>
+              <a:rPr sz="1600" b="1">
+                <a:solidFill>
+                  <a:srgbClr val="000000"/>
+                </a:solidFill>
+                <a:latin typeface="Arial"/>
+              </a:rPr>
+              <a:t>Most confident 10 percent (or 25, or 50):  </a:t>
+            </a:r>
+            <a:r>
+              <a:rPr sz="1600" b="0">
+                <a:solidFill>
+                  <a:srgbClr val="000000"/>
+                </a:solidFill>
+                <a:latin typeface="Arial"/>
+              </a:rPr>
+              <a:t>the fraction of predictions with the smallest estimated error. Keeping only those gives much higher accuracy.</a:t>
+            </a:r>
+          </a:p>
+          <a:p>
+            <a:pPr algn="l">
+              <a:spcAft>
+                <a:spcPts val="1300"/>
+              </a:spcAft>
+            </a:pPr>
+            <a:r>
+              <a:rPr sz="1600" b="1">
+                <a:solidFill>
+                  <a:srgbClr val="000000"/>
+                </a:solidFill>
+                <a:latin typeface="Arial"/>
+              </a:rPr>
+              <a:t>Uncertainty interval:  </a:t>
+            </a:r>
+            <a:r>
+              <a:rPr sz="1600" b="0">
+                <a:solidFill>
+                  <a:srgbClr val="000000"/>
+                </a:solidFill>
+                <a:latin typeface="Arial"/>
+              </a:rPr>
+              <a:t>instead of a single number, the model returns a range of logD values for each prediction.</a:t>
+            </a:r>
+          </a:p>
+          <a:p>
+            <a:pPr algn="l">
+              <a:spcAft>
+                <a:spcPts val="1300"/>
+              </a:spcAft>
+            </a:pPr>
+            <a:r>
+              <a:rPr sz="1600" b="1">
+                <a:solidFill>
+                  <a:srgbClr val="000000"/>
+                </a:solidFill>
+                <a:latin typeface="Arial"/>
+              </a:rPr>
+              <a:t>90 percent interval:  </a:t>
+            </a:r>
+            <a:r>
+              <a:rPr sz="1600" b="0">
+                <a:solidFill>
+                  <a:srgbClr val="000000"/>
+                </a:solidFill>
+                <a:latin typeface="Arial"/>
+              </a:rPr>
+              <a:t>a range built to contain the true logD about 90 percent of the time. An 80 percent interval is narrower and contains it about 80 percent of the time.</a:t>
+            </a:r>
+          </a:p>
+          <a:p>
+            <a:pPr algn="l">
+              <a:spcAft>
+                <a:spcPts val="1300"/>
+              </a:spcAft>
+            </a:pPr>
+            <a:r>
+              <a:rPr sz="1600" b="1">
+                <a:solidFill>
+                  <a:srgbClr val="000000"/>
+                </a:solidFill>
+                <a:latin typeface="Arial"/>
+              </a:rPr>
+              <a:t>Coverage:  </a:t>
+            </a:r>
+            <a:r>
+              <a:rPr sz="1600" b="0">
+                <a:solidFill>
+                  <a:srgbClr val="000000"/>
+                </a:solidFill>
+                <a:latin typeface="Arial"/>
+              </a:rPr>
+              <a:t>the fraction of points whose true value actually lands inside the interval. We measured 0.89 to 0.90 against the 90 percent target, so the ranges are honest.</a:t>
+            </a:r>
+          </a:p>
+        </p:txBody>
+      </p:sp>
     </p:spTree>
   </p:cSld>
   <p:clrMapOvr>
@@ -6036,14 +6209,69 @@
                 </a:solidFill>
                 <a:latin typeface="Arial"/>
               </a:rPr>
-              <a:t>Accuracy versus confidence, Track A</a:t>
+              <a:t>What a 90 percent interval means</a:t>
+            </a:r>
+          </a:p>
+        </p:txBody>
+      </p:sp>
+      <p:sp>
+        <p:nvSpPr>
+          <p:cNvPr id="3" name="TextBox 2"/>
+          <p:cNvSpPr txBox="1"/>
+          <p:nvPr/>
+        </p:nvSpPr>
+        <p:spPr>
+          <a:xfrm>
+            <a:off x="640080" y="1280160"/>
+            <a:ext cx="10972800" cy="1783080"/>
+          </a:xfrm>
+          <a:prstGeom prst="rect">
+            <a:avLst/>
+          </a:prstGeom>
+          <a:noFill/>
+        </p:spPr>
+        <p:txBody>
+          <a:bodyPr wrap="square" lIns="0" rIns="0" tIns="0" bIns="0">
+            <a:spAutoFit/>
+          </a:bodyPr>
+          <a:lstStyle/>
+          <a:p>
+            <a:pPr algn="l">
+              <a:spcAft>
+                <a:spcPts val="800"/>
+              </a:spcAft>
+            </a:pPr>
+            <a:r>
+              <a:rPr sz="1500" b="0" i="0">
+                <a:solidFill>
+                  <a:srgbClr val="000000"/>
+                </a:solidFill>
+                <a:latin typeface="Arial"/>
+              </a:rPr>
+              <a:t>The model gives a range, not just a single number. For example, it might predict a logD of 1.5 and report that it is 90 percent sure the true value is between 0.6 and 2.4. Across many predictions, each with its own 90 percent range, the true value should land inside about 90 times out of 100, while an 80 percent range is narrower and contains it about 80 times out of 100.</a:t>
+            </a:r>
+          </a:p>
+          <a:p>
+            <a:pPr algn="l">
+              <a:spcAft>
+                <a:spcPts val="600"/>
+              </a:spcAft>
+            </a:pPr>
+            <a:r>
+              <a:rPr sz="1500" b="0" i="0">
+                <a:solidFill>
+                  <a:srgbClr val="000000"/>
+                </a:solidFill>
+                <a:latin typeface="Arial"/>
+              </a:rPr>
+              <a:t>Coverage is how often this actually happens. Checking every range against the real value, the true logD landed inside the 90 percent range 89 to 90 percent of the time, right on target, which is what it means to say the ranges are honest.</a:t>
             </a:r>
           </a:p>
         </p:txBody>
       </p:sp>
       <p:pic>
         <p:nvPicPr>
-          <p:cNvPr id="3" name="Picture 2" descr="confidence_curve_a.png"/>
+          <p:cNvPr id="4" name="Picture 3" descr="coverage_illustration.png"/>
           <p:cNvPicPr>
             <a:picLocks noChangeAspect="1"/>
           </p:cNvPicPr>
@@ -6057,53 +6285,14 @@
         </p:blipFill>
         <p:spPr>
           <a:xfrm>
-            <a:off x="792327" y="1508760"/>
-            <a:ext cx="10607040" cy="3787693"/>
+            <a:off x="3219269" y="3154680"/>
+            <a:ext cx="5753155" cy="3429000"/>
           </a:xfrm>
           <a:prstGeom prst="rect">
             <a:avLst/>
           </a:prstGeom>
         </p:spPr>
       </p:pic>
-      <p:sp>
-        <p:nvSpPr>
-          <p:cNvPr id="4" name="TextBox 3"/>
-          <p:cNvSpPr txBox="1"/>
-          <p:nvPr/>
-        </p:nvSpPr>
-        <p:spPr>
-          <a:xfrm>
-            <a:off x="640080" y="5442757"/>
-            <a:ext cx="10881360" cy="1005840"/>
-          </a:xfrm>
-          <a:prstGeom prst="rect">
-            <a:avLst/>
-          </a:prstGeom>
-          <a:noFill/>
-        </p:spPr>
-        <p:txBody>
-          <a:bodyPr wrap="square" lIns="0" rIns="0" tIns="0" bIns="0">
-            <a:spAutoFit/>
-          </a:bodyPr>
-          <a:lstStyle/>
-          <a:p>
-            <a:pPr algn="l">
-              <a:spcAft>
-                <a:spcPts val="600"/>
-              </a:spcAft>
-            </a:pPr>
-            <a:r>
-              <a:rPr sz="1300" b="0" i="1">
-                <a:solidFill>
-                  <a:srgbClr val="404040"/>
-                </a:solidFill>
-                <a:latin typeface="Arial"/>
-              </a:rPr>
-              <a:t>Moving right to left keeps fewer but more confident predictions. The most confident tenth (the tenth with the smallest estimated error) reaches R-squared 0.912 and RMSE 0.493, against 0.466 and 1.148 over all predictions.</a:t>
-            </a:r>
-          </a:p>
-        </p:txBody>
-      </p:sp>
     </p:spTree>
   </p:cSld>
   <p:clrMapOvr>
@@ -6164,14 +6353,14 @@
                 </a:solidFill>
                 <a:latin typeface="Arial"/>
               </a:rPr>
-              <a:t>Accuracy versus confidence, Track B</a:t>
+              <a:t>Accuracy versus confidence, Track A</a:t>
             </a:r>
           </a:p>
         </p:txBody>
       </p:sp>
       <p:pic>
         <p:nvPicPr>
-          <p:cNvPr id="3" name="Picture 2" descr="confidence_curve_b.png"/>
+          <p:cNvPr id="3" name="Picture 2" descr="confidence_curve_a.png"/>
           <p:cNvPicPr>
             <a:picLocks noChangeAspect="1"/>
           </p:cNvPicPr>
@@ -6227,7 +6416,7 @@
                 </a:solidFill>
                 <a:latin typeface="Arial"/>
               </a:rPr>
-              <a:t>The same pattern holds for condition optimization: the most confident tenth reaches R-squared 0.940 and RMSE 0.341, against 0.725 and 0.823 over all predictions.</a:t>
+              <a:t>Moving right to left keeps fewer but more confident predictions. The most confident tenth (the tenth with the smallest estimated error) reaches R-squared 0.912 and RMSE 0.493, against 0.466 and 1.148 over all predictions.</a:t>
             </a:r>
           </a:p>
         </p:txBody>
@@ -6292,14 +6481,14 @@
                 </a:solidFill>
                 <a:latin typeface="Arial"/>
               </a:rPr>
-              <a:t>Predicted versus actual logD</a:t>
+              <a:t>Accuracy versus confidence, Track B</a:t>
             </a:r>
           </a:p>
         </p:txBody>
       </p:sp>
       <p:pic>
         <p:nvPicPr>
-          <p:cNvPr id="3" name="Picture 2" descr="pred_vs_actual_a.png"/>
+          <p:cNvPr id="3" name="Picture 2" descr="confidence_curve_b.png"/>
           <p:cNvPicPr>
             <a:picLocks noChangeAspect="1"/>
           </p:cNvPicPr>
@@ -6313,47 +6502,23 @@
         </p:blipFill>
         <p:spPr>
           <a:xfrm>
-            <a:off x="1097280" y="1600200"/>
-            <a:ext cx="4722725" cy="4297680"/>
+            <a:off x="792327" y="1508760"/>
+            <a:ext cx="10607040" cy="3787693"/>
           </a:xfrm>
           <a:prstGeom prst="rect">
             <a:avLst/>
           </a:prstGeom>
         </p:spPr>
       </p:pic>
-      <p:pic>
-        <p:nvPicPr>
-          <p:cNvPr id="4" name="Picture 3" descr="pred_vs_actual_b.png"/>
-          <p:cNvPicPr>
-            <a:picLocks noChangeAspect="1"/>
-          </p:cNvPicPr>
-          <p:nvPr/>
-        </p:nvPicPr>
-        <p:blipFill>
-          <a:blip r:embed="rId3"/>
-          <a:stretch>
-            <a:fillRect/>
-          </a:stretch>
-        </p:blipFill>
-        <p:spPr>
-          <a:xfrm>
-            <a:off x="6309360" y="1600200"/>
-            <a:ext cx="4796939" cy="4297680"/>
-          </a:xfrm>
-          <a:prstGeom prst="rect">
-            <a:avLst/>
-          </a:prstGeom>
-        </p:spPr>
-      </p:pic>
-      <p:sp>
-        <p:nvSpPr>
-          <p:cNvPr id="5" name="TextBox 4"/>
+      <p:sp>
+        <p:nvSpPr>
+          <p:cNvPr id="4" name="TextBox 3"/>
           <p:cNvSpPr txBox="1"/>
           <p:nvPr/>
         </p:nvSpPr>
         <p:spPr>
           <a:xfrm>
-            <a:off x="640080" y="6080760"/>
+            <a:off x="640080" y="5442757"/>
             <a:ext cx="10881360" cy="1005840"/>
           </a:xfrm>
           <a:prstGeom prst="rect">
@@ -6379,7 +6544,7 @@
                 </a:solidFill>
                 <a:latin typeface="Arial"/>
               </a:rPr>
-              <a:t>Left: Track A, new molecules. Right: Track B, known molecules. Each point is a prediction; darker points are the more confident ones and lie closer to the diagonal, where predicted equals actual.</a:t>
+              <a:t>The same pattern holds for condition optimization: the most confident tenth reaches R-squared 0.940 and RMSE 0.341, against 0.725 and 0.823 over all predictions.</a:t>
             </a:r>
           </a:p>
         </p:txBody>
@@ -6444,14 +6609,14 @@
                 </a:solidFill>
                 <a:latin typeface="Arial"/>
               </a:rPr>
-              <a:t>Accuracy by metal</a:t>
+              <a:t>Predicted versus actual logD</a:t>
             </a:r>
           </a:p>
         </p:txBody>
       </p:sp>
       <p:pic>
         <p:nvPicPr>
-          <p:cNvPr id="3" name="Picture 2" descr="by_metal_accuracy.png"/>
+          <p:cNvPr id="3" name="Picture 2" descr="pred_vs_actual_a.png"/>
           <p:cNvPicPr>
             <a:picLocks noChangeAspect="1"/>
           </p:cNvPicPr>
@@ -6465,23 +6630,47 @@
         </p:blipFill>
         <p:spPr>
           <a:xfrm>
-            <a:off x="1270309" y="1508760"/>
-            <a:ext cx="9651076" cy="4114800"/>
+            <a:off x="1097280" y="1600200"/>
+            <a:ext cx="4722725" cy="4297680"/>
           </a:xfrm>
           <a:prstGeom prst="rect">
             <a:avLst/>
           </a:prstGeom>
         </p:spPr>
       </p:pic>
-      <p:sp>
-        <p:nvSpPr>
-          <p:cNvPr id="4" name="TextBox 3"/>
+      <p:pic>
+        <p:nvPicPr>
+          <p:cNvPr id="4" name="Picture 3" descr="pred_vs_actual_b.png"/>
+          <p:cNvPicPr>
+            <a:picLocks noChangeAspect="1"/>
+          </p:cNvPicPr>
+          <p:nvPr/>
+        </p:nvPicPr>
+        <p:blipFill>
+          <a:blip r:embed="rId3"/>
+          <a:stretch>
+            <a:fillRect/>
+          </a:stretch>
+        </p:blipFill>
+        <p:spPr>
+          <a:xfrm>
+            <a:off x="6309360" y="1600200"/>
+            <a:ext cx="4796939" cy="4297680"/>
+          </a:xfrm>
+          <a:prstGeom prst="rect">
+            <a:avLst/>
+          </a:prstGeom>
+        </p:spPr>
+      </p:pic>
+      <p:sp>
+        <p:nvSpPr>
+          <p:cNvPr id="5" name="TextBox 4"/>
           <p:cNvSpPr txBox="1"/>
           <p:nvPr/>
         </p:nvSpPr>
         <p:spPr>
           <a:xfrm>
-            <a:off x="640080" y="5769864"/>
+            <a:off x="640080" y="6080760"/>
             <a:ext cx="10881360" cy="1005840"/>
           </a:xfrm>
           <a:prstGeom prst="rect">
@@ -6507,7 +6696,7 @@
                 </a:solidFill>
                 <a:latin typeface="Arial"/>
               </a:rPr>
-              <a:t>Accuracy is not uniform. It is highest on Americium and Curium and lowest on Neptunium(V), Erbium, and Uranium(VI), so a single overall number hides large differences between metals.</a:t>
+              <a:t>Left: Track A, new molecules. Right: Track B, known molecules. Each point is a prediction; darker points are the more confident ones and lie closer to the diagonal, where predicted equals actual.</a:t>
             </a:r>
           </a:p>
         </p:txBody>

</xml_diff>

<commit_message>
Restore the user's 21-slide deck (remove the inserted features slide)
Co-Authored-By: Claude Opus 4.8 <noreply@anthropic.com>
</commit_message>
<xml_diff>
--- a/docs/REE_Results_Slides_Final.pptx
+++ b/docs/REE_Results_Slides_Final.pptx
@@ -26,7 +26,6 @@
     <p:sldId id="274" r:id="rId25"/>
     <p:sldId id="275" r:id="rId26"/>
     <p:sldId id="276" r:id="rId27"/>
-    <p:sldId id="277" r:id="rId28"/>
   </p:sldIdLst>
   <p:sldSz cx="12191695" cy="6858000" type="screen4x3"/>
   <p:notesSz cx="6858000" cy="9144000"/>
@@ -3271,14 +3270,14 @@
                 </a:solidFill>
                 <a:latin typeface="Arial"/>
               </a:rPr>
-              <a:t>Accuracy by metal</a:t>
+              <a:t>Confidence by metal</a:t>
             </a:r>
           </a:p>
         </p:txBody>
       </p:sp>
       <p:pic>
         <p:nvPicPr>
-          <p:cNvPr id="3" name="Picture 2" descr="by_metal_accuracy.png"/>
+          <p:cNvPr id="3" name="Picture 2" descr="confidence_per_metal.png"/>
           <p:cNvPicPr>
             <a:picLocks noChangeAspect="1"/>
           </p:cNvPicPr>
@@ -3292,8 +3291,8 @@
         </p:blipFill>
         <p:spPr>
           <a:xfrm>
-            <a:off x="1270309" y="1508760"/>
-            <a:ext cx="9651076" cy="4114800"/>
+            <a:off x="2308061" y="1508760"/>
+            <a:ext cx="7575571" cy="4297680"/>
           </a:xfrm>
           <a:prstGeom prst="rect">
             <a:avLst/>
@@ -3308,7 +3307,7 @@
         </p:nvSpPr>
         <p:spPr>
           <a:xfrm>
-            <a:off x="640080" y="5769864"/>
+            <a:off x="640080" y="5952744"/>
             <a:ext cx="10881360" cy="1005840"/>
           </a:xfrm>
           <a:prstGeom prst="rect">
@@ -3334,7 +3333,7 @@
                 </a:solidFill>
                 <a:latin typeface="Arial"/>
               </a:rPr>
-              <a:t>Accuracy is not uniform. It is highest on Americium and Curium and lowest on Neptunium(V), Erbium, and Uranium(VI), so a single overall number hides large differences between metals.</a:t>
+              <a:t>Each bar is the model's median estimated error for a metal, which is its confidence signal, so a shorter bar means it is more sure. The model is most confident on Americium and Curium and least confident on Neptunium(V), Uranium(VI), and Erbium.</a:t>
             </a:r>
           </a:p>
         </p:txBody>
@@ -3399,14 +3398,14 @@
                 </a:solidFill>
                 <a:latin typeface="Arial"/>
               </a:rPr>
-              <a:t>Confidence by metal</a:t>
+              <a:t>Confidence versus error, by metal</a:t>
             </a:r>
           </a:p>
         </p:txBody>
       </p:sp>
       <p:pic>
         <p:nvPicPr>
-          <p:cNvPr id="3" name="Picture 2" descr="confidence_per_metal.png"/>
+          <p:cNvPr id="3" name="Picture 2" descr="by_metal_confidence_vs_error.png"/>
           <p:cNvPicPr>
             <a:picLocks noChangeAspect="1"/>
           </p:cNvPicPr>
@@ -3420,8 +3419,8 @@
         </p:blipFill>
         <p:spPr>
           <a:xfrm>
-            <a:off x="2308061" y="1508760"/>
-            <a:ext cx="7575571" cy="4297680"/>
+            <a:off x="3267777" y="1508760"/>
+            <a:ext cx="5656139" cy="3931920"/>
           </a:xfrm>
           <a:prstGeom prst="rect">
             <a:avLst/>
@@ -3436,7 +3435,7 @@
         </p:nvSpPr>
         <p:spPr>
           <a:xfrm>
-            <a:off x="640080" y="5952744"/>
+            <a:off x="640080" y="5586983"/>
             <a:ext cx="10881360" cy="1005840"/>
           </a:xfrm>
           <a:prstGeom prst="rect">
@@ -3462,7 +3461,7 @@
                 </a:solidFill>
                 <a:latin typeface="Arial"/>
               </a:rPr>
-              <a:t>Each bar is the model's median estimated error for a metal, which is its confidence signal, so a shorter bar means it is more sure. The model is most confident on Americium and Curium and least confident on Neptunium(V), Uranium(VI), and Erbium.</a:t>
+              <a:t>The horizontal axis is the model's estimated error and the vertical axis is the actual error. They line up, so Americium and Curium sit low on both while Neptunium(V), Uranium(VI), and Erbium sit high on both, which is what lets the model flag the metals it cannot predict well.</a:t>
             </a:r>
           </a:p>
         </p:txBody>
@@ -3527,14 +3526,14 @@
                 </a:solidFill>
                 <a:latin typeface="Arial"/>
               </a:rPr>
-              <a:t>Confidence versus error, by metal</a:t>
+              <a:t>Separation between metal pairs</a:t>
             </a:r>
           </a:p>
         </p:txBody>
       </p:sp>
       <p:pic>
         <p:nvPicPr>
-          <p:cNvPr id="3" name="Picture 2" descr="by_metal_confidence_vs_error.png"/>
+          <p:cNvPr id="3" name="Picture 2" descr="by_metal_pair_separation.png"/>
           <p:cNvPicPr>
             <a:picLocks noChangeAspect="1"/>
           </p:cNvPicPr>
@@ -3548,8 +3547,8 @@
         </p:blipFill>
         <p:spPr>
           <a:xfrm>
-            <a:off x="3267777" y="1508760"/>
-            <a:ext cx="5656139" cy="3931920"/>
+            <a:off x="900040" y="1508760"/>
+            <a:ext cx="10391613" cy="4114800"/>
           </a:xfrm>
           <a:prstGeom prst="rect">
             <a:avLst/>
@@ -3564,7 +3563,7 @@
         </p:nvSpPr>
         <p:spPr>
           <a:xfrm>
-            <a:off x="640080" y="5586983"/>
+            <a:off x="640080" y="5769864"/>
             <a:ext cx="10881360" cy="1005840"/>
           </a:xfrm>
           <a:prstGeom prst="rect">
@@ -3590,7 +3589,7 @@
                 </a:solidFill>
                 <a:latin typeface="Arial"/>
               </a:rPr>
-              <a:t>The horizontal axis is the model's estimated error and the vertical axis is the actual error. They line up, so Americium and Curium sit low on both while Neptunium(V), Uranium(VI), and Erbium sit high on both, which is what lets the model flag the metals it cannot predict well.</a:t>
+              <a:t>A separation is the logD difference between two metals at the same conditions. Pairs far apart in logD such as Dysprosium and Ytterbium are predicted well, while tight adjacent pairs such as Erbium and Terbium are hardest, which is the case that matters most for industry.</a:t>
             </a:r>
           </a:p>
         </p:txBody>
@@ -3655,14 +3654,14 @@
                 </a:solidFill>
                 <a:latin typeface="Arial"/>
               </a:rPr>
-              <a:t>Separation between metal pairs</a:t>
+              <a:t>Confidence by metal pair</a:t>
             </a:r>
           </a:p>
         </p:txBody>
       </p:sp>
       <p:pic>
         <p:nvPicPr>
-          <p:cNvPr id="3" name="Picture 2" descr="by_metal_pair_separation.png"/>
+          <p:cNvPr id="3" name="Picture 2" descr="by_pair_confidence_vs_error.png"/>
           <p:cNvPicPr>
             <a:picLocks noChangeAspect="1"/>
           </p:cNvPicPr>
@@ -3676,8 +3675,8 @@
         </p:blipFill>
         <p:spPr>
           <a:xfrm>
-            <a:off x="900040" y="1508760"/>
-            <a:ext cx="10391613" cy="4114800"/>
+            <a:off x="2728891" y="1508760"/>
+            <a:ext cx="6733912" cy="3931920"/>
           </a:xfrm>
           <a:prstGeom prst="rect">
             <a:avLst/>
@@ -3692,7 +3691,7 @@
         </p:nvSpPr>
         <p:spPr>
           <a:xfrm>
-            <a:off x="640080" y="5769864"/>
+            <a:off x="640080" y="5586983"/>
             <a:ext cx="10881360" cy="1005840"/>
           </a:xfrm>
           <a:prstGeom prst="rect">
@@ -3718,7 +3717,7 @@
                 </a:solidFill>
                 <a:latin typeface="Arial"/>
               </a:rPr>
-              <a:t>A separation is the logD difference between two metals at the same conditions. Pairs far apart in logD such as Dysprosium and Ytterbium are predicted well, while tight adjacent pairs such as Erbium and Terbium are hardest, which is the case that matters most for industry.</a:t>
+              <a:t>Confidence behaves the same way on pairs: the model's estimated error for a pair lines up with the actual separation error, so it is most confident on the easy far-apart pairs and least confident on hard adjacent pairs such as Erbium and Terbium.</a:t>
             </a:r>
           </a:p>
         </p:txBody>
@@ -3783,14 +3782,14 @@
                 </a:solidFill>
                 <a:latin typeface="Arial"/>
               </a:rPr>
-              <a:t>Confidence by metal pair</a:t>
+              <a:t>Ensemble weights</a:t>
             </a:r>
           </a:p>
         </p:txBody>
       </p:sp>
       <p:pic>
         <p:nvPicPr>
-          <p:cNvPr id="3" name="Picture 2" descr="by_pair_confidence_vs_error.png"/>
+          <p:cNvPr id="3" name="Picture 2" descr="ensemble_weights.png"/>
           <p:cNvPicPr>
             <a:picLocks noChangeAspect="1"/>
           </p:cNvPicPr>
@@ -3804,8 +3803,8 @@
         </p:blipFill>
         <p:spPr>
           <a:xfrm>
-            <a:off x="2728891" y="1508760"/>
-            <a:ext cx="6733912" cy="3931920"/>
+            <a:off x="792327" y="1508760"/>
+            <a:ext cx="10607040" cy="3795179"/>
           </a:xfrm>
           <a:prstGeom prst="rect">
             <a:avLst/>
@@ -3820,7 +3819,7 @@
         </p:nvSpPr>
         <p:spPr>
           <a:xfrm>
-            <a:off x="640080" y="5586983"/>
+            <a:off x="640080" y="5450243"/>
             <a:ext cx="10881360" cy="1005840"/>
           </a:xfrm>
           <a:prstGeom prst="rect">
@@ -3846,7 +3845,7 @@
                 </a:solidFill>
                 <a:latin typeface="Arial"/>
               </a:rPr>
-              <a:t>Confidence behaves the same way on pairs: the model's estimated error for a pair lines up with the actual separation error, so it is most confident on the easy far-apart pairs and least confident on hard adjacent pairs such as Erbium and Terbium.</a:t>
+              <a:t>Non-negative least squares keeps only the members that help, leaving ExtraTrees, LightGBM, and XGBoost on Track B and dropping the rest to a weight of zero.</a:t>
             </a:r>
           </a:p>
         </p:txBody>
@@ -3911,14 +3910,14 @@
                 </a:solidFill>
                 <a:latin typeface="Arial"/>
               </a:rPr>
-              <a:t>Ensemble weights</a:t>
+              <a:t>Uncertainty intervals</a:t>
             </a:r>
           </a:p>
         </p:txBody>
       </p:sp>
       <p:pic>
         <p:nvPicPr>
-          <p:cNvPr id="3" name="Picture 2" descr="ensemble_weights.png"/>
+          <p:cNvPr id="3" name="Picture 2" descr="conformal_calibration.png"/>
           <p:cNvPicPr>
             <a:picLocks noChangeAspect="1"/>
           </p:cNvPicPr>
@@ -3974,7 +3973,7 @@
                 </a:solidFill>
                 <a:latin typeface="Arial"/>
               </a:rPr>
-              <a:t>Non-negative least squares keeps only the members that help, leaving ExtraTrees, LightGBM, and XGBoost on Track B and dropping the rest to a weight of zero.</a:t>
+              <a:t>Each prediction comes with a range. A 90 percent interval is built to contain the true logD about 90 percent of the time, an 80 percent interval about 80 percent. The left bars show the measured coverage (0.89 to 0.90 and 0.79 to 0.80), so the ranges are honest; the right bars show the typical width, narrower on Track B.</a:t>
             </a:r>
           </a:p>
         </p:txBody>
@@ -4039,45 +4038,21 @@
                 </a:solidFill>
                 <a:latin typeface="Arial"/>
               </a:rPr>
-              <a:t>Uncertainty intervals</a:t>
-            </a:r>
-          </a:p>
-        </p:txBody>
-      </p:sp>
-      <p:pic>
-        <p:nvPicPr>
-          <p:cNvPr id="3" name="Picture 2" descr="conformal_calibration.png"/>
-          <p:cNvPicPr>
-            <a:picLocks noChangeAspect="1"/>
-          </p:cNvPicPr>
-          <p:nvPr/>
-        </p:nvPicPr>
-        <p:blipFill>
-          <a:blip r:embed="rId2"/>
-          <a:stretch>
-            <a:fillRect/>
-          </a:stretch>
-        </p:blipFill>
-        <p:spPr>
-          <a:xfrm>
-            <a:off x="792327" y="1508760"/>
-            <a:ext cx="10607040" cy="3795179"/>
-          </a:xfrm>
-          <a:prstGeom prst="rect">
-            <a:avLst/>
-          </a:prstGeom>
-        </p:spPr>
-      </p:pic>
-      <p:sp>
-        <p:nvSpPr>
-          <p:cNvPr id="4" name="TextBox 3"/>
+              <a:t>Comparison with Dr. Zhang's model</a:t>
+            </a:r>
+          </a:p>
+        </p:txBody>
+      </p:sp>
+      <p:sp>
+        <p:nvSpPr>
+          <p:cNvPr id="3" name="TextBox 2"/>
           <p:cNvSpPr txBox="1"/>
           <p:nvPr/>
         </p:nvSpPr>
         <p:spPr>
           <a:xfrm>
-            <a:off x="640080" y="5450243"/>
-            <a:ext cx="10881360" cy="1005840"/>
+            <a:off x="640080" y="1645920"/>
+            <a:ext cx="10972800" cy="3657600"/>
           </a:xfrm>
           <a:prstGeom prst="rect">
             <a:avLst/>
@@ -4092,17 +4067,49 @@
           <a:p>
             <a:pPr algn="l">
               <a:spcAft>
+                <a:spcPts val="1400"/>
+              </a:spcAft>
+            </a:pPr>
+            <a:r>
+              <a:rPr sz="1800" b="0" i="0">
+                <a:solidFill>
+                  <a:srgbClr val="000000"/>
+                </a:solidFill>
+                <a:latin typeface="Arial"/>
+              </a:rPr>
+              <a:t>Both projects use the same 8,075-row f-element dataset (295 molecules, 28 metals), so the comparison is fair on the data.</a:t>
+            </a:r>
+          </a:p>
+          <a:p>
+            <a:pPr algn="l">
+              <a:spcAft>
+                <a:spcPts val="1400"/>
+              </a:spcAft>
+            </a:pPr>
+            <a:r>
+              <a:rPr sz="1800" b="0" i="0">
+                <a:solidFill>
+                  <a:srgbClr val="000000"/>
+                </a:solidFill>
+                <a:latin typeface="Arial"/>
+              </a:rPr>
+              <a:t>His supervised model is a 3-class XGBoost classifier that reports 72 percent accuracy on one 494-row held-out test, with no way to rank which predictions to trust.</a:t>
+            </a:r>
+          </a:p>
+          <a:p>
+            <a:pPr algn="l">
+              <a:spcAft>
                 <a:spcPts val="600"/>
               </a:spcAft>
             </a:pPr>
             <a:r>
-              <a:rPr sz="1300" b="0" i="1">
-                <a:solidFill>
-                  <a:srgbClr val="404040"/>
-                </a:solidFill>
-                <a:latin typeface="Arial"/>
-              </a:rPr>
-              <a:t>Each prediction comes with a range. A 90 percent interval is built to contain the true logD about 90 percent of the time, an 80 percent interval about 80 percent. The left bars show the measured coverage (0.89 to 0.90 and 0.79 to 0.80), so the ranges are honest; the right bars show the typical width, narrower on Track B.</a:t>
+              <a:rPr sz="1800" b="0" i="0">
+                <a:solidFill>
+                  <a:srgbClr val="000000"/>
+                </a:solidFill>
+                <a:latin typeface="Arial"/>
+              </a:rPr>
+              <a:t>Ours predicts the continuous logD value with a confidence score and an uncertainty interval, and it can also be scored as a classifier on his exact task, which the next slides do.</a:t>
             </a:r>
           </a:p>
         </p:txBody>
@@ -4167,21 +4174,45 @@
                 </a:solidFill>
                 <a:latin typeface="Arial"/>
               </a:rPr>
-              <a:t>Comparison with Dr. Zhang's model</a:t>
-            </a:r>
-          </a:p>
-        </p:txBody>
-      </p:sp>
-      <p:sp>
-        <p:nvSpPr>
-          <p:cNvPr id="3" name="TextBox 2"/>
+              <a:t>Accuracy by confidence level, versus Zhang</a:t>
+            </a:r>
+          </a:p>
+        </p:txBody>
+      </p:sp>
+      <p:pic>
+        <p:nvPicPr>
+          <p:cNvPr id="3" name="Picture 2" descr="zhang_comparison_selective.png"/>
+          <p:cNvPicPr>
+            <a:picLocks noChangeAspect="1"/>
+          </p:cNvPicPr>
+          <p:nvPr/>
+        </p:nvPicPr>
+        <p:blipFill>
+          <a:blip r:embed="rId2"/>
+          <a:stretch>
+            <a:fillRect/>
+          </a:stretch>
+        </p:blipFill>
+        <p:spPr>
+          <a:xfrm>
+            <a:off x="2932411" y="1508760"/>
+            <a:ext cx="6326872" cy="3931920"/>
+          </a:xfrm>
+          <a:prstGeom prst="rect">
+            <a:avLst/>
+          </a:prstGeom>
+        </p:spPr>
+      </p:pic>
+      <p:sp>
+        <p:nvSpPr>
+          <p:cNvPr id="4" name="TextBox 3"/>
           <p:cNvSpPr txBox="1"/>
           <p:nvPr/>
         </p:nvSpPr>
         <p:spPr>
           <a:xfrm>
-            <a:off x="640080" y="1645920"/>
-            <a:ext cx="10972800" cy="3657600"/>
+            <a:off x="640080" y="5586983"/>
+            <a:ext cx="10881360" cy="1005840"/>
           </a:xfrm>
           <a:prstGeom prst="rect">
             <a:avLst/>
@@ -4196,49 +4227,17 @@
           <a:p>
             <a:pPr algn="l">
               <a:spcAft>
-                <a:spcPts val="1400"/>
-              </a:spcAft>
-            </a:pPr>
-            <a:r>
-              <a:rPr sz="1800" b="0" i="0">
-                <a:solidFill>
-                  <a:srgbClr val="000000"/>
-                </a:solidFill>
-                <a:latin typeface="Arial"/>
-              </a:rPr>
-              <a:t>Both projects use the same 8,075-row f-element dataset (295 molecules, 28 metals), so the comparison is fair on the data.</a:t>
-            </a:r>
-          </a:p>
-          <a:p>
-            <a:pPr algn="l">
-              <a:spcAft>
-                <a:spcPts val="1400"/>
-              </a:spcAft>
-            </a:pPr>
-            <a:r>
-              <a:rPr sz="1800" b="0" i="0">
-                <a:solidFill>
-                  <a:srgbClr val="000000"/>
-                </a:solidFill>
-                <a:latin typeface="Arial"/>
-              </a:rPr>
-              <a:t>His supervised model is a 3-class XGBoost classifier that reports 72 percent accuracy on one 494-row held-out test, with no way to rank which predictions to trust.</a:t>
-            </a:r>
-          </a:p>
-          <a:p>
-            <a:pPr algn="l">
-              <a:spcAft>
                 <a:spcPts val="600"/>
               </a:spcAft>
             </a:pPr>
             <a:r>
-              <a:rPr sz="1800" b="0" i="0">
-                <a:solidFill>
-                  <a:srgbClr val="000000"/>
-                </a:solidFill>
-                <a:latin typeface="Arial"/>
-              </a:rPr>
-              <a:t>Ours predicts the continuous logD value with a confidence score and an uncertainty interval, and it can also be scored as a classifier on his exact task, which the next slides do.</a:t>
+              <a:rPr sz="1300" b="0" i="1">
+                <a:solidFill>
+                  <a:srgbClr val="404040"/>
+                </a:solidFill>
+                <a:latin typeface="Arial"/>
+              </a:rPr>
+              <a:t>His 0.72 is a single value over all molecules. Ours can be ranked by confidence, so on the predictions it is most sure about it is far more accurate, which a single value cannot offer.</a:t>
             </a:r>
           </a:p>
         </p:txBody>
@@ -4303,134 +4302,6 @@
                 </a:solidFill>
                 <a:latin typeface="Arial"/>
               </a:rPr>
-              <a:t>Accuracy by confidence level, versus Zhang</a:t>
-            </a:r>
-          </a:p>
-        </p:txBody>
-      </p:sp>
-      <p:pic>
-        <p:nvPicPr>
-          <p:cNvPr id="3" name="Picture 2" descr="zhang_comparison_selective.png"/>
-          <p:cNvPicPr>
-            <a:picLocks noChangeAspect="1"/>
-          </p:cNvPicPr>
-          <p:nvPr/>
-        </p:nvPicPr>
-        <p:blipFill>
-          <a:blip r:embed="rId2"/>
-          <a:stretch>
-            <a:fillRect/>
-          </a:stretch>
-        </p:blipFill>
-        <p:spPr>
-          <a:xfrm>
-            <a:off x="2932411" y="1508760"/>
-            <a:ext cx="6326872" cy="3931920"/>
-          </a:xfrm>
-          <a:prstGeom prst="rect">
-            <a:avLst/>
-          </a:prstGeom>
-        </p:spPr>
-      </p:pic>
-      <p:sp>
-        <p:nvSpPr>
-          <p:cNvPr id="4" name="TextBox 3"/>
-          <p:cNvSpPr txBox="1"/>
-          <p:nvPr/>
-        </p:nvSpPr>
-        <p:spPr>
-          <a:xfrm>
-            <a:off x="640080" y="5586983"/>
-            <a:ext cx="10881360" cy="1005840"/>
-          </a:xfrm>
-          <a:prstGeom prst="rect">
-            <a:avLst/>
-          </a:prstGeom>
-          <a:noFill/>
-        </p:spPr>
-        <p:txBody>
-          <a:bodyPr wrap="square" lIns="0" rIns="0" tIns="0" bIns="0">
-            <a:spAutoFit/>
-          </a:bodyPr>
-          <a:lstStyle/>
-          <a:p>
-            <a:pPr algn="l">
-              <a:spcAft>
-                <a:spcPts val="600"/>
-              </a:spcAft>
-            </a:pPr>
-            <a:r>
-              <a:rPr sz="1300" b="0" i="1">
-                <a:solidFill>
-                  <a:srgbClr val="404040"/>
-                </a:solidFill>
-                <a:latin typeface="Arial"/>
-              </a:rPr>
-              <a:t>His 0.72 is a single value over all molecules. Ours can be ranked by confidence, so on the predictions it is most sure about it is far more accurate, which a single value cannot offer.</a:t>
-            </a:r>
-          </a:p>
-        </p:txBody>
-      </p:sp>
-    </p:spTree>
-  </p:cSld>
-  <p:clrMapOvr>
-    <a:masterClrMapping/>
-  </p:clrMapOvr>
-</p:sld>
-</file>
-
-<file path=ppt/slides/slide19.xml><?xml version="1.0" encoding="utf-8"?>
-<p:sld xmlns:a="http://schemas.openxmlformats.org/drawingml/2006/main" xmlns:p="http://schemas.openxmlformats.org/presentationml/2006/main" xmlns:r="http://schemas.openxmlformats.org/officeDocument/2006/relationships">
-  <p:cSld>
-    <p:bg>
-      <p:bgPr>
-        <a:solidFill>
-          <a:srgbClr val="FFFFFF"/>
-        </a:solidFill>
-        <a:effectLst/>
-      </p:bgPr>
-    </p:bg>
-    <p:spTree>
-      <p:nvGrpSpPr>
-        <p:cNvPr id="1" name=""/>
-        <p:cNvGrpSpPr/>
-        <p:nvPr/>
-      </p:nvGrpSpPr>
-      <p:grpSpPr/>
-      <p:sp>
-        <p:nvSpPr>
-          <p:cNvPr id="2" name="TextBox 1"/>
-          <p:cNvSpPr txBox="1"/>
-          <p:nvPr/>
-        </p:nvSpPr>
-        <p:spPr>
-          <a:xfrm>
-            <a:off x="640080" y="457200"/>
-            <a:ext cx="10972800" cy="914400"/>
-          </a:xfrm>
-          <a:prstGeom prst="rect">
-            <a:avLst/>
-          </a:prstGeom>
-          <a:noFill/>
-        </p:spPr>
-        <p:txBody>
-          <a:bodyPr wrap="square" lIns="0" rIns="0" tIns="0" bIns="0">
-            <a:spAutoFit/>
-          </a:bodyPr>
-          <a:lstStyle/>
-          <a:p>
-            <a:pPr algn="l">
-              <a:spcAft>
-                <a:spcPts val="600"/>
-              </a:spcAft>
-            </a:pPr>
-            <a:r>
-              <a:rPr sz="2900" b="1" i="0">
-                <a:solidFill>
-                  <a:srgbClr val="000000"/>
-                </a:solidFill>
-                <a:latin typeface="Arial"/>
-              </a:rPr>
               <a:t>Our model on Dr. Zhang's test set</a:t>
             </a:r>
           </a:p>
@@ -4507,331 +4378,7 @@
 </p:sld>
 </file>
 
-<file path=ppt/slides/slide2.xml><?xml version="1.0" encoding="utf-8"?>
-<p:sld xmlns:a="http://schemas.openxmlformats.org/drawingml/2006/main" xmlns:p="http://schemas.openxmlformats.org/presentationml/2006/main" xmlns:r="http://schemas.openxmlformats.org/officeDocument/2006/relationships">
-  <p:cSld>
-    <p:bg>
-      <p:bgPr>
-        <a:solidFill>
-          <a:srgbClr val="FFFFFF"/>
-        </a:solidFill>
-        <a:effectLst/>
-      </p:bgPr>
-    </p:bg>
-    <p:spTree>
-      <p:nvGrpSpPr>
-        <p:cNvPr id="1" name=""/>
-        <p:cNvGrpSpPr/>
-        <p:nvPr/>
-      </p:nvGrpSpPr>
-      <p:grpSpPr/>
-      <p:sp>
-        <p:nvSpPr>
-          <p:cNvPr id="2" name="TextBox 1"/>
-          <p:cNvSpPr txBox="1"/>
-          <p:nvPr/>
-        </p:nvSpPr>
-        <p:spPr>
-          <a:xfrm>
-            <a:off x="640080" y="457200"/>
-            <a:ext cx="10972800" cy="914400"/>
-          </a:xfrm>
-          <a:prstGeom prst="rect">
-            <a:avLst/>
-          </a:prstGeom>
-          <a:noFill/>
-        </p:spPr>
-        <p:txBody>
-          <a:bodyPr wrap="square" lIns="0" rIns="0" tIns="0" bIns="0">
-            <a:spAutoFit/>
-          </a:bodyPr>
-          <a:lstStyle/>
-          <a:p>
-            <a:pPr algn="l">
-              <a:spcAft>
-                <a:spcPts val="600"/>
-              </a:spcAft>
-            </a:pPr>
-            <a:r>
-              <a:rPr sz="2900" b="1" i="0">
-                <a:solidFill>
-                  <a:srgbClr val="000000"/>
-                </a:solidFill>
-                <a:latin typeface="Arial"/>
-              </a:rPr>
-              <a:t>Dataset</a:t>
-            </a:r>
-          </a:p>
-        </p:txBody>
-      </p:sp>
-      <p:sp>
-        <p:nvSpPr>
-          <p:cNvPr id="3" name="TextBox 2"/>
-          <p:cNvSpPr txBox="1"/>
-          <p:nvPr/>
-        </p:nvSpPr>
-        <p:spPr>
-          <a:xfrm>
-            <a:off x="640080" y="1371600"/>
-            <a:ext cx="10972800" cy="1554480"/>
-          </a:xfrm>
-          <a:prstGeom prst="rect">
-            <a:avLst/>
-          </a:prstGeom>
-          <a:noFill/>
-        </p:spPr>
-        <p:txBody>
-          <a:bodyPr wrap="square" lIns="0" rIns="0" tIns="0" bIns="0">
-            <a:spAutoFit/>
-          </a:bodyPr>
-          <a:lstStyle/>
-          <a:p>
-            <a:pPr algn="l">
-              <a:spcAft>
-                <a:spcPts val="600"/>
-              </a:spcAft>
-            </a:pPr>
-            <a:r>
-              <a:rPr sz="1600" b="0" i="0">
-                <a:solidFill>
-                  <a:srgbClr val="000000"/>
-                </a:solidFill>
-                <a:latin typeface="Arial"/>
-              </a:rPr>
-              <a:t>The goal is to predict how well an extractant separates two f-elements, with logD (the log of the distribution coefficient, D) as the target. The inputs are molecular descriptors, the SMILES string, molecular fingerprints, and environmental factors such as pH and temperature.</a:t>
-            </a:r>
-          </a:p>
-        </p:txBody>
-      </p:sp>
-      <p:sp>
-        <p:nvSpPr>
-          <p:cNvPr id="4" name="TextBox 3"/>
-          <p:cNvSpPr txBox="1"/>
-          <p:nvPr/>
-        </p:nvSpPr>
-        <p:spPr>
-          <a:xfrm>
-            <a:off x="640080" y="3108960"/>
-            <a:ext cx="2743200" cy="1463040"/>
-          </a:xfrm>
-          <a:prstGeom prst="rect">
-            <a:avLst/>
-          </a:prstGeom>
-          <a:noFill/>
-        </p:spPr>
-        <p:txBody>
-          <a:bodyPr wrap="square" lIns="0" rIns="0" tIns="0" bIns="0">
-            <a:spAutoFit/>
-          </a:bodyPr>
-          <a:lstStyle/>
-          <a:p>
-            <a:pPr algn="l">
-              <a:spcAft>
-                <a:spcPts val="600"/>
-              </a:spcAft>
-            </a:pPr>
-            <a:r>
-              <a:rPr sz="4400" b="1" i="0">
-                <a:solidFill>
-                  <a:srgbClr val="000000"/>
-                </a:solidFill>
-                <a:latin typeface="Arial"/>
-              </a:rPr>
-              <a:t>8,075</a:t>
-            </a:r>
-          </a:p>
-          <a:p>
-            <a:pPr algn="l">
-              <a:spcAft>
-                <a:spcPts val="600"/>
-              </a:spcAft>
-            </a:pPr>
-            <a:r>
-              <a:rPr sz="1400" b="0" i="0">
-                <a:solidFill>
-                  <a:srgbClr val="404040"/>
-                </a:solidFill>
-                <a:latin typeface="Arial"/>
-              </a:rPr>
-              <a:t>measurements</a:t>
-            </a:r>
-          </a:p>
-        </p:txBody>
-      </p:sp>
-      <p:sp>
-        <p:nvSpPr>
-          <p:cNvPr id="5" name="TextBox 4"/>
-          <p:cNvSpPr txBox="1"/>
-          <p:nvPr/>
-        </p:nvSpPr>
-        <p:spPr>
-          <a:xfrm>
-            <a:off x="3429000" y="3108960"/>
-            <a:ext cx="2743200" cy="1463040"/>
-          </a:xfrm>
-          <a:prstGeom prst="rect">
-            <a:avLst/>
-          </a:prstGeom>
-          <a:noFill/>
-        </p:spPr>
-        <p:txBody>
-          <a:bodyPr wrap="square" lIns="0" rIns="0" tIns="0" bIns="0">
-            <a:spAutoFit/>
-          </a:bodyPr>
-          <a:lstStyle/>
-          <a:p>
-            <a:pPr algn="l">
-              <a:spcAft>
-                <a:spcPts val="600"/>
-              </a:spcAft>
-            </a:pPr>
-            <a:r>
-              <a:rPr sz="4400" b="1" i="0">
-                <a:solidFill>
-                  <a:srgbClr val="000000"/>
-                </a:solidFill>
-                <a:latin typeface="Arial"/>
-              </a:rPr>
-              <a:t>295</a:t>
-            </a:r>
-          </a:p>
-          <a:p>
-            <a:pPr algn="l">
-              <a:spcAft>
-                <a:spcPts val="600"/>
-              </a:spcAft>
-            </a:pPr>
-            <a:r>
-              <a:rPr sz="1400" b="0" i="0">
-                <a:solidFill>
-                  <a:srgbClr val="404040"/>
-                </a:solidFill>
-                <a:latin typeface="Arial"/>
-              </a:rPr>
-              <a:t>distinct extractants</a:t>
-            </a:r>
-          </a:p>
-        </p:txBody>
-      </p:sp>
-      <p:sp>
-        <p:nvSpPr>
-          <p:cNvPr id="6" name="TextBox 5"/>
-          <p:cNvSpPr txBox="1"/>
-          <p:nvPr/>
-        </p:nvSpPr>
-        <p:spPr>
-          <a:xfrm>
-            <a:off x="6217920" y="3108960"/>
-            <a:ext cx="2743200" cy="1463040"/>
-          </a:xfrm>
-          <a:prstGeom prst="rect">
-            <a:avLst/>
-          </a:prstGeom>
-          <a:noFill/>
-        </p:spPr>
-        <p:txBody>
-          <a:bodyPr wrap="square" lIns="0" rIns="0" tIns="0" bIns="0">
-            <a:spAutoFit/>
-          </a:bodyPr>
-          <a:lstStyle/>
-          <a:p>
-            <a:pPr algn="l">
-              <a:spcAft>
-                <a:spcPts val="600"/>
-              </a:spcAft>
-            </a:pPr>
-            <a:r>
-              <a:rPr sz="4400" b="1" i="0">
-                <a:solidFill>
-                  <a:srgbClr val="000000"/>
-                </a:solidFill>
-                <a:latin typeface="Arial"/>
-              </a:rPr>
-              <a:t>28</a:t>
-            </a:r>
-          </a:p>
-          <a:p>
-            <a:pPr algn="l">
-              <a:spcAft>
-                <a:spcPts val="600"/>
-              </a:spcAft>
-            </a:pPr>
-            <a:r>
-              <a:rPr sz="1400" b="0" i="0">
-                <a:solidFill>
-                  <a:srgbClr val="404040"/>
-                </a:solidFill>
-                <a:latin typeface="Arial"/>
-              </a:rPr>
-              <a:t>f-element metals</a:t>
-            </a:r>
-          </a:p>
-        </p:txBody>
-      </p:sp>
-      <p:sp>
-        <p:nvSpPr>
-          <p:cNvPr id="7" name="TextBox 6"/>
-          <p:cNvSpPr txBox="1"/>
-          <p:nvPr/>
-        </p:nvSpPr>
-        <p:spPr>
-          <a:xfrm>
-            <a:off x="9006840" y="3108960"/>
-            <a:ext cx="2743200" cy="1463040"/>
-          </a:xfrm>
-          <a:prstGeom prst="rect">
-            <a:avLst/>
-          </a:prstGeom>
-          <a:noFill/>
-        </p:spPr>
-        <p:txBody>
-          <a:bodyPr wrap="square" lIns="0" rIns="0" tIns="0" bIns="0">
-            <a:spAutoFit/>
-          </a:bodyPr>
-          <a:lstStyle/>
-          <a:p>
-            <a:pPr algn="l">
-              <a:spcAft>
-                <a:spcPts val="600"/>
-              </a:spcAft>
-            </a:pPr>
-            <a:r>
-              <a:rPr sz="4400" b="1" i="0">
-                <a:solidFill>
-                  <a:srgbClr val="000000"/>
-                </a:solidFill>
-                <a:latin typeface="Arial"/>
-              </a:rPr>
-              <a:t>~17.5</a:t>
-            </a:r>
-          </a:p>
-          <a:p>
-            <a:pPr algn="l">
-              <a:spcAft>
-                <a:spcPts val="600"/>
-              </a:spcAft>
-            </a:pPr>
-            <a:r>
-              <a:rPr sz="1400" b="0" i="0">
-                <a:solidFill>
-                  <a:srgbClr val="404040"/>
-                </a:solidFill>
-                <a:latin typeface="Arial"/>
-              </a:rPr>
-              <a:t>log-unit range of logD</a:t>
-            </a:r>
-          </a:p>
-        </p:txBody>
-      </p:sp>
-    </p:spTree>
-  </p:cSld>
-  <p:clrMapOvr>
-    <a:masterClrMapping/>
-  </p:clrMapOvr>
-</p:sld>
-</file>
-
-<file path=ppt/slides/slide20.xml><?xml version="1.0" encoding="utf-8"?>
+<file path=ppt/slides/slide19.xml><?xml version="1.0" encoding="utf-8"?>
 <p:sld xmlns:a="http://schemas.openxmlformats.org/drawingml/2006/main" xmlns:p="http://schemas.openxmlformats.org/presentationml/2006/main" xmlns:r="http://schemas.openxmlformats.org/officeDocument/2006/relationships">
   <p:cSld>
     <p:bg>
@@ -5166,7 +4713,7 @@
 </p:sld>
 </file>
 
-<file path=ppt/slides/slide21.xml><?xml version="1.0" encoding="utf-8"?>
+<file path=ppt/slides/slide2.xml><?xml version="1.0" encoding="utf-8"?>
 <p:sld xmlns:a="http://schemas.openxmlformats.org/drawingml/2006/main" xmlns:p="http://schemas.openxmlformats.org/presentationml/2006/main" xmlns:r="http://schemas.openxmlformats.org/officeDocument/2006/relationships">
   <p:cSld>
     <p:bg>
@@ -5218,6 +4765,330 @@
                 </a:solidFill>
                 <a:latin typeface="Arial"/>
               </a:rPr>
+              <a:t>Dataset</a:t>
+            </a:r>
+          </a:p>
+        </p:txBody>
+      </p:sp>
+      <p:sp>
+        <p:nvSpPr>
+          <p:cNvPr id="3" name="TextBox 2"/>
+          <p:cNvSpPr txBox="1"/>
+          <p:nvPr/>
+        </p:nvSpPr>
+        <p:spPr>
+          <a:xfrm>
+            <a:off x="640080" y="1371600"/>
+            <a:ext cx="10972800" cy="1554480"/>
+          </a:xfrm>
+          <a:prstGeom prst="rect">
+            <a:avLst/>
+          </a:prstGeom>
+          <a:noFill/>
+        </p:spPr>
+        <p:txBody>
+          <a:bodyPr wrap="square" lIns="0" rIns="0" tIns="0" bIns="0">
+            <a:spAutoFit/>
+          </a:bodyPr>
+          <a:lstStyle/>
+          <a:p>
+            <a:pPr algn="l">
+              <a:spcAft>
+                <a:spcPts val="600"/>
+              </a:spcAft>
+            </a:pPr>
+            <a:r>
+              <a:rPr sz="1600" b="0" i="0">
+                <a:solidFill>
+                  <a:srgbClr val="000000"/>
+                </a:solidFill>
+                <a:latin typeface="Arial"/>
+              </a:rPr>
+              <a:t>The goal is to predict how well an extractant separates two f-elements, with logD (the log of the distribution coefficient, D) as the target. The inputs are molecular descriptors, the SMILES string, molecular fingerprints, and environmental factors such as pH and temperature.</a:t>
+            </a:r>
+          </a:p>
+        </p:txBody>
+      </p:sp>
+      <p:sp>
+        <p:nvSpPr>
+          <p:cNvPr id="4" name="TextBox 3"/>
+          <p:cNvSpPr txBox="1"/>
+          <p:nvPr/>
+        </p:nvSpPr>
+        <p:spPr>
+          <a:xfrm>
+            <a:off x="640080" y="3108960"/>
+            <a:ext cx="2743200" cy="1463040"/>
+          </a:xfrm>
+          <a:prstGeom prst="rect">
+            <a:avLst/>
+          </a:prstGeom>
+          <a:noFill/>
+        </p:spPr>
+        <p:txBody>
+          <a:bodyPr wrap="square" lIns="0" rIns="0" tIns="0" bIns="0">
+            <a:spAutoFit/>
+          </a:bodyPr>
+          <a:lstStyle/>
+          <a:p>
+            <a:pPr algn="l">
+              <a:spcAft>
+                <a:spcPts val="600"/>
+              </a:spcAft>
+            </a:pPr>
+            <a:r>
+              <a:rPr sz="4400" b="1" i="0">
+                <a:solidFill>
+                  <a:srgbClr val="000000"/>
+                </a:solidFill>
+                <a:latin typeface="Arial"/>
+              </a:rPr>
+              <a:t>8,075</a:t>
+            </a:r>
+          </a:p>
+          <a:p>
+            <a:pPr algn="l">
+              <a:spcAft>
+                <a:spcPts val="600"/>
+              </a:spcAft>
+            </a:pPr>
+            <a:r>
+              <a:rPr sz="1400" b="0" i="0">
+                <a:solidFill>
+                  <a:srgbClr val="404040"/>
+                </a:solidFill>
+                <a:latin typeface="Arial"/>
+              </a:rPr>
+              <a:t>measurements</a:t>
+            </a:r>
+          </a:p>
+        </p:txBody>
+      </p:sp>
+      <p:sp>
+        <p:nvSpPr>
+          <p:cNvPr id="5" name="TextBox 4"/>
+          <p:cNvSpPr txBox="1"/>
+          <p:nvPr/>
+        </p:nvSpPr>
+        <p:spPr>
+          <a:xfrm>
+            <a:off x="3429000" y="3108960"/>
+            <a:ext cx="2743200" cy="1463040"/>
+          </a:xfrm>
+          <a:prstGeom prst="rect">
+            <a:avLst/>
+          </a:prstGeom>
+          <a:noFill/>
+        </p:spPr>
+        <p:txBody>
+          <a:bodyPr wrap="square" lIns="0" rIns="0" tIns="0" bIns="0">
+            <a:spAutoFit/>
+          </a:bodyPr>
+          <a:lstStyle/>
+          <a:p>
+            <a:pPr algn="l">
+              <a:spcAft>
+                <a:spcPts val="600"/>
+              </a:spcAft>
+            </a:pPr>
+            <a:r>
+              <a:rPr sz="4400" b="1" i="0">
+                <a:solidFill>
+                  <a:srgbClr val="000000"/>
+                </a:solidFill>
+                <a:latin typeface="Arial"/>
+              </a:rPr>
+              <a:t>295</a:t>
+            </a:r>
+          </a:p>
+          <a:p>
+            <a:pPr algn="l">
+              <a:spcAft>
+                <a:spcPts val="600"/>
+              </a:spcAft>
+            </a:pPr>
+            <a:r>
+              <a:rPr sz="1400" b="0" i="0">
+                <a:solidFill>
+                  <a:srgbClr val="404040"/>
+                </a:solidFill>
+                <a:latin typeface="Arial"/>
+              </a:rPr>
+              <a:t>distinct extractants</a:t>
+            </a:r>
+          </a:p>
+        </p:txBody>
+      </p:sp>
+      <p:sp>
+        <p:nvSpPr>
+          <p:cNvPr id="6" name="TextBox 5"/>
+          <p:cNvSpPr txBox="1"/>
+          <p:nvPr/>
+        </p:nvSpPr>
+        <p:spPr>
+          <a:xfrm>
+            <a:off x="6217920" y="3108960"/>
+            <a:ext cx="2743200" cy="1463040"/>
+          </a:xfrm>
+          <a:prstGeom prst="rect">
+            <a:avLst/>
+          </a:prstGeom>
+          <a:noFill/>
+        </p:spPr>
+        <p:txBody>
+          <a:bodyPr wrap="square" lIns="0" rIns="0" tIns="0" bIns="0">
+            <a:spAutoFit/>
+          </a:bodyPr>
+          <a:lstStyle/>
+          <a:p>
+            <a:pPr algn="l">
+              <a:spcAft>
+                <a:spcPts val="600"/>
+              </a:spcAft>
+            </a:pPr>
+            <a:r>
+              <a:rPr sz="4400" b="1" i="0">
+                <a:solidFill>
+                  <a:srgbClr val="000000"/>
+                </a:solidFill>
+                <a:latin typeface="Arial"/>
+              </a:rPr>
+              <a:t>28</a:t>
+            </a:r>
+          </a:p>
+          <a:p>
+            <a:pPr algn="l">
+              <a:spcAft>
+                <a:spcPts val="600"/>
+              </a:spcAft>
+            </a:pPr>
+            <a:r>
+              <a:rPr sz="1400" b="0" i="0">
+                <a:solidFill>
+                  <a:srgbClr val="404040"/>
+                </a:solidFill>
+                <a:latin typeface="Arial"/>
+              </a:rPr>
+              <a:t>f-element metals</a:t>
+            </a:r>
+          </a:p>
+        </p:txBody>
+      </p:sp>
+      <p:sp>
+        <p:nvSpPr>
+          <p:cNvPr id="7" name="TextBox 6"/>
+          <p:cNvSpPr txBox="1"/>
+          <p:nvPr/>
+        </p:nvSpPr>
+        <p:spPr>
+          <a:xfrm>
+            <a:off x="9006840" y="3108960"/>
+            <a:ext cx="2743200" cy="1463040"/>
+          </a:xfrm>
+          <a:prstGeom prst="rect">
+            <a:avLst/>
+          </a:prstGeom>
+          <a:noFill/>
+        </p:spPr>
+        <p:txBody>
+          <a:bodyPr wrap="square" lIns="0" rIns="0" tIns="0" bIns="0">
+            <a:spAutoFit/>
+          </a:bodyPr>
+          <a:lstStyle/>
+          <a:p>
+            <a:pPr algn="l">
+              <a:spcAft>
+                <a:spcPts val="600"/>
+              </a:spcAft>
+            </a:pPr>
+            <a:r>
+              <a:rPr sz="4400" b="1" i="0">
+                <a:solidFill>
+                  <a:srgbClr val="000000"/>
+                </a:solidFill>
+                <a:latin typeface="Arial"/>
+              </a:rPr>
+              <a:t>~17.5</a:t>
+            </a:r>
+          </a:p>
+          <a:p>
+            <a:pPr algn="l">
+              <a:spcAft>
+                <a:spcPts val="600"/>
+              </a:spcAft>
+            </a:pPr>
+            <a:r>
+              <a:rPr sz="1400" b="0" i="0">
+                <a:solidFill>
+                  <a:srgbClr val="404040"/>
+                </a:solidFill>
+                <a:latin typeface="Arial"/>
+              </a:rPr>
+              <a:t>log-unit range of logD</a:t>
+            </a:r>
+          </a:p>
+        </p:txBody>
+      </p:sp>
+    </p:spTree>
+  </p:cSld>
+  <p:clrMapOvr>
+    <a:masterClrMapping/>
+  </p:clrMapOvr>
+</p:sld>
+</file>
+
+<file path=ppt/slides/slide20.xml><?xml version="1.0" encoding="utf-8"?>
+<p:sld xmlns:a="http://schemas.openxmlformats.org/drawingml/2006/main" xmlns:p="http://schemas.openxmlformats.org/presentationml/2006/main" xmlns:r="http://schemas.openxmlformats.org/officeDocument/2006/relationships">
+  <p:cSld>
+    <p:bg>
+      <p:bgPr>
+        <a:solidFill>
+          <a:srgbClr val="FFFFFF"/>
+        </a:solidFill>
+        <a:effectLst/>
+      </p:bgPr>
+    </p:bg>
+    <p:spTree>
+      <p:nvGrpSpPr>
+        <p:cNvPr id="1" name=""/>
+        <p:cNvGrpSpPr/>
+        <p:nvPr/>
+      </p:nvGrpSpPr>
+      <p:grpSpPr/>
+      <p:sp>
+        <p:nvSpPr>
+          <p:cNvPr id="2" name="TextBox 1"/>
+          <p:cNvSpPr txBox="1"/>
+          <p:nvPr/>
+        </p:nvSpPr>
+        <p:spPr>
+          <a:xfrm>
+            <a:off x="640080" y="457200"/>
+            <a:ext cx="10972800" cy="914400"/>
+          </a:xfrm>
+          <a:prstGeom prst="rect">
+            <a:avLst/>
+          </a:prstGeom>
+          <a:noFill/>
+        </p:spPr>
+        <p:txBody>
+          <a:bodyPr wrap="square" lIns="0" rIns="0" tIns="0" bIns="0">
+            <a:spAutoFit/>
+          </a:bodyPr>
+          <a:lstStyle/>
+          <a:p>
+            <a:pPr algn="l">
+              <a:spcAft>
+                <a:spcPts val="600"/>
+              </a:spcAft>
+            </a:pPr>
+            <a:r>
+              <a:rPr sz="2900" b="1" i="0">
+                <a:solidFill>
+                  <a:srgbClr val="000000"/>
+                </a:solidFill>
+                <a:latin typeface="Arial"/>
+              </a:rPr>
               <a:t>Training on Dr. Zhang's data</a:t>
             </a:r>
           </a:p>
@@ -5294,7 +5165,7 @@
 </p:sld>
 </file>
 
-<file path=ppt/slides/slide22.xml><?xml version="1.0" encoding="utf-8"?>
+<file path=ppt/slides/slide21.xml><?xml version="1.0" encoding="utf-8"?>
 <p:sld xmlns:a="http://schemas.openxmlformats.org/drawingml/2006/main" xmlns:p="http://schemas.openxmlformats.org/presentationml/2006/main" xmlns:r="http://schemas.openxmlformats.org/officeDocument/2006/relationships">
   <p:cSld>
     <p:bg>
@@ -5530,7 +5401,7 @@
                 </a:solidFill>
                 <a:latin typeface="Arial"/>
               </a:rPr>
-              <a:t>Dataset features and why</a:t>
+              <a:t>Two prediction tasks</a:t>
             </a:r>
           </a:p>
         </p:txBody>
@@ -5544,7 +5415,7 @@
         <p:spPr>
           <a:xfrm>
             <a:off x="640080" y="1371600"/>
-            <a:ext cx="10972800" cy="5120640"/>
+            <a:ext cx="10972800" cy="731520"/>
           </a:xfrm>
           <a:prstGeom prst="rect">
             <a:avLst/>
@@ -5559,101 +5430,191 @@
           <a:p>
             <a:pPr algn="l">
               <a:spcAft>
-                <a:spcPts val="1400"/>
-              </a:spcAft>
-            </a:pPr>
-            <a:r>
-              <a:rPr sz="1500" b="1">
+                <a:spcPts val="600"/>
+              </a:spcAft>
+            </a:pPr>
+            <a:r>
+              <a:rPr sz="1600" b="0" i="0">
                 <a:solidFill>
                   <a:srgbClr val="000000"/>
                 </a:solidFill>
                 <a:latin typeface="Arial"/>
               </a:rPr>
-              <a:t>Extractant structure:  </a:t>
-            </a:r>
-            <a:r>
-              <a:rPr sz="1500" b="0">
+              <a:t>The tasks are kept apart so a molecule cannot leak across training and testing, which would inflate the score.</a:t>
+            </a:r>
+          </a:p>
+        </p:txBody>
+      </p:sp>
+      <p:sp>
+        <p:nvSpPr>
+          <p:cNvPr id="4" name="TextBox 3"/>
+          <p:cNvSpPr txBox="1"/>
+          <p:nvPr/>
+        </p:nvSpPr>
+        <p:spPr>
+          <a:xfrm>
+            <a:off x="640080" y="2377440"/>
+            <a:ext cx="5303520" cy="3108960"/>
+          </a:xfrm>
+          <a:prstGeom prst="rect">
+            <a:avLst/>
+          </a:prstGeom>
+          <a:noFill/>
+        </p:spPr>
+        <p:txBody>
+          <a:bodyPr wrap="square" lIns="0" rIns="0" tIns="0" bIns="0">
+            <a:spAutoFit/>
+          </a:bodyPr>
+          <a:lstStyle/>
+          <a:p>
+            <a:pPr algn="l">
+              <a:spcAft>
+                <a:spcPts val="600"/>
+              </a:spcAft>
+            </a:pPr>
+            <a:r>
+              <a:rPr sz="1900" b="1" i="0">
                 <a:solidFill>
                   <a:srgbClr val="000000"/>
                 </a:solidFill>
                 <a:latin typeface="Arial"/>
               </a:rPr>
-              <a:t>SMILES, a Morgan fingerprint, RDKit descriptors, and donor-atom counts (O, N, S, P) with logP. These set how, and how strongly, the extractant binds a metal.</a:t>
-            </a:r>
-          </a:p>
-          <a:p>
-            <a:pPr algn="l">
-              <a:spcAft>
-                <a:spcPts val="1400"/>
-              </a:spcAft>
-            </a:pPr>
-            <a:r>
-              <a:rPr sz="1500" b="1">
+              <a:t>Track A: screen a new molecule</a:t>
+            </a:r>
+          </a:p>
+          <a:p>
+            <a:pPr algn="l">
+              <a:spcAft>
+                <a:spcPts val="1200"/>
+              </a:spcAft>
+            </a:pPr>
+            <a:r>
+              <a:rPr sz="1300" b="0" i="1">
+                <a:solidFill>
+                  <a:srgbClr val="404040"/>
+                </a:solidFill>
+                <a:latin typeface="Arial"/>
+              </a:rPr>
+              <a:t>molecule-grouped cross-validation</a:t>
+            </a:r>
+          </a:p>
+          <a:p>
+            <a:pPr algn="l">
+              <a:spcAft>
+                <a:spcPts val="800"/>
+              </a:spcAft>
+            </a:pPr>
+            <a:r>
+              <a:rPr sz="1800" b="1" i="0">
                 <a:solidFill>
                   <a:srgbClr val="000000"/>
                 </a:solidFill>
                 <a:latin typeface="Arial"/>
               </a:rPr>
-              <a:t>Metal descriptors:  </a:t>
-            </a:r>
-            <a:r>
-              <a:rPr sz="1500" b="0">
+              <a:t>R-squared 0.466     RMSE 1.148</a:t>
+            </a:r>
+          </a:p>
+          <a:p>
+            <a:pPr algn="l">
+              <a:spcAft>
+                <a:spcPts val="600"/>
+              </a:spcAft>
+            </a:pPr>
+            <a:r>
+              <a:rPr sz="1500" b="0" i="0">
                 <a:solidFill>
                   <a:srgbClr val="000000"/>
                 </a:solidFill>
                 <a:latin typeface="Arial"/>
               </a:rPr>
-              <a:t>ionic radius, charge and oxidation state, ionization energies, electronegativity, and atomic number. These carry the lanthanide-contraction trend that makes neighboring rare earths hard to separate, and let the model relate one metal to another.</a:t>
-            </a:r>
-          </a:p>
-          <a:p>
-            <a:pPr algn="l">
-              <a:spcAft>
-                <a:spcPts val="1400"/>
-              </a:spcAft>
-            </a:pPr>
-            <a:r>
-              <a:rPr sz="1500" b="1">
+              <a:t>Most confident 10 percent: R-squared 0.912, RMSE 0.493</a:t>
+            </a:r>
+          </a:p>
+        </p:txBody>
+      </p:sp>
+      <p:sp>
+        <p:nvSpPr>
+          <p:cNvPr id="5" name="TextBox 4"/>
+          <p:cNvSpPr txBox="1"/>
+          <p:nvPr/>
+        </p:nvSpPr>
+        <p:spPr>
+          <a:xfrm>
+            <a:off x="6400800" y="2377440"/>
+            <a:ext cx="5303520" cy="3108960"/>
+          </a:xfrm>
+          <a:prstGeom prst="rect">
+            <a:avLst/>
+          </a:prstGeom>
+          <a:noFill/>
+        </p:spPr>
+        <p:txBody>
+          <a:bodyPr wrap="square" lIns="0" rIns="0" tIns="0" bIns="0">
+            <a:spAutoFit/>
+          </a:bodyPr>
+          <a:lstStyle/>
+          <a:p>
+            <a:pPr algn="l">
+              <a:spcAft>
+                <a:spcPts val="600"/>
+              </a:spcAft>
+            </a:pPr>
+            <a:r>
+              <a:rPr sz="1900" b="1" i="0">
                 <a:solidFill>
                   <a:srgbClr val="000000"/>
                 </a:solidFill>
                 <a:latin typeface="Arial"/>
               </a:rPr>
-              <a:t>Acid and conditions:  </a:t>
-            </a:r>
-            <a:r>
-              <a:rPr sz="1500" b="0">
+              <a:t>Track B: optimize conditions</a:t>
+            </a:r>
+          </a:p>
+          <a:p>
+            <a:pPr algn="l">
+              <a:spcAft>
+                <a:spcPts val="1200"/>
+              </a:spcAft>
+            </a:pPr>
+            <a:r>
+              <a:rPr sz="1300" b="0" i="1">
+                <a:solidFill>
+                  <a:srgbClr val="404040"/>
+                </a:solidFill>
+                <a:latin typeface="Arial"/>
+              </a:rPr>
+              <a:t>random-row cross-validation</a:t>
+            </a:r>
+          </a:p>
+          <a:p>
+            <a:pPr algn="l">
+              <a:spcAft>
+                <a:spcPts val="800"/>
+              </a:spcAft>
+            </a:pPr>
+            <a:r>
+              <a:rPr sz="1800" b="1" i="0">
                 <a:solidFill>
                   <a:srgbClr val="000000"/>
                 </a:solidFill>
                 <a:latin typeface="Arial"/>
               </a:rPr>
-              <a:t>acid type and concentration, temperature, and extractant concentration. logD is an equilibrium, so it shifts with these as much as with the molecule.</a:t>
-            </a:r>
-          </a:p>
-          <a:p>
-            <a:pPr algn="l">
-              <a:spcAft>
-                <a:spcPts val="1400"/>
-              </a:spcAft>
-            </a:pPr>
-            <a:r>
-              <a:rPr sz="1500" b="1">
+              <a:t>R-squared 0.725     RMSE 0.823</a:t>
+            </a:r>
+          </a:p>
+          <a:p>
+            <a:pPr algn="l">
+              <a:spcAft>
+                <a:spcPts val="600"/>
+              </a:spcAft>
+            </a:pPr>
+            <a:r>
+              <a:rPr sz="1500" b="0" i="0">
                 <a:solidFill>
                   <a:srgbClr val="000000"/>
                 </a:solidFill>
                 <a:latin typeface="Arial"/>
               </a:rPr>
-              <a:t>Diluent (solvent):  </a:t>
-            </a:r>
-            <a:r>
-              <a:rPr sz="1500" b="0">
-                <a:solidFill>
-                  <a:srgbClr val="000000"/>
-                </a:solidFill>
-                <a:latin typeface="Arial"/>
-              </a:rPr>
-              <a:t>molar mass, logP, boiling and melting points, density, solubility, and dipole moment. The diluent sets the organic-phase environment around the extractant.</a:t>
+              <a:t>Most confident 10 percent: R-squared 0.940, RMSE 0.341</a:t>
             </a:r>
           </a:p>
         </p:txBody>
@@ -5718,7 +5679,7 @@
                 </a:solidFill>
                 <a:latin typeface="Arial"/>
               </a:rPr>
-              <a:t>Two prediction tasks</a:t>
+              <a:t>Definitions</a:t>
             </a:r>
           </a:p>
         </p:txBody>
@@ -5731,8 +5692,8 @@
         </p:nvSpPr>
         <p:spPr>
           <a:xfrm>
-            <a:off x="640080" y="1371600"/>
-            <a:ext cx="10972800" cy="731520"/>
+            <a:off x="640080" y="1463040"/>
+            <a:ext cx="10972800" cy="4937760"/>
           </a:xfrm>
           <a:prstGeom prst="rect">
             <a:avLst/>
@@ -5747,191 +5708,126 @@
           <a:p>
             <a:pPr algn="l">
               <a:spcAft>
-                <a:spcPts val="600"/>
-              </a:spcAft>
-            </a:pPr>
-            <a:r>
-              <a:rPr sz="1600" b="0" i="0">
+                <a:spcPts val="1300"/>
+              </a:spcAft>
+            </a:pPr>
+            <a:r>
+              <a:rPr sz="1600" b="1">
                 <a:solidFill>
                   <a:srgbClr val="000000"/>
                 </a:solidFill>
                 <a:latin typeface="Arial"/>
               </a:rPr>
-              <a:t>The tasks are kept apart so a molecule cannot leak across training and testing, which would inflate the score.</a:t>
-            </a:r>
-          </a:p>
-        </p:txBody>
-      </p:sp>
-      <p:sp>
-        <p:nvSpPr>
-          <p:cNvPr id="4" name="TextBox 3"/>
-          <p:cNvSpPr txBox="1"/>
-          <p:nvPr/>
-        </p:nvSpPr>
-        <p:spPr>
-          <a:xfrm>
-            <a:off x="640080" y="2377440"/>
-            <a:ext cx="5303520" cy="3108960"/>
-          </a:xfrm>
-          <a:prstGeom prst="rect">
-            <a:avLst/>
-          </a:prstGeom>
-          <a:noFill/>
-        </p:spPr>
-        <p:txBody>
-          <a:bodyPr wrap="square" lIns="0" rIns="0" tIns="0" bIns="0">
-            <a:spAutoFit/>
-          </a:bodyPr>
-          <a:lstStyle/>
-          <a:p>
-            <a:pPr algn="l">
-              <a:spcAft>
-                <a:spcPts val="600"/>
-              </a:spcAft>
-            </a:pPr>
-            <a:r>
-              <a:rPr sz="1900" b="1" i="0">
+              <a:t>Confidence score:  </a:t>
+            </a:r>
+            <a:r>
+              <a:rPr sz="1600" b="0">
                 <a:solidFill>
                   <a:srgbClr val="000000"/>
                 </a:solidFill>
                 <a:latin typeface="Arial"/>
               </a:rPr>
-              <a:t>Track A: screen a new molecule</a:t>
-            </a:r>
-          </a:p>
-          <a:p>
-            <a:pPr algn="l">
-              <a:spcAft>
-                <a:spcPts val="1200"/>
-              </a:spcAft>
-            </a:pPr>
-            <a:r>
-              <a:rPr sz="1300" b="0" i="1">
-                <a:solidFill>
-                  <a:srgbClr val="404040"/>
-                </a:solidFill>
-                <a:latin typeface="Arial"/>
-              </a:rPr>
-              <a:t>molecule-grouped cross-validation</a:t>
-            </a:r>
-          </a:p>
-          <a:p>
-            <a:pPr algn="l">
-              <a:spcAft>
-                <a:spcPts val="800"/>
-              </a:spcAft>
-            </a:pPr>
-            <a:r>
-              <a:rPr sz="1800" b="1" i="0">
+              <a:t>a second model estimates how far off each prediction is likely to be, so a small estimated error means high confidence.</a:t>
+            </a:r>
+          </a:p>
+          <a:p>
+            <a:pPr algn="l">
+              <a:spcAft>
+                <a:spcPts val="1300"/>
+              </a:spcAft>
+            </a:pPr>
+            <a:r>
+              <a:rPr sz="1600" b="1">
                 <a:solidFill>
                   <a:srgbClr val="000000"/>
                 </a:solidFill>
                 <a:latin typeface="Arial"/>
               </a:rPr>
-              <a:t>R-squared 0.466     RMSE 1.148</a:t>
-            </a:r>
-          </a:p>
-          <a:p>
-            <a:pPr algn="l">
-              <a:spcAft>
-                <a:spcPts val="600"/>
-              </a:spcAft>
-            </a:pPr>
-            <a:r>
-              <a:rPr sz="1500" b="0" i="0">
+              <a:t>Most confident 10 percent (or 25, or 50):  </a:t>
+            </a:r>
+            <a:r>
+              <a:rPr sz="1600" b="0">
                 <a:solidFill>
                   <a:srgbClr val="000000"/>
                 </a:solidFill>
                 <a:latin typeface="Arial"/>
               </a:rPr>
-              <a:t>Most confident 10 percent: R-squared 0.912, RMSE 0.493</a:t>
-            </a:r>
-          </a:p>
-        </p:txBody>
-      </p:sp>
-      <p:sp>
-        <p:nvSpPr>
-          <p:cNvPr id="5" name="TextBox 4"/>
-          <p:cNvSpPr txBox="1"/>
-          <p:nvPr/>
-        </p:nvSpPr>
-        <p:spPr>
-          <a:xfrm>
-            <a:off x="6400800" y="2377440"/>
-            <a:ext cx="5303520" cy="3108960"/>
-          </a:xfrm>
-          <a:prstGeom prst="rect">
-            <a:avLst/>
-          </a:prstGeom>
-          <a:noFill/>
-        </p:spPr>
-        <p:txBody>
-          <a:bodyPr wrap="square" lIns="0" rIns="0" tIns="0" bIns="0">
-            <a:spAutoFit/>
-          </a:bodyPr>
-          <a:lstStyle/>
-          <a:p>
-            <a:pPr algn="l">
-              <a:spcAft>
-                <a:spcPts val="600"/>
-              </a:spcAft>
-            </a:pPr>
-            <a:r>
-              <a:rPr sz="1900" b="1" i="0">
+              <a:t>the fraction of predictions with the smallest estimated error. Keeping only those gives much higher accuracy.</a:t>
+            </a:r>
+          </a:p>
+          <a:p>
+            <a:pPr algn="l">
+              <a:spcAft>
+                <a:spcPts val="1300"/>
+              </a:spcAft>
+            </a:pPr>
+            <a:r>
+              <a:rPr sz="1600" b="1">
                 <a:solidFill>
                   <a:srgbClr val="000000"/>
                 </a:solidFill>
                 <a:latin typeface="Arial"/>
               </a:rPr>
-              <a:t>Track B: optimize conditions</a:t>
-            </a:r>
-          </a:p>
-          <a:p>
-            <a:pPr algn="l">
-              <a:spcAft>
-                <a:spcPts val="1200"/>
-              </a:spcAft>
-            </a:pPr>
-            <a:r>
-              <a:rPr sz="1300" b="0" i="1">
-                <a:solidFill>
-                  <a:srgbClr val="404040"/>
-                </a:solidFill>
-                <a:latin typeface="Arial"/>
-              </a:rPr>
-              <a:t>random-row cross-validation</a:t>
-            </a:r>
-          </a:p>
-          <a:p>
-            <a:pPr algn="l">
-              <a:spcAft>
-                <a:spcPts val="800"/>
-              </a:spcAft>
-            </a:pPr>
-            <a:r>
-              <a:rPr sz="1800" b="1" i="0">
+              <a:t>Uncertainty interval:  </a:t>
+            </a:r>
+            <a:r>
+              <a:rPr sz="1600" b="0">
                 <a:solidFill>
                   <a:srgbClr val="000000"/>
                 </a:solidFill>
                 <a:latin typeface="Arial"/>
               </a:rPr>
-              <a:t>R-squared 0.725     RMSE 0.823</a:t>
-            </a:r>
-          </a:p>
-          <a:p>
-            <a:pPr algn="l">
-              <a:spcAft>
-                <a:spcPts val="600"/>
-              </a:spcAft>
-            </a:pPr>
-            <a:r>
-              <a:rPr sz="1500" b="0" i="0">
+              <a:t>instead of a single number, the model returns a range of logD values for each prediction.</a:t>
+            </a:r>
+          </a:p>
+          <a:p>
+            <a:pPr algn="l">
+              <a:spcAft>
+                <a:spcPts val="1300"/>
+              </a:spcAft>
+            </a:pPr>
+            <a:r>
+              <a:rPr sz="1600" b="1">
                 <a:solidFill>
                   <a:srgbClr val="000000"/>
                 </a:solidFill>
                 <a:latin typeface="Arial"/>
               </a:rPr>
-              <a:t>Most confident 10 percent: R-squared 0.940, RMSE 0.341</a:t>
+              <a:t>90 percent interval:  </a:t>
+            </a:r>
+            <a:r>
+              <a:rPr sz="1600" b="0">
+                <a:solidFill>
+                  <a:srgbClr val="000000"/>
+                </a:solidFill>
+                <a:latin typeface="Arial"/>
+              </a:rPr>
+              <a:t>a range built to contain the true logD about 90 percent of the time. An 80 percent interval is narrower and contains it about 80 percent of the time.</a:t>
+            </a:r>
+          </a:p>
+          <a:p>
+            <a:pPr algn="l">
+              <a:spcAft>
+                <a:spcPts val="1300"/>
+              </a:spcAft>
+            </a:pPr>
+            <a:r>
+              <a:rPr sz="1600" b="1">
+                <a:solidFill>
+                  <a:srgbClr val="000000"/>
+                </a:solidFill>
+                <a:latin typeface="Arial"/>
+              </a:rPr>
+              <a:t>Coverage:  </a:t>
+            </a:r>
+            <a:r>
+              <a:rPr sz="1600" b="0">
+                <a:solidFill>
+                  <a:srgbClr val="000000"/>
+                </a:solidFill>
+                <a:latin typeface="Arial"/>
+              </a:rPr>
+              <a:t>the fraction of points whose true value actually lands inside the interval. We measured 0.89 to 0.90 against the 90 percent target, so the ranges are honest.</a:t>
             </a:r>
           </a:p>
         </p:txBody>
@@ -5996,7 +5892,7 @@
                 </a:solidFill>
                 <a:latin typeface="Arial"/>
               </a:rPr>
-              <a:t>Definitions</a:t>
+              <a:t>What a 90 percent interval means</a:t>
             </a:r>
           </a:p>
         </p:txBody>
@@ -6009,8 +5905,8 @@
         </p:nvSpPr>
         <p:spPr>
           <a:xfrm>
-            <a:off x="640080" y="1463040"/>
-            <a:ext cx="10972800" cy="4937760"/>
+            <a:off x="640080" y="1280160"/>
+            <a:ext cx="10972800" cy="1783080"/>
           </a:xfrm>
           <a:prstGeom prst="rect">
             <a:avLst/>
@@ -6025,130 +5921,61 @@
           <a:p>
             <a:pPr algn="l">
               <a:spcAft>
-                <a:spcPts val="1300"/>
-              </a:spcAft>
-            </a:pPr>
-            <a:r>
-              <a:rPr sz="1600" b="1">
+                <a:spcPts val="800"/>
+              </a:spcAft>
+            </a:pPr>
+            <a:r>
+              <a:rPr sz="1500" b="0" i="0">
                 <a:solidFill>
                   <a:srgbClr val="000000"/>
                 </a:solidFill>
                 <a:latin typeface="Arial"/>
               </a:rPr>
-              <a:t>Confidence score:  </a:t>
-            </a:r>
-            <a:r>
-              <a:rPr sz="1600" b="0">
+              <a:t>The model gives a range, not just a single number. For example, it might predict a logD of 1.5 and report that it is 90 percent sure the true value is between 0.6 and 2.4. Across many predictions, each with its own 90 percent range, the true value should land inside about 90 times out of 100, while an 80 percent range is narrower and contains it about 80 times out of 100.</a:t>
+            </a:r>
+          </a:p>
+          <a:p>
+            <a:pPr algn="l">
+              <a:spcAft>
+                <a:spcPts val="600"/>
+              </a:spcAft>
+            </a:pPr>
+            <a:r>
+              <a:rPr sz="1500" b="0" i="0">
                 <a:solidFill>
                   <a:srgbClr val="000000"/>
                 </a:solidFill>
                 <a:latin typeface="Arial"/>
               </a:rPr>
-              <a:t>a second model estimates how far off each prediction is likely to be, so a small estimated error means high confidence.</a:t>
-            </a:r>
-          </a:p>
-          <a:p>
-            <a:pPr algn="l">
-              <a:spcAft>
-                <a:spcPts val="1300"/>
-              </a:spcAft>
-            </a:pPr>
-            <a:r>
-              <a:rPr sz="1600" b="1">
-                <a:solidFill>
-                  <a:srgbClr val="000000"/>
-                </a:solidFill>
-                <a:latin typeface="Arial"/>
-              </a:rPr>
-              <a:t>Most confident 10 percent (or 25, or 50):  </a:t>
-            </a:r>
-            <a:r>
-              <a:rPr sz="1600" b="0">
-                <a:solidFill>
-                  <a:srgbClr val="000000"/>
-                </a:solidFill>
-                <a:latin typeface="Arial"/>
-              </a:rPr>
-              <a:t>the fraction of predictions with the smallest estimated error. Keeping only those gives much higher accuracy.</a:t>
-            </a:r>
-          </a:p>
-          <a:p>
-            <a:pPr algn="l">
-              <a:spcAft>
-                <a:spcPts val="1300"/>
-              </a:spcAft>
-            </a:pPr>
-            <a:r>
-              <a:rPr sz="1600" b="1">
-                <a:solidFill>
-                  <a:srgbClr val="000000"/>
-                </a:solidFill>
-                <a:latin typeface="Arial"/>
-              </a:rPr>
-              <a:t>Uncertainty interval:  </a:t>
-            </a:r>
-            <a:r>
-              <a:rPr sz="1600" b="0">
-                <a:solidFill>
-                  <a:srgbClr val="000000"/>
-                </a:solidFill>
-                <a:latin typeface="Arial"/>
-              </a:rPr>
-              <a:t>instead of a single number, the model returns a range of logD values for each prediction.</a:t>
-            </a:r>
-          </a:p>
-          <a:p>
-            <a:pPr algn="l">
-              <a:spcAft>
-                <a:spcPts val="1300"/>
-              </a:spcAft>
-            </a:pPr>
-            <a:r>
-              <a:rPr sz="1600" b="1">
-                <a:solidFill>
-                  <a:srgbClr val="000000"/>
-                </a:solidFill>
-                <a:latin typeface="Arial"/>
-              </a:rPr>
-              <a:t>90 percent interval:  </a:t>
-            </a:r>
-            <a:r>
-              <a:rPr sz="1600" b="0">
-                <a:solidFill>
-                  <a:srgbClr val="000000"/>
-                </a:solidFill>
-                <a:latin typeface="Arial"/>
-              </a:rPr>
-              <a:t>a range built to contain the true logD about 90 percent of the time. An 80 percent interval is narrower and contains it about 80 percent of the time.</a:t>
-            </a:r>
-          </a:p>
-          <a:p>
-            <a:pPr algn="l">
-              <a:spcAft>
-                <a:spcPts val="1300"/>
-              </a:spcAft>
-            </a:pPr>
-            <a:r>
-              <a:rPr sz="1600" b="1">
-                <a:solidFill>
-                  <a:srgbClr val="000000"/>
-                </a:solidFill>
-                <a:latin typeface="Arial"/>
-              </a:rPr>
-              <a:t>Coverage:  </a:t>
-            </a:r>
-            <a:r>
-              <a:rPr sz="1600" b="0">
-                <a:solidFill>
-                  <a:srgbClr val="000000"/>
-                </a:solidFill>
-                <a:latin typeface="Arial"/>
-              </a:rPr>
-              <a:t>the fraction of points whose true value actually lands inside the interval. We measured 0.89 to 0.90 against the 90 percent target, so the ranges are honest.</a:t>
-            </a:r>
-          </a:p>
-        </p:txBody>
-      </p:sp>
+              <a:t>Coverage is how often this actually happens. Checking every range against the real value, the true logD landed inside the 90 percent range 89 to 90 percent of the time, right on target, which is what it means to say the ranges are honest.</a:t>
+            </a:r>
+          </a:p>
+        </p:txBody>
+      </p:sp>
+      <p:pic>
+        <p:nvPicPr>
+          <p:cNvPr id="4" name="Picture 3" descr="coverage_illustration.png"/>
+          <p:cNvPicPr>
+            <a:picLocks noChangeAspect="1"/>
+          </p:cNvPicPr>
+          <p:nvPr/>
+        </p:nvPicPr>
+        <p:blipFill>
+          <a:blip r:embed="rId2"/>
+          <a:stretch>
+            <a:fillRect/>
+          </a:stretch>
+        </p:blipFill>
+        <p:spPr>
+          <a:xfrm>
+            <a:off x="3219269" y="3154680"/>
+            <a:ext cx="5753155" cy="3429000"/>
+          </a:xfrm>
+          <a:prstGeom prst="rect">
+            <a:avLst/>
+          </a:prstGeom>
+        </p:spPr>
+      </p:pic>
     </p:spTree>
   </p:cSld>
   <p:clrMapOvr>
@@ -6209,69 +6036,14 @@
                 </a:solidFill>
                 <a:latin typeface="Arial"/>
               </a:rPr>
-              <a:t>What a 90 percent interval means</a:t>
-            </a:r>
-          </a:p>
-        </p:txBody>
-      </p:sp>
-      <p:sp>
-        <p:nvSpPr>
-          <p:cNvPr id="3" name="TextBox 2"/>
-          <p:cNvSpPr txBox="1"/>
-          <p:nvPr/>
-        </p:nvSpPr>
-        <p:spPr>
-          <a:xfrm>
-            <a:off x="640080" y="1280160"/>
-            <a:ext cx="10972800" cy="1783080"/>
-          </a:xfrm>
-          <a:prstGeom prst="rect">
-            <a:avLst/>
-          </a:prstGeom>
-          <a:noFill/>
-        </p:spPr>
-        <p:txBody>
-          <a:bodyPr wrap="square" lIns="0" rIns="0" tIns="0" bIns="0">
-            <a:spAutoFit/>
-          </a:bodyPr>
-          <a:lstStyle/>
-          <a:p>
-            <a:pPr algn="l">
-              <a:spcAft>
-                <a:spcPts val="800"/>
-              </a:spcAft>
-            </a:pPr>
-            <a:r>
-              <a:rPr sz="1500" b="0" i="0">
-                <a:solidFill>
-                  <a:srgbClr val="000000"/>
-                </a:solidFill>
-                <a:latin typeface="Arial"/>
-              </a:rPr>
-              <a:t>The model gives a range, not just a single number. For example, it might predict a logD of 1.5 and report that it is 90 percent sure the true value is between 0.6 and 2.4. Across many predictions, each with its own 90 percent range, the true value should land inside about 90 times out of 100, while an 80 percent range is narrower and contains it about 80 times out of 100.</a:t>
-            </a:r>
-          </a:p>
-          <a:p>
-            <a:pPr algn="l">
-              <a:spcAft>
-                <a:spcPts val="600"/>
-              </a:spcAft>
-            </a:pPr>
-            <a:r>
-              <a:rPr sz="1500" b="0" i="0">
-                <a:solidFill>
-                  <a:srgbClr val="000000"/>
-                </a:solidFill>
-                <a:latin typeface="Arial"/>
-              </a:rPr>
-              <a:t>Coverage is how often this actually happens. Checking every range against the real value, the true logD landed inside the 90 percent range 89 to 90 percent of the time, right on target, which is what it means to say the ranges are honest.</a:t>
+              <a:t>Accuracy versus confidence, Track A</a:t>
             </a:r>
           </a:p>
         </p:txBody>
       </p:sp>
       <p:pic>
         <p:nvPicPr>
-          <p:cNvPr id="4" name="Picture 3" descr="coverage_illustration.png"/>
+          <p:cNvPr id="3" name="Picture 2" descr="confidence_curve_a.png"/>
           <p:cNvPicPr>
             <a:picLocks noChangeAspect="1"/>
           </p:cNvPicPr>
@@ -6285,14 +6057,53 @@
         </p:blipFill>
         <p:spPr>
           <a:xfrm>
-            <a:off x="3219269" y="3154680"/>
-            <a:ext cx="5753155" cy="3429000"/>
+            <a:off x="792327" y="1508760"/>
+            <a:ext cx="10607040" cy="3787693"/>
           </a:xfrm>
           <a:prstGeom prst="rect">
             <a:avLst/>
           </a:prstGeom>
         </p:spPr>
       </p:pic>
+      <p:sp>
+        <p:nvSpPr>
+          <p:cNvPr id="4" name="TextBox 3"/>
+          <p:cNvSpPr txBox="1"/>
+          <p:nvPr/>
+        </p:nvSpPr>
+        <p:spPr>
+          <a:xfrm>
+            <a:off x="640080" y="5442757"/>
+            <a:ext cx="10881360" cy="1005840"/>
+          </a:xfrm>
+          <a:prstGeom prst="rect">
+            <a:avLst/>
+          </a:prstGeom>
+          <a:noFill/>
+        </p:spPr>
+        <p:txBody>
+          <a:bodyPr wrap="square" lIns="0" rIns="0" tIns="0" bIns="0">
+            <a:spAutoFit/>
+          </a:bodyPr>
+          <a:lstStyle/>
+          <a:p>
+            <a:pPr algn="l">
+              <a:spcAft>
+                <a:spcPts val="600"/>
+              </a:spcAft>
+            </a:pPr>
+            <a:r>
+              <a:rPr sz="1300" b="0" i="1">
+                <a:solidFill>
+                  <a:srgbClr val="404040"/>
+                </a:solidFill>
+                <a:latin typeface="Arial"/>
+              </a:rPr>
+              <a:t>Moving right to left keeps fewer but more confident predictions. The most confident tenth (the tenth with the smallest estimated error) reaches R-squared 0.912 and RMSE 0.493, against 0.466 and 1.148 over all predictions.</a:t>
+            </a:r>
+          </a:p>
+        </p:txBody>
+      </p:sp>
     </p:spTree>
   </p:cSld>
   <p:clrMapOvr>
@@ -6353,14 +6164,14 @@
                 </a:solidFill>
                 <a:latin typeface="Arial"/>
               </a:rPr>
-              <a:t>Accuracy versus confidence, Track A</a:t>
+              <a:t>Accuracy versus confidence, Track B</a:t>
             </a:r>
           </a:p>
         </p:txBody>
       </p:sp>
       <p:pic>
         <p:nvPicPr>
-          <p:cNvPr id="3" name="Picture 2" descr="confidence_curve_a.png"/>
+          <p:cNvPr id="3" name="Picture 2" descr="confidence_curve_b.png"/>
           <p:cNvPicPr>
             <a:picLocks noChangeAspect="1"/>
           </p:cNvPicPr>
@@ -6416,7 +6227,7 @@
                 </a:solidFill>
                 <a:latin typeface="Arial"/>
               </a:rPr>
-              <a:t>Moving right to left keeps fewer but more confident predictions. The most confident tenth (the tenth with the smallest estimated error) reaches R-squared 0.912 and RMSE 0.493, against 0.466 and 1.148 over all predictions.</a:t>
+              <a:t>The same pattern holds for condition optimization: the most confident tenth reaches R-squared 0.940 and RMSE 0.341, against 0.725 and 0.823 over all predictions.</a:t>
             </a:r>
           </a:p>
         </p:txBody>
@@ -6481,14 +6292,14 @@
                 </a:solidFill>
                 <a:latin typeface="Arial"/>
               </a:rPr>
-              <a:t>Accuracy versus confidence, Track B</a:t>
+              <a:t>Predicted versus actual logD</a:t>
             </a:r>
           </a:p>
         </p:txBody>
       </p:sp>
       <p:pic>
         <p:nvPicPr>
-          <p:cNvPr id="3" name="Picture 2" descr="confidence_curve_b.png"/>
+          <p:cNvPr id="3" name="Picture 2" descr="pred_vs_actual_a.png"/>
           <p:cNvPicPr>
             <a:picLocks noChangeAspect="1"/>
           </p:cNvPicPr>
@@ -6502,23 +6313,47 @@
         </p:blipFill>
         <p:spPr>
           <a:xfrm>
-            <a:off x="792327" y="1508760"/>
-            <a:ext cx="10607040" cy="3787693"/>
+            <a:off x="1097280" y="1600200"/>
+            <a:ext cx="4722725" cy="4297680"/>
           </a:xfrm>
           <a:prstGeom prst="rect">
             <a:avLst/>
           </a:prstGeom>
         </p:spPr>
       </p:pic>
-      <p:sp>
-        <p:nvSpPr>
-          <p:cNvPr id="4" name="TextBox 3"/>
+      <p:pic>
+        <p:nvPicPr>
+          <p:cNvPr id="4" name="Picture 3" descr="pred_vs_actual_b.png"/>
+          <p:cNvPicPr>
+            <a:picLocks noChangeAspect="1"/>
+          </p:cNvPicPr>
+          <p:nvPr/>
+        </p:nvPicPr>
+        <p:blipFill>
+          <a:blip r:embed="rId3"/>
+          <a:stretch>
+            <a:fillRect/>
+          </a:stretch>
+        </p:blipFill>
+        <p:spPr>
+          <a:xfrm>
+            <a:off x="6309360" y="1600200"/>
+            <a:ext cx="4796939" cy="4297680"/>
+          </a:xfrm>
+          <a:prstGeom prst="rect">
+            <a:avLst/>
+          </a:prstGeom>
+        </p:spPr>
+      </p:pic>
+      <p:sp>
+        <p:nvSpPr>
+          <p:cNvPr id="5" name="TextBox 4"/>
           <p:cNvSpPr txBox="1"/>
           <p:nvPr/>
         </p:nvSpPr>
         <p:spPr>
           <a:xfrm>
-            <a:off x="640080" y="5442757"/>
+            <a:off x="640080" y="6080760"/>
             <a:ext cx="10881360" cy="1005840"/>
           </a:xfrm>
           <a:prstGeom prst="rect">
@@ -6544,7 +6379,7 @@
                 </a:solidFill>
                 <a:latin typeface="Arial"/>
               </a:rPr>
-              <a:t>The same pattern holds for condition optimization: the most confident tenth reaches R-squared 0.940 and RMSE 0.341, against 0.725 and 0.823 over all predictions.</a:t>
+              <a:t>Left: Track A, new molecules. Right: Track B, known molecules. Each point is a prediction; darker points are the more confident ones and lie closer to the diagonal, where predicted equals actual.</a:t>
             </a:r>
           </a:p>
         </p:txBody>
@@ -6609,14 +6444,14 @@
                 </a:solidFill>
                 <a:latin typeface="Arial"/>
               </a:rPr>
-              <a:t>Predicted versus actual logD</a:t>
+              <a:t>Accuracy by metal</a:t>
             </a:r>
           </a:p>
         </p:txBody>
       </p:sp>
       <p:pic>
         <p:nvPicPr>
-          <p:cNvPr id="3" name="Picture 2" descr="pred_vs_actual_a.png"/>
+          <p:cNvPr id="3" name="Picture 2" descr="by_metal_accuracy.png"/>
           <p:cNvPicPr>
             <a:picLocks noChangeAspect="1"/>
           </p:cNvPicPr>
@@ -6630,47 +6465,23 @@
         </p:blipFill>
         <p:spPr>
           <a:xfrm>
-            <a:off x="1097280" y="1600200"/>
-            <a:ext cx="4722725" cy="4297680"/>
+            <a:off x="1270309" y="1508760"/>
+            <a:ext cx="9651076" cy="4114800"/>
           </a:xfrm>
           <a:prstGeom prst="rect">
             <a:avLst/>
           </a:prstGeom>
         </p:spPr>
       </p:pic>
-      <p:pic>
-        <p:nvPicPr>
-          <p:cNvPr id="4" name="Picture 3" descr="pred_vs_actual_b.png"/>
-          <p:cNvPicPr>
-            <a:picLocks noChangeAspect="1"/>
-          </p:cNvPicPr>
-          <p:nvPr/>
-        </p:nvPicPr>
-        <p:blipFill>
-          <a:blip r:embed="rId3"/>
-          <a:stretch>
-            <a:fillRect/>
-          </a:stretch>
-        </p:blipFill>
-        <p:spPr>
-          <a:xfrm>
-            <a:off x="6309360" y="1600200"/>
-            <a:ext cx="4796939" cy="4297680"/>
-          </a:xfrm>
-          <a:prstGeom prst="rect">
-            <a:avLst/>
-          </a:prstGeom>
-        </p:spPr>
-      </p:pic>
-      <p:sp>
-        <p:nvSpPr>
-          <p:cNvPr id="5" name="TextBox 4"/>
+      <p:sp>
+        <p:nvSpPr>
+          <p:cNvPr id="4" name="TextBox 3"/>
           <p:cNvSpPr txBox="1"/>
           <p:nvPr/>
         </p:nvSpPr>
         <p:spPr>
           <a:xfrm>
-            <a:off x="640080" y="6080760"/>
+            <a:off x="640080" y="5769864"/>
             <a:ext cx="10881360" cy="1005840"/>
           </a:xfrm>
           <a:prstGeom prst="rect">
@@ -6696,7 +6507,7 @@
                 </a:solidFill>
                 <a:latin typeface="Arial"/>
               </a:rPr>
-              <a:t>Left: Track A, new molecules. Right: Track B, known molecules. Each point is a prediction; darker points are the more confident ones and lie closer to the diagonal, where predicted equals actual.</a:t>
+              <a:t>Accuracy is not uniform. It is highest on Americium and Curium and lowest on Neptunium(V), Erbium, and Uranium(VI), so a single overall number hides large differences between metals.</a:t>
             </a:r>
           </a:p>
         </p:txBody>

</xml_diff>

<commit_message>
Append dataset-features and ECM slides to the deck; original 21 slides unchanged
Co-Authored-By: Claude Opus 4.8 <noreply@anthropic.com>
</commit_message>
<xml_diff>
--- a/docs/REE_Results_Slides_Final.pptx
+++ b/docs/REE_Results_Slides_Final.pptx
@@ -26,6 +26,9 @@
     <p:sldId id="274" r:id="rId25"/>
     <p:sldId id="275" r:id="rId26"/>
     <p:sldId id="276" r:id="rId27"/>
+    <p:sldId id="277" r:id="rId28"/>
+    <p:sldId id="278" r:id="rId29"/>
+    <p:sldId id="279" r:id="rId30"/>
   </p:sldIdLst>
   <p:sldSz cx="12191695" cy="6858000" type="screen4x3"/>
   <p:notesSz cx="6858000" cy="9144000"/>
@@ -5337,6 +5340,485 @@
                 <a:latin typeface="Arial"/>
               </a:rPr>
               <a:t>Next steps: a direct separation-factor model and replicate averaging to push past the current ceilings.</a:t>
+            </a:r>
+          </a:p>
+        </p:txBody>
+      </p:sp>
+    </p:spTree>
+  </p:cSld>
+  <p:clrMapOvr>
+    <a:masterClrMapping/>
+  </p:clrMapOvr>
+</p:sld>
+</file>
+
+<file path=ppt/slides/slide22.xml><?xml version="1.0" encoding="utf-8"?>
+<p:sld xmlns:a="http://schemas.openxmlformats.org/drawingml/2006/main" xmlns:p="http://schemas.openxmlformats.org/presentationml/2006/main" xmlns:r="http://schemas.openxmlformats.org/officeDocument/2006/relationships">
+  <p:cSld>
+    <p:bg>
+      <p:bgPr>
+        <a:solidFill>
+          <a:srgbClr val="FFFFFF"/>
+        </a:solidFill>
+        <a:effectLst/>
+      </p:bgPr>
+    </p:bg>
+    <p:spTree>
+      <p:nvGrpSpPr>
+        <p:cNvPr id="1" name=""/>
+        <p:cNvGrpSpPr/>
+        <p:nvPr/>
+      </p:nvGrpSpPr>
+      <p:grpSpPr/>
+      <p:sp>
+        <p:nvSpPr>
+          <p:cNvPr id="2" name="TextBox 1"/>
+          <p:cNvSpPr txBox="1"/>
+          <p:nvPr/>
+        </p:nvSpPr>
+        <p:spPr>
+          <a:xfrm>
+            <a:off x="640080" y="457200"/>
+            <a:ext cx="10972800" cy="914400"/>
+          </a:xfrm>
+          <a:prstGeom prst="rect">
+            <a:avLst/>
+          </a:prstGeom>
+          <a:noFill/>
+        </p:spPr>
+        <p:txBody>
+          <a:bodyPr wrap="square" lIns="0" rIns="0" tIns="0" bIns="0">
+            <a:spAutoFit/>
+          </a:bodyPr>
+          <a:lstStyle/>
+          <a:p>
+            <a:pPr algn="l">
+              <a:spcAft>
+                <a:spcPts val="600"/>
+              </a:spcAft>
+            </a:pPr>
+            <a:r>
+              <a:rPr sz="2900" b="1" i="0">
+                <a:solidFill>
+                  <a:srgbClr val="000000"/>
+                </a:solidFill>
+                <a:latin typeface="Arial"/>
+              </a:rPr>
+              <a:t>Dataset features and why</a:t>
+            </a:r>
+          </a:p>
+        </p:txBody>
+      </p:sp>
+      <p:sp>
+        <p:nvSpPr>
+          <p:cNvPr id="3" name="TextBox 2"/>
+          <p:cNvSpPr txBox="1"/>
+          <p:nvPr/>
+        </p:nvSpPr>
+        <p:spPr>
+          <a:xfrm>
+            <a:off x="640080" y="1463040"/>
+            <a:ext cx="10972800" cy="4937760"/>
+          </a:xfrm>
+          <a:prstGeom prst="rect">
+            <a:avLst/>
+          </a:prstGeom>
+          <a:noFill/>
+        </p:spPr>
+        <p:txBody>
+          <a:bodyPr wrap="square" lIns="0" rIns="0" tIns="0" bIns="0">
+            <a:spAutoFit/>
+          </a:bodyPr>
+          <a:lstStyle/>
+          <a:p>
+            <a:pPr algn="l">
+              <a:spcAft>
+                <a:spcPts val="1400"/>
+              </a:spcAft>
+            </a:pPr>
+            <a:r>
+              <a:rPr sz="1500" b="1">
+                <a:solidFill>
+                  <a:srgbClr val="000000"/>
+                </a:solidFill>
+                <a:latin typeface="Arial"/>
+              </a:rPr>
+              <a:t>Extractant structure:  </a:t>
+            </a:r>
+            <a:r>
+              <a:rPr sz="1500" b="0">
+                <a:solidFill>
+                  <a:srgbClr val="000000"/>
+                </a:solidFill>
+                <a:latin typeface="Arial"/>
+              </a:rPr>
+              <a:t>SMILES, a Morgan fingerprint, RDKit descriptors, and donor-atom counts (O, N, S, P) with logP. These set how, and how strongly, the extractant binds a metal.</a:t>
+            </a:r>
+          </a:p>
+          <a:p>
+            <a:pPr algn="l">
+              <a:spcAft>
+                <a:spcPts val="1400"/>
+              </a:spcAft>
+            </a:pPr>
+            <a:r>
+              <a:rPr sz="1500" b="1">
+                <a:solidFill>
+                  <a:srgbClr val="000000"/>
+                </a:solidFill>
+                <a:latin typeface="Arial"/>
+              </a:rPr>
+              <a:t>Metal descriptors:  </a:t>
+            </a:r>
+            <a:r>
+              <a:rPr sz="1500" b="0">
+                <a:solidFill>
+                  <a:srgbClr val="000000"/>
+                </a:solidFill>
+                <a:latin typeface="Arial"/>
+              </a:rPr>
+              <a:t>ionic radius, charge and oxidation state, ionization energies, electronegativity, and atomic number. These carry the lanthanide-contraction trend that makes neighboring rare earths hard to separate.</a:t>
+            </a:r>
+          </a:p>
+          <a:p>
+            <a:pPr algn="l">
+              <a:spcAft>
+                <a:spcPts val="1400"/>
+              </a:spcAft>
+            </a:pPr>
+            <a:r>
+              <a:rPr sz="1500" b="1">
+                <a:solidFill>
+                  <a:srgbClr val="000000"/>
+                </a:solidFill>
+                <a:latin typeface="Arial"/>
+              </a:rPr>
+              <a:t>Acid and conditions:  </a:t>
+            </a:r>
+            <a:r>
+              <a:rPr sz="1500" b="0">
+                <a:solidFill>
+                  <a:srgbClr val="000000"/>
+                </a:solidFill>
+                <a:latin typeface="Arial"/>
+              </a:rPr>
+              <a:t>acid type and concentration, temperature, and extractant concentration. logD is an equilibrium, so it shifts with these as much as with the molecule.</a:t>
+            </a:r>
+          </a:p>
+          <a:p>
+            <a:pPr algn="l">
+              <a:spcAft>
+                <a:spcPts val="1400"/>
+              </a:spcAft>
+            </a:pPr>
+            <a:r>
+              <a:rPr sz="1500" b="1">
+                <a:solidFill>
+                  <a:srgbClr val="000000"/>
+                </a:solidFill>
+                <a:latin typeface="Arial"/>
+              </a:rPr>
+              <a:t>Diluent (solvent):  </a:t>
+            </a:r>
+            <a:r>
+              <a:rPr sz="1500" b="0">
+                <a:solidFill>
+                  <a:srgbClr val="000000"/>
+                </a:solidFill>
+                <a:latin typeface="Arial"/>
+              </a:rPr>
+              <a:t>molar mass, logP, boiling and melting points, density, solubility, and dipole moment. The diluent sets the organic-phase environment around the extractant.</a:t>
+            </a:r>
+          </a:p>
+        </p:txBody>
+      </p:sp>
+    </p:spTree>
+  </p:cSld>
+  <p:clrMapOvr>
+    <a:masterClrMapping/>
+  </p:clrMapOvr>
+</p:sld>
+</file>
+
+<file path=ppt/slides/slide23.xml><?xml version="1.0" encoding="utf-8"?>
+<p:sld xmlns:a="http://schemas.openxmlformats.org/drawingml/2006/main" xmlns:p="http://schemas.openxmlformats.org/presentationml/2006/main" xmlns:r="http://schemas.openxmlformats.org/officeDocument/2006/relationships">
+  <p:cSld>
+    <p:bg>
+      <p:bgPr>
+        <a:solidFill>
+          <a:srgbClr val="FFFFFF"/>
+        </a:solidFill>
+        <a:effectLst/>
+      </p:bgPr>
+    </p:bg>
+    <p:spTree>
+      <p:nvGrpSpPr>
+        <p:cNvPr id="1" name=""/>
+        <p:cNvGrpSpPr/>
+        <p:nvPr/>
+      </p:nvGrpSpPr>
+      <p:grpSpPr/>
+      <p:sp>
+        <p:nvSpPr>
+          <p:cNvPr id="2" name="TextBox 1"/>
+          <p:cNvSpPr txBox="1"/>
+          <p:nvPr/>
+        </p:nvSpPr>
+        <p:spPr>
+          <a:xfrm>
+            <a:off x="640080" y="457200"/>
+            <a:ext cx="10972800" cy="914400"/>
+          </a:xfrm>
+          <a:prstGeom prst="rect">
+            <a:avLst/>
+          </a:prstGeom>
+          <a:noFill/>
+        </p:spPr>
+        <p:txBody>
+          <a:bodyPr wrap="square" lIns="0" rIns="0" tIns="0" bIns="0">
+            <a:spAutoFit/>
+          </a:bodyPr>
+          <a:lstStyle/>
+          <a:p>
+            <a:pPr algn="l">
+              <a:spcAft>
+                <a:spcPts val="600"/>
+              </a:spcAft>
+            </a:pPr>
+            <a:r>
+              <a:rPr sz="2900" b="1" i="0">
+                <a:solidFill>
+                  <a:srgbClr val="000000"/>
+                </a:solidFill>
+                <a:latin typeface="Arial"/>
+              </a:rPr>
+              <a:t>ECM: predicting the free energy of extraction</a:t>
+            </a:r>
+          </a:p>
+        </p:txBody>
+      </p:sp>
+      <p:sp>
+        <p:nvSpPr>
+          <p:cNvPr id="3" name="TextBox 2"/>
+          <p:cNvSpPr txBox="1"/>
+          <p:nvPr/>
+        </p:nvSpPr>
+        <p:spPr>
+          <a:xfrm>
+            <a:off x="640080" y="1463040"/>
+            <a:ext cx="10972800" cy="4937760"/>
+          </a:xfrm>
+          <a:prstGeom prst="rect">
+            <a:avLst/>
+          </a:prstGeom>
+          <a:noFill/>
+        </p:spPr>
+        <p:txBody>
+          <a:bodyPr wrap="square" lIns="0" rIns="0" tIns="0" bIns="0">
+            <a:spAutoFit/>
+          </a:bodyPr>
+          <a:lstStyle/>
+          <a:p>
+            <a:pPr algn="l">
+              <a:spcAft>
+                <a:spcPts val="1600"/>
+              </a:spcAft>
+            </a:pPr>
+            <a:r>
+              <a:rPr sz="1500" b="1">
+                <a:solidFill>
+                  <a:srgbClr val="000000"/>
+                </a:solidFill>
+                <a:latin typeface="Arial"/>
+              </a:rPr>
+              <a:t>Target:  </a:t>
+            </a:r>
+            <a:r>
+              <a:rPr sz="1500" b="0">
+                <a:solidFill>
+                  <a:srgbClr val="000000"/>
+                </a:solidFill>
+                <a:latin typeface="Arial"/>
+              </a:rPr>
+              <a:t>delta G = -2.303 R T logD, in kJ/mol, so a favorable extraction is a negative, spontaneous free energy. Predicted from the extractant structure and the metal, with the reaction conditions left out.</a:t>
+            </a:r>
+          </a:p>
+          <a:p>
+            <a:pPr algn="l">
+              <a:spcAft>
+                <a:spcPts val="1600"/>
+              </a:spcAft>
+            </a:pPr>
+            <a:r>
+              <a:rPr sz="1500" b="1">
+                <a:solidFill>
+                  <a:srgbClr val="000000"/>
+                </a:solidFill>
+                <a:latin typeface="Arial"/>
+              </a:rPr>
+              <a:t>Why drop the conditions:  </a:t>
+            </a:r>
+            <a:r>
+              <a:rPr sz="1500" b="0">
+                <a:solidFill>
+                  <a:srgbClr val="000000"/>
+                </a:solidFill>
+                <a:latin typeface="Arial"/>
+              </a:rPr>
+              <a:t>the free energy is meant to be a property of the extractant and the metal, not of the acid concentration or temperature, so the model predicts the thermodynamics from structure alone.</a:t>
+            </a:r>
+          </a:p>
+          <a:p>
+            <a:pPr algn="l">
+              <a:spcAft>
+                <a:spcPts val="1600"/>
+              </a:spcAft>
+            </a:pPr>
+            <a:r>
+              <a:rPr sz="1500" b="1">
+                <a:solidFill>
+                  <a:srgbClr val="000000"/>
+                </a:solidFill>
+                <a:latin typeface="Arial"/>
+              </a:rPr>
+              <a:t>Two framings:  </a:t>
+            </a:r>
+            <a:r>
+              <a:rPr sz="1500" b="0">
+                <a:solidFill>
+                  <a:srgbClr val="000000"/>
+                </a:solidFill>
+                <a:latin typeface="Arial"/>
+              </a:rPr>
+              <a:t>per-row keeps every measurement; per-pair averages delta G to one value per extractant, metal, acid, and diluent system and is condition-independent, which is the cleaner target.</a:t>
+            </a:r>
+          </a:p>
+        </p:txBody>
+      </p:sp>
+    </p:spTree>
+  </p:cSld>
+  <p:clrMapOvr>
+    <a:masterClrMapping/>
+  </p:clrMapOvr>
+</p:sld>
+</file>
+
+<file path=ppt/slides/slide24.xml><?xml version="1.0" encoding="utf-8"?>
+<p:sld xmlns:a="http://schemas.openxmlformats.org/drawingml/2006/main" xmlns:p="http://schemas.openxmlformats.org/presentationml/2006/main" xmlns:r="http://schemas.openxmlformats.org/officeDocument/2006/relationships">
+  <p:cSld>
+    <p:bg>
+      <p:bgPr>
+        <a:solidFill>
+          <a:srgbClr val="FFFFFF"/>
+        </a:solidFill>
+        <a:effectLst/>
+      </p:bgPr>
+    </p:bg>
+    <p:spTree>
+      <p:nvGrpSpPr>
+        <p:cNvPr id="1" name=""/>
+        <p:cNvGrpSpPr/>
+        <p:nvPr/>
+      </p:nvGrpSpPr>
+      <p:grpSpPr/>
+      <p:sp>
+        <p:nvSpPr>
+          <p:cNvPr id="2" name="TextBox 1"/>
+          <p:cNvSpPr txBox="1"/>
+          <p:nvPr/>
+        </p:nvSpPr>
+        <p:spPr>
+          <a:xfrm>
+            <a:off x="640080" y="457200"/>
+            <a:ext cx="10972800" cy="914400"/>
+          </a:xfrm>
+          <a:prstGeom prst="rect">
+            <a:avLst/>
+          </a:prstGeom>
+          <a:noFill/>
+        </p:spPr>
+        <p:txBody>
+          <a:bodyPr wrap="square" lIns="0" rIns="0" tIns="0" bIns="0">
+            <a:spAutoFit/>
+          </a:bodyPr>
+          <a:lstStyle/>
+          <a:p>
+            <a:pPr algn="l">
+              <a:spcAft>
+                <a:spcPts val="600"/>
+              </a:spcAft>
+            </a:pPr>
+            <a:r>
+              <a:rPr sz="2900" b="1" i="0">
+                <a:solidFill>
+                  <a:srgbClr val="000000"/>
+                </a:solidFill>
+                <a:latin typeface="Arial"/>
+              </a:rPr>
+              <a:t>ECM results</a:t>
+            </a:r>
+          </a:p>
+        </p:txBody>
+      </p:sp>
+      <p:pic>
+        <p:nvPicPr>
+          <p:cNvPr id="3" name="Picture 2" descr="ecm.png"/>
+          <p:cNvPicPr>
+            <a:picLocks noChangeAspect="1"/>
+          </p:cNvPicPr>
+          <p:nvPr/>
+        </p:nvPicPr>
+        <p:blipFill>
+          <a:blip r:embed="rId2"/>
+          <a:stretch>
+            <a:fillRect/>
+          </a:stretch>
+        </p:blipFill>
+        <p:spPr>
+          <a:xfrm>
+            <a:off x="889775" y="1554480"/>
+            <a:ext cx="10412144" cy="3931920"/>
+          </a:xfrm>
+          <a:prstGeom prst="rect">
+            <a:avLst/>
+          </a:prstGeom>
+        </p:spPr>
+      </p:pic>
+      <p:sp>
+        <p:nvSpPr>
+          <p:cNvPr id="4" name="TextBox 3"/>
+          <p:cNvSpPr txBox="1"/>
+          <p:nvPr/>
+        </p:nvSpPr>
+        <p:spPr>
+          <a:xfrm>
+            <a:off x="640080" y="5650992"/>
+            <a:ext cx="10881360" cy="1005840"/>
+          </a:xfrm>
+          <a:prstGeom prst="rect">
+            <a:avLst/>
+          </a:prstGeom>
+          <a:noFill/>
+        </p:spPr>
+        <p:txBody>
+          <a:bodyPr wrap="square" lIns="0" rIns="0" tIns="0" bIns="0">
+            <a:spAutoFit/>
+          </a:bodyPr>
+          <a:lstStyle/>
+          <a:p>
+            <a:pPr algn="l">
+              <a:spcAft>
+                <a:spcPts val="600"/>
+              </a:spcAft>
+            </a:pPr>
+            <a:r>
+              <a:rPr sz="1300" b="0" i="1">
+                <a:solidFill>
+                  <a:srgbClr val="404040"/>
+                </a:solidFill>
+                <a:latin typeface="Arial"/>
+              </a:rPr>
+              <a:t>Per-pair is the better target (R-squared 0.42, RMSE 6.6 kJ/mol) than per-row (0.27), evaluated with molecule-grouped cross-validation so the extractants are new. Confidence is strong: the most confident quarter reach R-squared 0.68 and the top tenth 0.81 (RMSE 3.2 kJ/mol).</a:t>
             </a:r>
           </a:p>
         </p:txBody>

</xml_diff>

<commit_message>
ECM ensemble sweep: RandomForest is best (R2 0.473), stack only ties; switch ECM to RandomForest, add sweep sheet and slide, update docs
Co-Authored-By: Claude Opus 4.8 <noreply@anthropic.com>
</commit_message>
<xml_diff>
--- a/docs/REE_Results_Slides_Final.pptx
+++ b/docs/REE_Results_Slides_Final.pptx
@@ -29,6 +29,7 @@
     <p:sldId id="277" r:id="rId28"/>
     <p:sldId id="278" r:id="rId29"/>
     <p:sldId id="279" r:id="rId30"/>
+    <p:sldId id="280" r:id="rId31"/>
   </p:sldIdLst>
   <p:sldSz cx="12191695" cy="6858000" type="screen4x3"/>
   <p:notesSz cx="6858000" cy="9144000"/>
@@ -5818,7 +5819,170 @@
                 </a:solidFill>
                 <a:latin typeface="Arial"/>
               </a:rPr>
-              <a:t>Per-pair is the better target (R-squared 0.42, RMSE 6.6 kJ/mol) than per-row (0.27), evaluated with molecule-grouped cross-validation so the extractants are new. Confidence is strong: the most confident quarter reach R-squared 0.68 and the top tenth 0.81 (RMSE 3.2 kJ/mol).</a:t>
+              <a:t>Per-pair is the better target (R-squared 0.47, RMSE 6.3 kJ/mol) than per-row (0.28), evaluated with molecule-grouped cross-validation so the extractants are new. Confidence is strong: the most confident quarter reach R-squared 0.68 and the top tenth 0.78 (RMSE 3.6 kJ/mol).</a:t>
+            </a:r>
+          </a:p>
+        </p:txBody>
+      </p:sp>
+    </p:spTree>
+  </p:cSld>
+  <p:clrMapOvr>
+    <a:masterClrMapping/>
+  </p:clrMapOvr>
+</p:sld>
+</file>
+
+<file path=ppt/slides/slide25.xml><?xml version="1.0" encoding="utf-8"?>
+<p:sld xmlns:a="http://schemas.openxmlformats.org/drawingml/2006/main" xmlns:p="http://schemas.openxmlformats.org/presentationml/2006/main" xmlns:r="http://schemas.openxmlformats.org/officeDocument/2006/relationships">
+  <p:cSld>
+    <p:bg>
+      <p:bgPr>
+        <a:solidFill>
+          <a:srgbClr val="FFFFFF"/>
+        </a:solidFill>
+        <a:effectLst/>
+      </p:bgPr>
+    </p:bg>
+    <p:spTree>
+      <p:nvGrpSpPr>
+        <p:cNvPr id="1" name=""/>
+        <p:cNvGrpSpPr/>
+        <p:nvPr/>
+      </p:nvGrpSpPr>
+      <p:grpSpPr/>
+      <p:sp>
+        <p:nvSpPr>
+          <p:cNvPr id="2" name="TextBox 1"/>
+          <p:cNvSpPr txBox="1"/>
+          <p:nvPr/>
+        </p:nvSpPr>
+        <p:spPr>
+          <a:xfrm>
+            <a:off x="640080" y="457200"/>
+            <a:ext cx="10972800" cy="914400"/>
+          </a:xfrm>
+          <a:prstGeom prst="rect">
+            <a:avLst/>
+          </a:prstGeom>
+          <a:noFill/>
+        </p:spPr>
+        <p:txBody>
+          <a:bodyPr wrap="square" lIns="0" rIns="0" tIns="0" bIns="0">
+            <a:spAutoFit/>
+          </a:bodyPr>
+          <a:lstStyle/>
+          <a:p>
+            <a:pPr algn="l">
+              <a:spcAft>
+                <a:spcPts val="600"/>
+              </a:spcAft>
+            </a:pPr>
+            <a:r>
+              <a:rPr sz="2900" b="1" i="0">
+                <a:solidFill>
+                  <a:srgbClr val="000000"/>
+                </a:solidFill>
+                <a:latin typeface="Arial"/>
+              </a:rPr>
+              <a:t>ECM ensemble sweep</a:t>
+            </a:r>
+          </a:p>
+        </p:txBody>
+      </p:sp>
+      <p:sp>
+        <p:nvSpPr>
+          <p:cNvPr id="3" name="TextBox 2"/>
+          <p:cNvSpPr txBox="1"/>
+          <p:nvPr/>
+        </p:nvSpPr>
+        <p:spPr>
+          <a:xfrm>
+            <a:off x="640080" y="1463040"/>
+            <a:ext cx="10972800" cy="4937760"/>
+          </a:xfrm>
+          <a:prstGeom prst="rect">
+            <a:avLst/>
+          </a:prstGeom>
+          <a:noFill/>
+        </p:spPr>
+        <p:txBody>
+          <a:bodyPr wrap="square" lIns="0" rIns="0" tIns="0" bIns="0">
+            <a:spAutoFit/>
+          </a:bodyPr>
+          <a:lstStyle/>
+          <a:p>
+            <a:pPr algn="l">
+              <a:spcAft>
+                <a:spcPts val="1600"/>
+              </a:spcAft>
+            </a:pPr>
+            <a:r>
+              <a:rPr sz="1500" b="1">
+                <a:solidFill>
+                  <a:srgbClr val="000000"/>
+                </a:solidFill>
+                <a:latin typeface="Arial"/>
+              </a:rPr>
+              <a:t>Best model:  </a:t>
+            </a:r>
+            <a:r>
+              <a:rPr sz="1500" b="0">
+                <a:solidFill>
+                  <a:srgbClr val="000000"/>
+                </a:solidFill>
+                <a:latin typeface="Arial"/>
+              </a:rPr>
+              <a:t>RandomForest, R-squared 0.473 (RMSE 6.31 kJ/mol) for the per-pair free energy. The bagged-tree models beat the gradient boosters on this small, wide table of 2,273 systems.</a:t>
+            </a:r>
+          </a:p>
+          <a:p>
+            <a:pPr algn="l">
+              <a:spcAft>
+                <a:spcPts val="1600"/>
+              </a:spcAft>
+            </a:pPr>
+            <a:r>
+              <a:rPr sz="1500" b="1">
+                <a:solidFill>
+                  <a:srgbClr val="000000"/>
+                </a:solidFill>
+                <a:latin typeface="Arial"/>
+              </a:rPr>
+              <a:t>The field:  </a:t>
+            </a:r>
+            <a:r>
+              <a:rPr sz="1500" b="0">
+                <a:solidFill>
+                  <a:srgbClr val="000000"/>
+                </a:solidFill>
+                <a:latin typeface="Arial"/>
+              </a:rPr>
+              <a:t>XGBoost 0.444, CatBoost 0.441, HistGB 0.426, LightGBM 0.424, ExtraTrees 0.419, and a linear Ridge near zero, so the signal is nonlinear.</a:t>
+            </a:r>
+          </a:p>
+          <a:p>
+            <a:pPr algn="l">
+              <a:spcAft>
+                <a:spcPts val="1600"/>
+              </a:spcAft>
+            </a:pPr>
+            <a:r>
+              <a:rPr sz="1500" b="1">
+                <a:solidFill>
+                  <a:srgbClr val="000000"/>
+                </a:solidFill>
+                <a:latin typeface="Arial"/>
+              </a:rPr>
+              <a:t>Stacking:  </a:t>
+            </a:r>
+            <a:r>
+              <a:rPr sz="1500" b="0">
+                <a:solidFill>
+                  <a:srgbClr val="000000"/>
+                </a:solidFill>
+                <a:latin typeface="Arial"/>
+              </a:rPr>
+              <a:t>an NNLS stack, scored with its own cross-validation, reaches 0.474, a tie with RandomForest alone, so stacking is not used and the ECM is a plain RandomForest.</a:t>
             </a:r>
           </a:p>
         </p:txBody>

</xml_diff>

<commit_message>
Rename ECM to the free-energy (delta G) model everywhere
Drop the undefined ECM label across scripts (ecm*.py -> dg_*.py), result
CSVs, the figure, the workbook sheets, the README section, and the slides.
The free-energy model feeds the UCB screening. Re-ran the model and ensemble
scripts to confirm identical numbers (per-pair R2 0.473, RMSE 6.31 kJ/mol).

Co-Authored-By: Claude Opus 4.8 <noreply@anthropic.com>
</commit_message>
<xml_diff>
--- a/docs/REE_Results_Slides_Final.pptx
+++ b/docs/REE_Results_Slides_Final.pptx
@@ -5593,7 +5593,7 @@
                 </a:solidFill>
                 <a:latin typeface="Arial"/>
               </a:rPr>
-              <a:t>ECM: predicting the free energy of extraction</a:t>
+              <a:t>Predicting the free energy of extraction</a:t>
             </a:r>
           </a:p>
         </p:txBody>
@@ -5756,14 +5756,14 @@
                 </a:solidFill>
                 <a:latin typeface="Arial"/>
               </a:rPr>
-              <a:t>ECM results</a:t>
+              <a:t>Free energy (delta G) results</a:t>
             </a:r>
           </a:p>
         </p:txBody>
       </p:sp>
       <p:pic>
         <p:nvPicPr>
-          <p:cNvPr id="3" name="Picture 2" descr="ecm.png"/>
+          <p:cNvPr id="3" name="Picture 2" descr="dg.png"/>
           <p:cNvPicPr>
             <a:picLocks noChangeAspect="1"/>
           </p:cNvPicPr>
@@ -5884,7 +5884,7 @@
                 </a:solidFill>
                 <a:latin typeface="Arial"/>
               </a:rPr>
-              <a:t>ECM ensemble sweep</a:t>
+              <a:t>Delta G ensemble sweep</a:t>
             </a:r>
           </a:p>
         </p:txBody>
@@ -5982,7 +5982,7 @@
                 </a:solidFill>
                 <a:latin typeface="Arial"/>
               </a:rPr>
-              <a:t>an NNLS stack, scored with its own cross-validation, reaches 0.474, a tie with RandomForest alone, so stacking is not used and the ECM is a plain RandomForest.</a:t>
+              <a:t>an NNLS stack, scored with its own cross-validation, reaches 0.474, a tie with RandomForest alone, so stacking is not used and the free-energy model is a plain RandomForest.</a:t>
             </a:r>
           </a:p>
         </p:txBody>

</xml_diff>

<commit_message>
Add UCB graphs figure and a UCB results slide to the deck
Co-Authored-By: Claude Opus 4.8 <noreply@anthropic.com>
</commit_message>
<xml_diff>
--- a/docs/REE_Results_Slides_Final.pptx
+++ b/docs/REE_Results_Slides_Final.pptx
@@ -30,6 +30,7 @@
     <p:sldId id="278" r:id="rId29"/>
     <p:sldId id="279" r:id="rId30"/>
     <p:sldId id="280" r:id="rId31"/>
+    <p:sldId id="281" r:id="rId32"/>
   </p:sldIdLst>
   <p:sldSz cx="12191695" cy="6858000" type="screen4x3"/>
   <p:notesSz cx="6858000" cy="9144000"/>
@@ -5983,6 +5984,134 @@
                 <a:latin typeface="Arial"/>
               </a:rPr>
               <a:t>an NNLS stack, scored with its own cross-validation, reaches 0.474, a tie with RandomForest alone, so stacking is not used and the free-energy model is a plain RandomForest.</a:t>
+            </a:r>
+          </a:p>
+        </p:txBody>
+      </p:sp>
+    </p:spTree>
+  </p:cSld>
+  <p:clrMapOvr>
+    <a:masterClrMapping/>
+  </p:clrMapOvr>
+</p:sld>
+</file>
+
+<file path=ppt/slides/slide26.xml><?xml version="1.0" encoding="utf-8"?>
+<p:sld xmlns:a="http://schemas.openxmlformats.org/drawingml/2006/main" xmlns:p="http://schemas.openxmlformats.org/presentationml/2006/main" xmlns:r="http://schemas.openxmlformats.org/officeDocument/2006/relationships">
+  <p:cSld>
+    <p:bg>
+      <p:bgPr>
+        <a:solidFill>
+          <a:srgbClr val="FFFFFF"/>
+        </a:solidFill>
+        <a:effectLst/>
+      </p:bgPr>
+    </p:bg>
+    <p:spTree>
+      <p:nvGrpSpPr>
+        <p:cNvPr id="1" name=""/>
+        <p:cNvGrpSpPr/>
+        <p:nvPr/>
+      </p:nvGrpSpPr>
+      <p:grpSpPr/>
+      <p:sp>
+        <p:nvSpPr>
+          <p:cNvPr id="2" name="TextBox 1"/>
+          <p:cNvSpPr txBox="1"/>
+          <p:nvPr/>
+        </p:nvSpPr>
+        <p:spPr>
+          <a:xfrm>
+            <a:off x="640080" y="457200"/>
+            <a:ext cx="10972800" cy="914400"/>
+          </a:xfrm>
+          <a:prstGeom prst="rect">
+            <a:avLst/>
+          </a:prstGeom>
+          <a:noFill/>
+        </p:spPr>
+        <p:txBody>
+          <a:bodyPr wrap="square" lIns="0" rIns="0" tIns="0" bIns="0">
+            <a:spAutoFit/>
+          </a:bodyPr>
+          <a:lstStyle/>
+          <a:p>
+            <a:pPr algn="l">
+              <a:spcAft>
+                <a:spcPts val="600"/>
+              </a:spcAft>
+            </a:pPr>
+            <a:r>
+              <a:rPr sz="2900" b="1" i="0">
+                <a:solidFill>
+                  <a:srgbClr val="000000"/>
+                </a:solidFill>
+                <a:latin typeface="Arial"/>
+              </a:rPr>
+              <a:t>UCB and active-learning results</a:t>
+            </a:r>
+          </a:p>
+        </p:txBody>
+      </p:sp>
+      <p:pic>
+        <p:nvPicPr>
+          <p:cNvPr id="3" name="Picture 2" descr="ucb_graphs.png"/>
+          <p:cNvPicPr>
+            <a:picLocks noChangeAspect="1"/>
+          </p:cNvPicPr>
+          <p:nvPr/>
+        </p:nvPicPr>
+        <p:blipFill>
+          <a:blip r:embed="rId2"/>
+          <a:stretch>
+            <a:fillRect/>
+          </a:stretch>
+        </p:blipFill>
+        <p:spPr>
+          <a:xfrm>
+            <a:off x="426567" y="1600200"/>
+            <a:ext cx="11338560" cy="3276437"/>
+          </a:xfrm>
+          <a:prstGeom prst="rect">
+            <a:avLst/>
+          </a:prstGeom>
+        </p:spPr>
+      </p:pic>
+      <p:sp>
+        <p:nvSpPr>
+          <p:cNvPr id="4" name="TextBox 3"/>
+          <p:cNvSpPr txBox="1"/>
+          <p:nvPr/>
+        </p:nvSpPr>
+        <p:spPr>
+          <a:xfrm>
+            <a:off x="640080" y="5041229"/>
+            <a:ext cx="10881360" cy="1005840"/>
+          </a:xfrm>
+          <a:prstGeom prst="rect">
+            <a:avLst/>
+          </a:prstGeom>
+          <a:noFill/>
+        </p:spPr>
+        <p:txBody>
+          <a:bodyPr wrap="square" lIns="0" rIns="0" tIns="0" bIns="0">
+            <a:spAutoFit/>
+          </a:bodyPr>
+          <a:lstStyle/>
+          <a:p>
+            <a:pPr algn="l">
+              <a:spcAft>
+                <a:spcPts val="600"/>
+              </a:spcAft>
+            </a:pPr>
+            <a:r>
+              <a:rPr sz="1300" b="0" i="1">
+                <a:solidFill>
+                  <a:srgbClr val="404040"/>
+                </a:solidFill>
+                <a:latin typeface="Arial"/>
+              </a:rPr>
+              <a:t>Left: sampling the uncertain points builds the best model. Middle: ranking by prediction (greedy) or UCB finds the strongest extractants fastest. Right: for a one-shot pick on delta G, greedy reaches the most negative, strongest extractants, UCB sits in the middle, and random gets nothing. UCB does not beat the simpler choices here.</a:t>
             </a:r>
           </a:p>
         </p:txBody>

</xml_diff>

<commit_message>
Add active-analysis graphs (calibration, selective prediction, pred vs actual) and slide
Co-Authored-By: Claude Opus 4.8 <noreply@anthropic.com>
</commit_message>
<xml_diff>
--- a/docs/REE_Results_Slides_Final.pptx
+++ b/docs/REE_Results_Slides_Final.pptx
@@ -31,6 +31,7 @@
     <p:sldId id="279" r:id="rId30"/>
     <p:sldId id="280" r:id="rId31"/>
     <p:sldId id="281" r:id="rId32"/>
+    <p:sldId id="282" r:id="rId33"/>
   </p:sldIdLst>
   <p:sldSz cx="12191695" cy="6858000" type="screen4x3"/>
   <p:notesSz cx="6858000" cy="9144000"/>
@@ -6112,6 +6113,134 @@
                 <a:latin typeface="Arial"/>
               </a:rPr>
               <a:t>Left: sampling the uncertain points builds the best model. Middle: ranking by prediction (greedy) or UCB finds the strongest extractants fastest. Right: for a one-shot pick on delta G, greedy reaches the most negative, strongest extractants, UCB sits in the middle, and random gets nothing. UCB does not beat the simpler choices here.</a:t>
+            </a:r>
+          </a:p>
+        </p:txBody>
+      </p:sp>
+    </p:spTree>
+  </p:cSld>
+  <p:clrMapOvr>
+    <a:masterClrMapping/>
+  </p:clrMapOvr>
+</p:sld>
+</file>
+
+<file path=ppt/slides/slide27.xml><?xml version="1.0" encoding="utf-8"?>
+<p:sld xmlns:a="http://schemas.openxmlformats.org/drawingml/2006/main" xmlns:p="http://schemas.openxmlformats.org/presentationml/2006/main" xmlns:r="http://schemas.openxmlformats.org/officeDocument/2006/relationships">
+  <p:cSld>
+    <p:bg>
+      <p:bgPr>
+        <a:solidFill>
+          <a:srgbClr val="FFFFFF"/>
+        </a:solidFill>
+        <a:effectLst/>
+      </p:bgPr>
+    </p:bg>
+    <p:spTree>
+      <p:nvGrpSpPr>
+        <p:cNvPr id="1" name=""/>
+        <p:cNvGrpSpPr/>
+        <p:nvPr/>
+      </p:nvGrpSpPr>
+      <p:grpSpPr/>
+      <p:sp>
+        <p:nvSpPr>
+          <p:cNvPr id="2" name="TextBox 1"/>
+          <p:cNvSpPr txBox="1"/>
+          <p:nvPr/>
+        </p:nvSpPr>
+        <p:spPr>
+          <a:xfrm>
+            <a:off x="640080" y="457200"/>
+            <a:ext cx="10972800" cy="914400"/>
+          </a:xfrm>
+          <a:prstGeom prst="rect">
+            <a:avLst/>
+          </a:prstGeom>
+          <a:noFill/>
+        </p:spPr>
+        <p:txBody>
+          <a:bodyPr wrap="square" lIns="0" rIns="0" tIns="0" bIns="0">
+            <a:spAutoFit/>
+          </a:bodyPr>
+          <a:lstStyle/>
+          <a:p>
+            <a:pPr algn="l">
+              <a:spcAft>
+                <a:spcPts val="600"/>
+              </a:spcAft>
+            </a:pPr>
+            <a:r>
+              <a:rPr sz="2900" b="1" i="0">
+                <a:solidFill>
+                  <a:srgbClr val="000000"/>
+                </a:solidFill>
+                <a:latin typeface="Arial"/>
+              </a:rPr>
+              <a:t>Active analysis: calibrated intervals</a:t>
+            </a:r>
+          </a:p>
+        </p:txBody>
+      </p:sp>
+      <p:pic>
+        <p:nvPicPr>
+          <p:cNvPr id="3" name="Picture 2" descr="active_analysis.png"/>
+          <p:cNvPicPr>
+            <a:picLocks noChangeAspect="1"/>
+          </p:cNvPicPr>
+          <p:nvPr/>
+        </p:nvPicPr>
+        <p:blipFill>
+          <a:blip r:embed="rId2"/>
+          <a:stretch>
+            <a:fillRect/>
+          </a:stretch>
+        </p:blipFill>
+        <p:spPr>
+          <a:xfrm>
+            <a:off x="426567" y="1600200"/>
+            <a:ext cx="11338560" cy="3278024"/>
+          </a:xfrm>
+          <a:prstGeom prst="rect">
+            <a:avLst/>
+          </a:prstGeom>
+        </p:spPr>
+      </p:pic>
+      <p:sp>
+        <p:nvSpPr>
+          <p:cNvPr id="4" name="TextBox 3"/>
+          <p:cNvSpPr txBox="1"/>
+          <p:nvPr/>
+        </p:nvSpPr>
+        <p:spPr>
+          <a:xfrm>
+            <a:off x="640080" y="5042816"/>
+            <a:ext cx="10881360" cy="1005840"/>
+          </a:xfrm>
+          <a:prstGeom prst="rect">
+            <a:avLst/>
+          </a:prstGeom>
+          <a:noFill/>
+        </p:spPr>
+        <p:txBody>
+          <a:bodyPr wrap="square" lIns="0" rIns="0" tIns="0" bIns="0">
+            <a:spAutoFit/>
+          </a:bodyPr>
+          <a:lstStyle/>
+          <a:p>
+            <a:pPr algn="l">
+              <a:spcAft>
+                <a:spcPts val="600"/>
+              </a:spcAft>
+            </a:pPr>
+            <a:r>
+              <a:rPr sz="1300" b="0" i="1">
+                <a:solidFill>
+                  <a:srgbClr val="404040"/>
+                </a:solidFill>
+                <a:latin typeface="Arial"/>
+              </a:rPr>
+              <a:t>Left: the delta G intervals are calibrated, target coverage matches empirical coverage at every level. Middle: keeping only the most confident predictions raises R-squared from 0.47 to 0.78 and cuts RMSE from 6.3 to 3.6 kJ/mol. Right: the most confident quarter (blue) hug the diagonal. Calibrated, heterogeneous intervals are what let the model say which predictions to trust and which to test.</a:t>
             </a:r>
           </a:p>
         </p:txBody>

</xml_diff>

<commit_message>
Audit remediation: honest numbers and framing across README, workbook, slides
Track B logD relabeled (honest ~0.61 condition-key; 0.725 = random-row upper bound
with replicate memorization; ~0.44 on new molecules). delta G headline ~0.46+/-0.01.
Zhang reframed to the same-data comparison (drop the off-dataset 0.605). Added an
Audit corrections workbook tab and slide, the honest logD recompute (track_ab_results.csv),
and the two trend figures/slides.

Co-Authored-By: Claude Opus 4.8 <noreply@anthropic.com>
</commit_message>
<xml_diff>
--- a/docs/REE_Results_Slides_Final.pptx
+++ b/docs/REE_Results_Slides_Final.pptx
@@ -32,6 +32,9 @@
     <p:sldId id="280" r:id="rId31"/>
     <p:sldId id="281" r:id="rId32"/>
     <p:sldId id="282" r:id="rId33"/>
+    <p:sldId id="283" r:id="rId34"/>
+    <p:sldId id="284" r:id="rId35"/>
+    <p:sldId id="285" r:id="rId36"/>
   </p:sldIdLst>
   <p:sldSz cx="12191695" cy="6858000" type="screen4x3"/>
   <p:notesSz cx="6858000" cy="9144000"/>
@@ -5821,7 +5824,7 @@
                 </a:solidFill>
                 <a:latin typeface="Arial"/>
               </a:rPr>
-              <a:t>Per-pair is the better target (R-squared 0.47, RMSE 6.3 kJ/mol) than per-row (0.28), evaluated with molecule-grouped cross-validation so the extractants are new. Confidence is strong: the most confident quarter reach R-squared 0.68 and the top tenth 0.78 (RMSE 3.6 kJ/mol).</a:t>
+              <a:t>Per-pair is the better target (R-squared about 0.46, RMSE 6.3 kJ/mol) than per-row (0.28), molecule-grouped so the extractants are new. The 0.473 shown elsewhere was a selected maximum; the mean over shuffled splits is 0.461 plus or minus 0.009. Confidence is strong: the most confident tenth drop RMSE to 3.6 kJ/mol.</a:t>
             </a:r>
           </a:p>
         </p:txBody>
@@ -5934,7 +5937,7 @@
                 </a:solidFill>
                 <a:latin typeface="Arial"/>
               </a:rPr>
-              <a:t>RandomForest, R-squared 0.473 (RMSE 6.31 kJ/mol) for the per-pair free energy. The bagged-tree models beat the gradient boosters on this small, wide table of 2,273 systems.</a:t>
+              <a:t>RandomForest, R-squared about 0.46 plus or minus 0.01 (RMSE 6.3 kJ/mol) for the per-pair free energy; 0.473 was the maximum of the search, the mean over splits is 0.461. The bagged-tree models beat the gradient boosters on this small, wide table of 2,273 systems.</a:t>
             </a:r>
           </a:p>
           <a:p>
@@ -6253,6 +6256,347 @@
 </p:sld>
 </file>
 
+<file path=ppt/slides/slide28.xml><?xml version="1.0" encoding="utf-8"?>
+<p:sld xmlns:a="http://schemas.openxmlformats.org/drawingml/2006/main" xmlns:p="http://schemas.openxmlformats.org/presentationml/2006/main" xmlns:r="http://schemas.openxmlformats.org/officeDocument/2006/relationships">
+  <p:cSld>
+    <p:bg>
+      <p:bgPr>
+        <a:solidFill>
+          <a:srgbClr val="FFFFFF"/>
+        </a:solidFill>
+        <a:effectLst/>
+      </p:bgPr>
+    </p:bg>
+    <p:spTree>
+      <p:nvGrpSpPr>
+        <p:cNvPr id="1" name=""/>
+        <p:cNvGrpSpPr/>
+        <p:nvPr/>
+      </p:nvGrpSpPr>
+      <p:grpSpPr/>
+      <p:sp>
+        <p:nvSpPr>
+          <p:cNvPr id="2" name="TextBox 1"/>
+          <p:cNvSpPr txBox="1"/>
+          <p:nvPr/>
+        </p:nvSpPr>
+        <p:spPr>
+          <a:xfrm>
+            <a:off x="640080" y="457200"/>
+            <a:ext cx="10972800" cy="914400"/>
+          </a:xfrm>
+          <a:prstGeom prst="rect">
+            <a:avLst/>
+          </a:prstGeom>
+          <a:noFill/>
+        </p:spPr>
+        <p:txBody>
+          <a:bodyPr wrap="square" lIns="0" rIns="0" tIns="0" bIns="0">
+            <a:spAutoFit/>
+          </a:bodyPr>
+          <a:lstStyle/>
+          <a:p>
+            <a:pPr algn="l">
+              <a:spcAft>
+                <a:spcPts val="600"/>
+              </a:spcAft>
+            </a:pPr>
+            <a:r>
+              <a:rPr sz="2900" b="1" i="0">
+                <a:solidFill>
+                  <a:srgbClr val="000000"/>
+                </a:solidFill>
+                <a:latin typeface="Arial"/>
+              </a:rPr>
+              <a:t>Honest numbers after the audit</a:t>
+            </a:r>
+          </a:p>
+        </p:txBody>
+      </p:sp>
+      <p:sp>
+        <p:nvSpPr>
+          <p:cNvPr id="3" name="TextBox 2"/>
+          <p:cNvSpPr txBox="1"/>
+          <p:nvPr/>
+        </p:nvSpPr>
+        <p:spPr>
+          <a:xfrm>
+            <a:off x="640080" y="1371600"/>
+            <a:ext cx="10972800" cy="5120640"/>
+          </a:xfrm>
+          <a:prstGeom prst="rect">
+            <a:avLst/>
+          </a:prstGeom>
+          <a:noFill/>
+        </p:spPr>
+        <p:txBody>
+          <a:bodyPr wrap="square" lIns="0" rIns="0" tIns="0" bIns="0">
+            <a:spAutoFit/>
+          </a:bodyPr>
+          <a:lstStyle/>
+          <a:p>
+            <a:pPr algn="l">
+              <a:spcAft>
+                <a:spcPts val="1300"/>
+              </a:spcAft>
+            </a:pPr>
+            <a:r>
+              <a:rPr sz="1500" b="1">
+                <a:solidFill>
+                  <a:srgbClr val="000000"/>
+                </a:solidFill>
+                <a:latin typeface="Arial"/>
+              </a:rPr>
+              <a:t>Track A (new molecule):  </a:t>
+            </a:r>
+            <a:r>
+              <a:rPr sz="1500" b="0">
+                <a:solidFill>
+                  <a:srgbClr val="000000"/>
+                </a:solidFill>
+                <a:latin typeface="Arial"/>
+              </a:rPr>
+              <a:t>logD R-squared 0.466, unchanged and honest.</a:t>
+            </a:r>
+          </a:p>
+          <a:p>
+            <a:pPr algn="l">
+              <a:spcAft>
+                <a:spcPts val="1300"/>
+              </a:spcAft>
+            </a:pPr>
+            <a:r>
+              <a:rPr sz="1500" b="1">
+                <a:solidFill>
+                  <a:srgbClr val="000000"/>
+                </a:solidFill>
+                <a:latin typeface="Arial"/>
+              </a:rPr>
+              <a:t>Track B (known molecule):  </a:t>
+            </a:r>
+            <a:r>
+              <a:rPr sz="1500" b="0">
+                <a:solidFill>
+                  <a:srgbClr val="000000"/>
+                </a:solidFill>
+                <a:latin typeface="Arial"/>
+              </a:rPr>
+              <a:t>honest R-squared about 0.61, interpolating conditions for a molecule already seen. The 0.725 figure was a random-row split that memorizes replicates; on genuinely new molecules these features fall to about 0.44.</a:t>
+            </a:r>
+          </a:p>
+          <a:p>
+            <a:pPr algn="l">
+              <a:spcAft>
+                <a:spcPts val="1300"/>
+              </a:spcAft>
+            </a:pPr>
+            <a:r>
+              <a:rPr sz="1500" b="1">
+                <a:solidFill>
+                  <a:srgbClr val="000000"/>
+                </a:solidFill>
+                <a:latin typeface="Arial"/>
+              </a:rPr>
+              <a:t>Free energy (delta G):  </a:t>
+            </a:r>
+            <a:r>
+              <a:rPr sz="1500" b="0">
+                <a:solidFill>
+                  <a:srgbClr val="000000"/>
+                </a:solidFill>
+                <a:latin typeface="Arial"/>
+              </a:rPr>
+              <a:t>R-squared about 0.46 plus or minus 0.01; the 0.473 was a selected maximum of a model search.</a:t>
+            </a:r>
+          </a:p>
+          <a:p>
+            <a:pPr algn="l">
+              <a:spcAft>
+                <a:spcPts val="1300"/>
+              </a:spcAft>
+            </a:pPr>
+            <a:r>
+              <a:rPr sz="1500" b="1">
+                <a:solidFill>
+                  <a:srgbClr val="000000"/>
+                </a:solidFill>
+                <a:latin typeface="Arial"/>
+              </a:rPr>
+              <a:t>Confidence:  </a:t>
+            </a:r>
+            <a:r>
+              <a:rPr sz="1500" b="0">
+                <a:solidFill>
+                  <a:srgbClr val="000000"/>
+                </a:solidFill>
+                <a:latin typeface="Arial"/>
+              </a:rPr>
+              <a:t>the 90 percent intervals are calibrated (they cover 90 percent); the most-confident-slice figures are operating points, not overall accuracy.</a:t>
+            </a:r>
+          </a:p>
+          <a:p>
+            <a:pPr algn="l">
+              <a:spcAft>
+                <a:spcPts val="1300"/>
+              </a:spcAft>
+            </a:pPr>
+            <a:r>
+              <a:rPr sz="1500" b="1">
+                <a:solidFill>
+                  <a:srgbClr val="000000"/>
+                </a:solidFill>
+                <a:latin typeface="Arial"/>
+              </a:rPr>
+              <a:t>Versus Dr. Zhang:  </a:t>
+            </a:r>
+            <a:r>
+              <a:rPr sz="1500" b="0">
+                <a:solidFill>
+                  <a:srgbClr val="000000"/>
+                </a:solidFill>
+                <a:latin typeface="Arial"/>
+              </a:rPr>
+              <a:t>about equal on the same data and split (0.657 vs 0.648); the split, not the model, drives his 0.72 headline.</a:t>
+            </a:r>
+          </a:p>
+        </p:txBody>
+      </p:sp>
+    </p:spTree>
+  </p:cSld>
+  <p:clrMapOvr>
+    <a:masterClrMapping/>
+  </p:clrMapOvr>
+</p:sld>
+</file>
+
+<file path=ppt/slides/slide29.xml><?xml version="1.0" encoding="utf-8"?>
+<p:sld xmlns:a="http://schemas.openxmlformats.org/drawingml/2006/main" xmlns:p="http://schemas.openxmlformats.org/presentationml/2006/main" xmlns:r="http://schemas.openxmlformats.org/officeDocument/2006/relationships">
+  <p:cSld>
+    <p:bg>
+      <p:bgPr>
+        <a:solidFill>
+          <a:srgbClr val="FFFFFF"/>
+        </a:solidFill>
+        <a:effectLst/>
+      </p:bgPr>
+    </p:bg>
+    <p:spTree>
+      <p:nvGrpSpPr>
+        <p:cNvPr id="1" name=""/>
+        <p:cNvGrpSpPr/>
+        <p:nvPr/>
+      </p:nvGrpSpPr>
+      <p:grpSpPr/>
+      <p:sp>
+        <p:nvSpPr>
+          <p:cNvPr id="2" name="TextBox 1"/>
+          <p:cNvSpPr txBox="1"/>
+          <p:nvPr/>
+        </p:nvSpPr>
+        <p:spPr>
+          <a:xfrm>
+            <a:off x="640080" y="457200"/>
+            <a:ext cx="10972800" cy="914400"/>
+          </a:xfrm>
+          <a:prstGeom prst="rect">
+            <a:avLst/>
+          </a:prstGeom>
+          <a:noFill/>
+        </p:spPr>
+        <p:txBody>
+          <a:bodyPr wrap="square" lIns="0" rIns="0" tIns="0" bIns="0">
+            <a:spAutoFit/>
+          </a:bodyPr>
+          <a:lstStyle/>
+          <a:p>
+            <a:pPr algn="l">
+              <a:spcAft>
+                <a:spcPts val="600"/>
+              </a:spcAft>
+            </a:pPr>
+            <a:r>
+              <a:rPr sz="2900" b="1" i="0">
+                <a:solidFill>
+                  <a:srgbClr val="000000"/>
+                </a:solidFill>
+                <a:latin typeface="Arial"/>
+              </a:rPr>
+              <a:t>Active analysis: good picks or mid?</a:t>
+            </a:r>
+          </a:p>
+        </p:txBody>
+      </p:sp>
+      <p:pic>
+        <p:nvPicPr>
+          <p:cNvPr id="3" name="Picture 2" descr="active_analysis_trends.png"/>
+          <p:cNvPicPr>
+            <a:picLocks noChangeAspect="1"/>
+          </p:cNvPicPr>
+          <p:nvPr/>
+        </p:nvPicPr>
+        <p:blipFill>
+          <a:blip r:embed="rId2"/>
+          <a:stretch>
+            <a:fillRect/>
+          </a:stretch>
+        </p:blipFill>
+        <p:spPr>
+          <a:xfrm>
+            <a:off x="3051443" y="1417320"/>
+            <a:ext cx="6088808" cy="4206240"/>
+          </a:xfrm>
+          <a:prstGeom prst="rect">
+            <a:avLst/>
+          </a:prstGeom>
+        </p:spPr>
+      </p:pic>
+      <p:sp>
+        <p:nvSpPr>
+          <p:cNvPr id="4" name="TextBox 3"/>
+          <p:cNvSpPr txBox="1"/>
+          <p:nvPr/>
+        </p:nvSpPr>
+        <p:spPr>
+          <a:xfrm>
+            <a:off x="640080" y="5769864"/>
+            <a:ext cx="10881360" cy="1005840"/>
+          </a:xfrm>
+          <a:prstGeom prst="rect">
+            <a:avLst/>
+          </a:prstGeom>
+          <a:noFill/>
+        </p:spPr>
+        <p:txBody>
+          <a:bodyPr wrap="square" lIns="0" rIns="0" tIns="0" bIns="0">
+            <a:spAutoFit/>
+          </a:bodyPr>
+          <a:lstStyle/>
+          <a:p>
+            <a:pPr algn="l">
+              <a:spcAft>
+                <a:spcPts val="600"/>
+              </a:spcAft>
+            </a:pPr>
+            <a:r>
+              <a:rPr sz="1300" b="0" i="1">
+                <a:solidFill>
+                  <a:srgbClr val="404040"/>
+                </a:solidFill>
+                <a:latin typeface="Arial"/>
+              </a:rPr>
+              <a:t>Greedy selection puts 81 percent of its top picks in the strongest tertile (vs 37 percent random) and beats each metal's average, but it captures only about 62 percent of the achievable strength and about 57 percent of its top-decile picks miss the true elite. Its confident picks are the trustworthy ones.</a:t>
+            </a:r>
+          </a:p>
+        </p:txBody>
+      </p:sp>
+    </p:spTree>
+  </p:cSld>
+  <p:clrMapOvr>
+    <a:masterClrMapping/>
+  </p:clrMapOvr>
+</p:sld>
+</file>
+
 <file path=ppt/slides/slide3.xml><?xml version="1.0" encoding="utf-8"?>
 <p:sld xmlns:a="http://schemas.openxmlformats.org/drawingml/2006/main" xmlns:p="http://schemas.openxmlformats.org/presentationml/2006/main" xmlns:r="http://schemas.openxmlformats.org/officeDocument/2006/relationships">
   <p:cSld>
@@ -6519,6 +6863,134 @@
                 <a:latin typeface="Arial"/>
               </a:rPr>
               <a:t>Most confident 10 percent: R-squared 0.940, RMSE 0.341</a:t>
+            </a:r>
+          </a:p>
+        </p:txBody>
+      </p:sp>
+    </p:spTree>
+  </p:cSld>
+  <p:clrMapOvr>
+    <a:masterClrMapping/>
+  </p:clrMapOvr>
+</p:sld>
+</file>
+
+<file path=ppt/slides/slide30.xml><?xml version="1.0" encoding="utf-8"?>
+<p:sld xmlns:a="http://schemas.openxmlformats.org/drawingml/2006/main" xmlns:p="http://schemas.openxmlformats.org/presentationml/2006/main" xmlns:r="http://schemas.openxmlformats.org/officeDocument/2006/relationships">
+  <p:cSld>
+    <p:bg>
+      <p:bgPr>
+        <a:solidFill>
+          <a:srgbClr val="FFFFFF"/>
+        </a:solidFill>
+        <a:effectLst/>
+      </p:bgPr>
+    </p:bg>
+    <p:spTree>
+      <p:nvGrpSpPr>
+        <p:cNvPr id="1" name=""/>
+        <p:cNvGrpSpPr/>
+        <p:nvPr/>
+      </p:nvGrpSpPr>
+      <p:grpSpPr/>
+      <p:sp>
+        <p:nvSpPr>
+          <p:cNvPr id="2" name="TextBox 1"/>
+          <p:cNvSpPr txBox="1"/>
+          <p:nvPr/>
+        </p:nvSpPr>
+        <p:spPr>
+          <a:xfrm>
+            <a:off x="640080" y="457200"/>
+            <a:ext cx="10972800" cy="914400"/>
+          </a:xfrm>
+          <a:prstGeom prst="rect">
+            <a:avLst/>
+          </a:prstGeom>
+          <a:noFill/>
+        </p:spPr>
+        <p:txBody>
+          <a:bodyPr wrap="square" lIns="0" rIns="0" tIns="0" bIns="0">
+            <a:spAutoFit/>
+          </a:bodyPr>
+          <a:lstStyle/>
+          <a:p>
+            <a:pPr algn="l">
+              <a:spcAft>
+                <a:spcPts val="600"/>
+              </a:spcAft>
+            </a:pPr>
+            <a:r>
+              <a:rPr sz="2900" b="1" i="0">
+                <a:solidFill>
+                  <a:srgbClr val="000000"/>
+                </a:solidFill>
+                <a:latin typeface="Arial"/>
+              </a:rPr>
+              <a:t>What the chosen extractants share</a:t>
+            </a:r>
+          </a:p>
+        </p:txBody>
+      </p:sp>
+      <p:pic>
+        <p:nvPicPr>
+          <p:cNvPr id="3" name="Picture 2" descr="picks_trends.png"/>
+          <p:cNvPicPr>
+            <a:picLocks noChangeAspect="1"/>
+          </p:cNvPicPr>
+          <p:nvPr/>
+        </p:nvPicPr>
+        <p:blipFill>
+          <a:blip r:embed="rId2"/>
+          <a:stretch>
+            <a:fillRect/>
+          </a:stretch>
+        </p:blipFill>
+        <p:spPr>
+          <a:xfrm>
+            <a:off x="1081687" y="1737360"/>
+            <a:ext cx="10028321" cy="3657600"/>
+          </a:xfrm>
+          <a:prstGeom prst="rect">
+            <a:avLst/>
+          </a:prstGeom>
+        </p:spPr>
+      </p:pic>
+      <p:sp>
+        <p:nvSpPr>
+          <p:cNvPr id="4" name="TextBox 3"/>
+          <p:cNvSpPr txBox="1"/>
+          <p:nvPr/>
+        </p:nvSpPr>
+        <p:spPr>
+          <a:xfrm>
+            <a:off x="640080" y="5559552"/>
+            <a:ext cx="10881360" cy="1005840"/>
+          </a:xfrm>
+          <a:prstGeom prst="rect">
+            <a:avLst/>
+          </a:prstGeom>
+          <a:noFill/>
+        </p:spPr>
+        <p:txBody>
+          <a:bodyPr wrap="square" lIns="0" rIns="0" tIns="0" bIns="0">
+            <a:spAutoFit/>
+          </a:bodyPr>
+          <a:lstStyle/>
+          <a:p>
+            <a:pPr algn="l">
+              <a:spcAft>
+                <a:spcPts val="600"/>
+              </a:spcAft>
+            </a:pPr>
+            <a:r>
+              <a:rPr sz="1300" b="0" i="1">
+                <a:solidFill>
+                  <a:srgbClr val="404040"/>
+                </a:solidFill>
+                <a:latin typeface="Arial"/>
+              </a:rPr>
+              <a:t>The picks concentrate on americium and the trivalent lanthanides and actinides (americium 2.85x over-represented, 30 percent of picks), and lean toward less-aromatic, more aliphatic extractants, consistent with classic organophosphorus f-element extractants. Effect sizes are modest.</a:t>
             </a:r>
           </a:p>
         </p:txBody>

</xml_diff>

<commit_message>
Fix .gitignore conflict markers; recompute the Track B confidence curve on the condition-key split (honest top-10% R2 0.874, RMSE 0.430); propagate the honest numbers into the deck, workbook, README, and methods doc
Co-Authored-By: Claude Opus 4.8 <noreply@anthropic.com>
</commit_message>
<xml_diff>
--- a/docs/REE_Results_Slides_Final.pptx
+++ b/docs/REE_Results_Slides_Final.pptx
@@ -6830,7 +6830,7 @@
                 </a:solidFill>
                 <a:latin typeface="Arial"/>
               </a:rPr>
-              <a:t>random-row cross-validation</a:t>
+              <a:t>condition-key CV (honest)</a:t>
             </a:r>
           </a:p>
           <a:p>
@@ -6846,7 +6846,7 @@
                 </a:solidFill>
                 <a:latin typeface="Arial"/>
               </a:rPr>
-              <a:t>R-squared 0.725     RMSE 0.823</a:t>
+              <a:t>R-squared 0.61     RMSE 0.979</a:t>
             </a:r>
           </a:p>
           <a:p>
@@ -6862,7 +6862,7 @@
                 </a:solidFill>
                 <a:latin typeface="Arial"/>
               </a:rPr>
-              <a:t>Most confident 10 percent: R-squared 0.940, RMSE 0.341</a:t>
+              <a:t>Most confident 10 percent: R-squared 0.874, RMSE 0.430</a:t>
             </a:r>
           </a:p>
         </p:txBody>
@@ -7603,7 +7603,7 @@
                 </a:solidFill>
                 <a:latin typeface="Arial"/>
               </a:rPr>
-              <a:t>The same pattern holds for condition optimization: the most confident tenth reaches R-squared 0.940 and RMSE 0.341, against 0.725 and 0.823 over all predictions.</a:t>
+              <a:t>The same pattern holds for condition optimization: the most confident tenth reaches R-squared 0.874 and RMSE 0.430, against 0.61 and 0.979 over all predictions.</a:t>
             </a:r>
           </a:p>
         </p:txBody>

</xml_diff>

<commit_message>
Add the separation results to the deck (order, confidence, and the confidence-forward Zhang comparison) plus the sep_zhang_confidence figure; reference it in the methods doc and correct the residual 'Zhang has no confidence layer' wording to the model-agnostic framing
Co-Authored-By: Claude Opus 4.8 <noreply@anthropic.com>
</commit_message>
<xml_diff>
--- a/docs/REE_Results_Slides_Final.pptx
+++ b/docs/REE_Results_Slides_Final.pptx
@@ -35,6 +35,9 @@
     <p:sldId id="283" r:id="rId34"/>
     <p:sldId id="284" r:id="rId35"/>
     <p:sldId id="285" r:id="rId36"/>
+    <p:sldId id="286" r:id="rId37"/>
+    <p:sldId id="287" r:id="rId38"/>
+    <p:sldId id="288" r:id="rId39"/>
   </p:sldIdLst>
   <p:sldSz cx="12191695" cy="6858000" type="screen4x3"/>
   <p:notesSz cx="6858000" cy="9144000"/>
@@ -6991,6 +6994,366 @@
                 <a:latin typeface="Arial"/>
               </a:rPr>
               <a:t>The picks concentrate on americium and the trivalent lanthanides and actinides (americium 2.85x over-represented, 30 percent of picks), and lean toward less-aromatic, more aliphatic extractants, consistent with classic organophosphorus f-element extractants. Effect sizes are modest.</a:t>
+            </a:r>
+          </a:p>
+        </p:txBody>
+      </p:sp>
+    </p:spTree>
+  </p:cSld>
+  <p:clrMapOvr>
+    <a:masterClrMapping/>
+  </p:clrMapOvr>
+</p:sld>
+</file>
+
+<file path=ppt/slides/slide31.xml><?xml version="1.0" encoding="utf-8"?>
+<p:sld xmlns:a="http://schemas.openxmlformats.org/drawingml/2006/main" xmlns:p="http://schemas.openxmlformats.org/presentationml/2006/main" xmlns:r="http://schemas.openxmlformats.org/officeDocument/2006/relationships">
+  <p:cSld>
+    <p:bg>
+      <p:bgPr>
+        <a:solidFill>
+          <a:srgbClr val="FFFFFF"/>
+        </a:solidFill>
+        <a:effectLst/>
+      </p:bgPr>
+    </p:bg>
+    <p:spTree>
+      <p:nvGrpSpPr>
+        <p:cNvPr id="1" name=""/>
+        <p:cNvGrpSpPr/>
+        <p:nvPr/>
+      </p:nvGrpSpPr>
+      <p:grpSpPr/>
+      <p:sp>
+        <p:nvSpPr>
+          <p:cNvPr id="2" name="TextBox 1"/>
+          <p:cNvSpPr txBox="1"/>
+          <p:nvPr/>
+        </p:nvSpPr>
+        <p:spPr>
+          <a:xfrm>
+            <a:off x="640080" y="457200"/>
+            <a:ext cx="10972800" cy="914400"/>
+          </a:xfrm>
+          <a:prstGeom prst="rect">
+            <a:avLst/>
+          </a:prstGeom>
+          <a:noFill/>
+        </p:spPr>
+        <p:txBody>
+          <a:bodyPr wrap="square" lIns="0" rIns="0" tIns="0" bIns="0">
+            <a:spAutoFit/>
+          </a:bodyPr>
+          <a:lstStyle/>
+          <a:p>
+            <a:pPr algn="l"/>
+            <a:r>
+              <a:rPr sz="2900" b="1" i="0">
+                <a:solidFill>
+                  <a:srgbClr val="000000"/>
+                </a:solidFill>
+                <a:latin typeface="Arial"/>
+              </a:rPr>
+              <a:t>Separation between two f-elements</a:t>
+            </a:r>
+          </a:p>
+        </p:txBody>
+      </p:sp>
+      <p:pic>
+        <p:nvPicPr>
+          <p:cNvPr id="3" name="Picture 2" descr="sep_factor_eval.png"/>
+          <p:cNvPicPr>
+            <a:picLocks noChangeAspect="1"/>
+          </p:cNvPicPr>
+          <p:nvPr/>
+        </p:nvPicPr>
+        <p:blipFill>
+          <a:blip r:embed="rId2"/>
+          <a:stretch>
+            <a:fillRect/>
+          </a:stretch>
+        </p:blipFill>
+        <p:spPr>
+          <a:xfrm>
+            <a:off x="1255033" y="1554480"/>
+            <a:ext cx="9681628" cy="3840480"/>
+          </a:xfrm>
+          <a:prstGeom prst="rect">
+            <a:avLst/>
+          </a:prstGeom>
+        </p:spPr>
+      </p:pic>
+      <p:sp>
+        <p:nvSpPr>
+          <p:cNvPr id="4" name="TextBox 3"/>
+          <p:cNvSpPr txBox="1"/>
+          <p:nvPr/>
+        </p:nvSpPr>
+        <p:spPr>
+          <a:xfrm>
+            <a:off x="640080" y="5541264"/>
+            <a:ext cx="10881360" cy="1097280"/>
+          </a:xfrm>
+          <a:prstGeom prst="rect">
+            <a:avLst/>
+          </a:prstGeom>
+          <a:noFill/>
+        </p:spPr>
+        <p:txBody>
+          <a:bodyPr wrap="square" lIns="0" rIns="0" tIns="0" bIns="0">
+            <a:spAutoFit/>
+          </a:bodyPr>
+          <a:lstStyle/>
+          <a:p>
+            <a:pPr algn="l"/>
+            <a:r>
+              <a:rPr sz="1300" b="0" i="1">
+                <a:solidFill>
+                  <a:srgbClr val="404040"/>
+                </a:solidFill>
+                <a:latin typeface="Arial"/>
+              </a:rPr>
+              <a:t>Separation is obtained by differencing the logD model. The order, which f-element extracts more, is predicted moderately (direction 0.73 known, 0.66 new), even for near-identical neighbors; the size of the gap is not (magnitude R-squared 0.17 known, negative for new).</a:t>
+            </a:r>
+          </a:p>
+        </p:txBody>
+      </p:sp>
+    </p:spTree>
+  </p:cSld>
+  <p:clrMapOvr>
+    <a:masterClrMapping/>
+  </p:clrMapOvr>
+</p:sld>
+</file>
+
+<file path=ppt/slides/slide32.xml><?xml version="1.0" encoding="utf-8"?>
+<p:sld xmlns:a="http://schemas.openxmlformats.org/drawingml/2006/main" xmlns:p="http://schemas.openxmlformats.org/presentationml/2006/main" xmlns:r="http://schemas.openxmlformats.org/officeDocument/2006/relationships">
+  <p:cSld>
+    <p:bg>
+      <p:bgPr>
+        <a:solidFill>
+          <a:srgbClr val="FFFFFF"/>
+        </a:solidFill>
+        <a:effectLst/>
+      </p:bgPr>
+    </p:bg>
+    <p:spTree>
+      <p:nvGrpSpPr>
+        <p:cNvPr id="1" name=""/>
+        <p:cNvGrpSpPr/>
+        <p:nvPr/>
+      </p:nvGrpSpPr>
+      <p:grpSpPr/>
+      <p:sp>
+        <p:nvSpPr>
+          <p:cNvPr id="2" name="TextBox 1"/>
+          <p:cNvSpPr txBox="1"/>
+          <p:nvPr/>
+        </p:nvSpPr>
+        <p:spPr>
+          <a:xfrm>
+            <a:off x="640080" y="457200"/>
+            <a:ext cx="10972800" cy="914400"/>
+          </a:xfrm>
+          <a:prstGeom prst="rect">
+            <a:avLst/>
+          </a:prstGeom>
+          <a:noFill/>
+        </p:spPr>
+        <p:txBody>
+          <a:bodyPr wrap="square" lIns="0" rIns="0" tIns="0" bIns="0">
+            <a:spAutoFit/>
+          </a:bodyPr>
+          <a:lstStyle/>
+          <a:p>
+            <a:pPr algn="l"/>
+            <a:r>
+              <a:rPr sz="2900" b="1" i="0">
+                <a:solidFill>
+                  <a:srgbClr val="000000"/>
+                </a:solidFill>
+                <a:latin typeface="Arial"/>
+              </a:rPr>
+              <a:t>Separation: confidence helps known extractants</a:t>
+            </a:r>
+          </a:p>
+        </p:txBody>
+      </p:sp>
+      <p:pic>
+        <p:nvPicPr>
+          <p:cNvPr id="3" name="Picture 2" descr="sep_factor_confidence.png"/>
+          <p:cNvPicPr>
+            <a:picLocks noChangeAspect="1"/>
+          </p:cNvPicPr>
+          <p:nvPr/>
+        </p:nvPicPr>
+        <p:blipFill>
+          <a:blip r:embed="rId2"/>
+          <a:stretch>
+            <a:fillRect/>
+          </a:stretch>
+        </p:blipFill>
+        <p:spPr>
+          <a:xfrm>
+            <a:off x="1031967" y="1554480"/>
+            <a:ext cx="10127759" cy="3840480"/>
+          </a:xfrm>
+          <a:prstGeom prst="rect">
+            <a:avLst/>
+          </a:prstGeom>
+        </p:spPr>
+      </p:pic>
+      <p:sp>
+        <p:nvSpPr>
+          <p:cNvPr id="4" name="TextBox 3"/>
+          <p:cNvSpPr txBox="1"/>
+          <p:nvPr/>
+        </p:nvSpPr>
+        <p:spPr>
+          <a:xfrm>
+            <a:off x="640080" y="5541264"/>
+            <a:ext cx="10881360" cy="1097280"/>
+          </a:xfrm>
+          <a:prstGeom prst="rect">
+            <a:avLst/>
+          </a:prstGeom>
+          <a:noFill/>
+        </p:spPr>
+        <p:txBody>
+          <a:bodyPr wrap="square" lIns="0" rIns="0" tIns="0" bIns="0">
+            <a:spAutoFit/>
+          </a:bodyPr>
+          <a:lstStyle/>
+          <a:p>
+            <a:pPr algn="l"/>
+            <a:r>
+              <a:rPr sz="1300" b="0" i="1">
+                <a:solidFill>
+                  <a:srgbClr val="404040"/>
+                </a:solidFill>
+                <a:latin typeface="Arial"/>
+              </a:rPr>
+              <a:t>Keeping only the most confident pairs improves a known extractant (direction 0.73 to 0.79, error dropping below the no-skill line) but not a new one (direction slips, error stays flat). The confidence layer earns its keep on known extractants.</a:t>
+            </a:r>
+          </a:p>
+        </p:txBody>
+      </p:sp>
+    </p:spTree>
+  </p:cSld>
+  <p:clrMapOvr>
+    <a:masterClrMapping/>
+  </p:clrMapOvr>
+</p:sld>
+</file>
+
+<file path=ppt/slides/slide33.xml><?xml version="1.0" encoding="utf-8"?>
+<p:sld xmlns:a="http://schemas.openxmlformats.org/drawingml/2006/main" xmlns:p="http://schemas.openxmlformats.org/presentationml/2006/main" xmlns:r="http://schemas.openxmlformats.org/officeDocument/2006/relationships">
+  <p:cSld>
+    <p:bg>
+      <p:bgPr>
+        <a:solidFill>
+          <a:srgbClr val="FFFFFF"/>
+        </a:solidFill>
+        <a:effectLst/>
+      </p:bgPr>
+    </p:bg>
+    <p:spTree>
+      <p:nvGrpSpPr>
+        <p:cNvPr id="1" name=""/>
+        <p:cNvGrpSpPr/>
+        <p:nvPr/>
+      </p:nvGrpSpPr>
+      <p:grpSpPr/>
+      <p:sp>
+        <p:nvSpPr>
+          <p:cNvPr id="2" name="TextBox 1"/>
+          <p:cNvSpPr txBox="1"/>
+          <p:nvPr/>
+        </p:nvSpPr>
+        <p:spPr>
+          <a:xfrm>
+            <a:off x="640080" y="457200"/>
+            <a:ext cx="10972800" cy="914400"/>
+          </a:xfrm>
+          <a:prstGeom prst="rect">
+            <a:avLst/>
+          </a:prstGeom>
+          <a:noFill/>
+        </p:spPr>
+        <p:txBody>
+          <a:bodyPr wrap="square" lIns="0" rIns="0" tIns="0" bIns="0">
+            <a:spAutoFit/>
+          </a:bodyPr>
+          <a:lstStyle/>
+          <a:p>
+            <a:pPr algn="l"/>
+            <a:r>
+              <a:rPr sz="2900" b="1" i="0">
+                <a:solidFill>
+                  <a:srgbClr val="000000"/>
+                </a:solidFill>
+                <a:latin typeface="Arial"/>
+              </a:rPr>
+              <a:t>Separation vs Dr. Zhang, with our confidence</a:t>
+            </a:r>
+          </a:p>
+        </p:txBody>
+      </p:sp>
+      <p:pic>
+        <p:nvPicPr>
+          <p:cNvPr id="3" name="Picture 2" descr="sep_zhang_confidence.png"/>
+          <p:cNvPicPr>
+            <a:picLocks noChangeAspect="1"/>
+          </p:cNvPicPr>
+          <p:nvPr/>
+        </p:nvPicPr>
+        <p:blipFill>
+          <a:blip r:embed="rId2"/>
+          <a:stretch>
+            <a:fillRect/>
+          </a:stretch>
+        </p:blipFill>
+        <p:spPr>
+          <a:xfrm>
+            <a:off x="1011309" y="1554480"/>
+            <a:ext cx="10169075" cy="3840480"/>
+          </a:xfrm>
+          <a:prstGeom prst="rect">
+            <a:avLst/>
+          </a:prstGeom>
+        </p:spPr>
+      </p:pic>
+      <p:sp>
+        <p:nvSpPr>
+          <p:cNvPr id="4" name="TextBox 3"/>
+          <p:cNvSpPr txBox="1"/>
+          <p:nvPr/>
+        </p:nvSpPr>
+        <p:spPr>
+          <a:xfrm>
+            <a:off x="640080" y="5541264"/>
+            <a:ext cx="10881360" cy="1097280"/>
+          </a:xfrm>
+          <a:prstGeom prst="rect">
+            <a:avLst/>
+          </a:prstGeom>
+          <a:noFill/>
+        </p:spPr>
+        <p:txBody>
+          <a:bodyPr wrap="square" lIns="0" rIns="0" tIns="0" bIns="0">
+            <a:spAutoFit/>
+          </a:bodyPr>
+          <a:lstStyle/>
+          <a:p>
+            <a:pPr algn="l"/>
+            <a:r>
+              <a:rPr sz="1300" b="0" i="1">
+                <a:solidFill>
+                  <a:srgbClr val="404040"/>
+                </a:solidFill>
+                <a:latin typeface="Arial"/>
+              </a:rPr>
+              <a:t>The confidence layer is our contribution and is model-agnostic. His published model reports one flat number; applied to either base model our model leads on the confident slice (signed R-squared 0.59 vs 0.47, direction 0.79 vs 0.70, known extractant).</a:t>
             </a:r>
           </a:p>
         </p:txBody>

</xml_diff>